<commit_message>
Study 3: final refusal-corrected numbers in write-up and ISTSS deck
Co-Authored-By: Claude Fable 5 <noreply@anthropic.com>
Claude-Session: https://claude.ai/code/session_019BJ4u1WYcsA14q2B552n7R
</commit_message>
<xml_diff>
--- a/projects/marvin-stress-trauma/istss_trauma_saturation.pptx
+++ b/projects/marvin-stress-trauma/istss_trauma_saturation.pptx
@@ -230,16 +230,16 @@
                 <c:formatCode>General</c:formatCode>
                 <c:ptCount val="4"/>
                 <c:pt idx="0">
-                  <c:v>7.3</c:v>
+                  <c:v>6.5</c:v>
                 </c:pt>
                 <c:pt idx="1">
-                  <c:v>14.6</c:v>
+                  <c:v>13.6</c:v>
                 </c:pt>
                 <c:pt idx="2">
-                  <c:v>29.2</c:v>
+                  <c:v>28.4</c:v>
                 </c:pt>
                 <c:pt idx="3">
-                  <c:v>58.5</c:v>
+                  <c:v>59.1</c:v>
                 </c:pt>
               </c:numCache>
             </c:numRef>
@@ -344,16 +344,16 @@
                 <c:formatCode>General</c:formatCode>
                 <c:ptCount val="4"/>
                 <c:pt idx="0">
-                  <c:v>9.8</c:v>
+                  <c:v>9.4</c:v>
                 </c:pt>
                 <c:pt idx="1">
-                  <c:v>15.6</c:v>
+                  <c:v>15.2</c:v>
                 </c:pt>
                 <c:pt idx="2">
-                  <c:v>24.7</c:v>
+                  <c:v>24.4</c:v>
                 </c:pt>
                 <c:pt idx="3">
-                  <c:v>39.3</c:v>
+                  <c:v>39.4</c:v>
                 </c:pt>
               </c:numCache>
             </c:numRef>
@@ -458,16 +458,16 @@
                 <c:formatCode>General</c:formatCode>
                 <c:ptCount val="4"/>
                 <c:pt idx="0">
-                  <c:v>19</c:v>
+                  <c:v>19.6</c:v>
                 </c:pt>
                 <c:pt idx="1">
-                  <c:v>21.2</c:v>
+                  <c:v>21.5</c:v>
                 </c:pt>
                 <c:pt idx="2">
-                  <c:v>23.5</c:v>
+                  <c:v>23.7</c:v>
                 </c:pt>
                 <c:pt idx="3">
-                  <c:v>26.2</c:v>
+                  <c:v>26</c:v>
                 </c:pt>
               </c:numCache>
             </c:numRef>
@@ -572,16 +572,16 @@
                 <c:formatCode>General</c:formatCode>
                 <c:ptCount val="4"/>
                 <c:pt idx="0">
-                  <c:v>42</c:v>
+                  <c:v>40.9</c:v>
                 </c:pt>
                 <c:pt idx="1">
-                  <c:v>40.5</c:v>
+                  <c:v>39.6</c:v>
                 </c:pt>
                 <c:pt idx="2">
-                  <c:v>39</c:v>
+                  <c:v>38.4</c:v>
                 </c:pt>
                 <c:pt idx="3">
-                  <c:v>37.6</c:v>
+                  <c:v>37.2</c:v>
                 </c:pt>
               </c:numCache>
             </c:numRef>
@@ -1292,7 +1292,7 @@
           <a:p>
             <a:r>
               <a:rPr lang="en-US" dirty="0"/>
-              <a:t>The same result as a picture. Each line is a trauma level; the horizontal axis is the stressor count; the vertical axis is adjusted PTSD prevalence. The red line — no trauma exposure — climbs from 7 percent to 29 percent and keeps going. The five-event line starts near 40 percent and does not move. The gradient belongs to the unexposed; the burden belongs to the exposed.</a:t>
+              <a:t>The same result as a picture. Each line is a trauma level; the horizontal axis is the stressor count; the vertical axis is adjusted PTSD prevalence. The red line — no trauma exposure — climbs from 7 percent to 28 percent and keeps going. The five-event line starts near 40 percent and does not move. The gradient belongs to the unexposed; the burden belongs to the exposed.</a:t>
             </a:r>
             <a:endParaRPr lang="en-US" dirty="0"/>
           </a:p>
@@ -1380,7 +1380,7 @@
           <a:p>
             <a:r>
               <a:rPr lang="en-US" dirty="0"/>
-              <a:t>Why this matters for programming: the absolute scale. Going from zero to four stressors adds 22 percentage points of PTSD prevalence among adults with no trauma exposure — from 7 to 29 percent. The same contrast among adults with five event types adds nothing, minus three points with a confidence interval straddling zero, against a baseline near 40 percent. Depression: plus 22 versus plus 3. Anxiety: plus 17 versus minus 4. All three nulls at high exposure.</a:t>
+              <a:t>Why this matters for programming: the absolute scale. Going from zero to four stressors adds 22 percentage points of PTSD prevalence among adults with no trauma exposure — from 7 to 28 percent. The same contrast among adults with five event types adds nothing, minus two and a half points with a confidence interval straddling zero, against a baseline near 40 percent. Depression: plus 24 versus plus 4. Anxiety: plus 18 versus minus 4. All three nulls at high exposure.</a:t>
             </a:r>
             <a:endParaRPr lang="en-US" dirty="0"/>
           </a:p>
@@ -1468,7 +1468,7 @@
           <a:p>
             <a:r>
               <a:rPr lang="en-US" dirty="0"/>
-              <a:t>The result is not an artifact of any cutoff. PCL-5 at 33, PHQ-9 at 15, GAD-7 at 7, and the continuous symptom scores all show the interaction at p of 0.0001 or below. The categorical specification from earlier versions of this work agrees.</a:t>
+              <a:t>The result is not an artifact of any cutoff. PCL-5 at 33, PHQ-9 at 15, GAD-7 at 7, and the continuous symptom scores all show the interaction at p of 0.0002 or below. The categorical specification from earlier versions of this work agrees.</a:t>
             </a:r>
             <a:endParaRPr lang="en-US" dirty="0"/>
           </a:p>
@@ -2260,7 +2260,7 @@
           <a:p>
             <a:r>
               <a:rPr lang="en-US" dirty="0"/>
-              <a:t>Survey of 1,766 adults, January to March 2024. Six states: five conflict-affected — Benue, Borno, Enugu, Rivers, Sokoto — and Ogun as a non-conflict comparison, which anchors the low end of the trauma gradient. Stratified multi-stage cluster design: state strata, 572 community clusters, community and IDP-camp settings. Analyses account for the design throughout.</a:t>
+              <a:t>Survey of 1,729 adults (37 who declined the trauma items are excluded), January to March 2024. Six states: five conflict-affected — Benue, Borno, Enugu, Rivers, Sokoto — and Ogun as a non-conflict comparison, which anchors the low end of the trauma gradient. Stratified multi-stage cluster design: state strata, 572 community clusters, community and IDP-camp settings. Analyses account for the design throughout.</a:t>
             </a:r>
             <a:endParaRPr lang="en-US" dirty="0"/>
           </a:p>
@@ -2524,7 +2524,7 @@
           <a:p>
             <a:r>
               <a:rPr lang="en-US" dirty="0"/>
-              <a:t>Read one row aloud. Among adults with no trauma exposure, each additional stressor raises PTSD prevalence by 73 percent. Among adults with five or more event types, nothing — a null. Depression and anxiety do the same. The interaction is significant for all three outcomes, p at or below 0.0006. The red row is the finding: stress sensitivity is concentrated where trauma exposure is lowest.</a:t>
+              <a:t>Read one row aloud. Among adults with no trauma exposure, each additional stressor nearly doubles PTSD prevalence — IRR 1.97. Among adults with five or more event types, nothing — a null. Depression and anxiety do the same. The interaction is below 0.0001 for all three outcomes. The red row is the finding: stress sensitivity is concentrated where trauma exposure is lowest.</a:t>
             </a:r>
             <a:endParaRPr lang="en-US" dirty="0"/>
           </a:p>
@@ -3222,7 +3222,7 @@
                 <a:ea typeface="Avenir Book" pitchFamily="34" charset="-122"/>
                 <a:cs typeface="Avenir Book" pitchFamily="34" charset="-120"/>
               </a:rPr>
-              <a:t>+21.9</a:t>
+              <a:t>+21.8</a:t>
             </a:r>
             <a:endParaRPr lang="en-US" sz="6000" dirty="0"/>
           </a:p>
@@ -3278,7 +3278,7 @@
                 <a:ea typeface="Avenir Book" pitchFamily="34" charset="-122"/>
                 <a:cs typeface="Avenir Book" pitchFamily="34" charset="-120"/>
               </a:rPr>
-              <a:t>(95% CI 7.7–36.1)</a:t>
+              <a:t>(95% CI 7.2–36.5)</a:t>
             </a:r>
             <a:endParaRPr lang="en-US" sz="1400" dirty="0"/>
           </a:p>
@@ -3317,7 +3317,7 @@
                 <a:ea typeface="Avenir Book" pitchFamily="34" charset="-122"/>
                 <a:cs typeface="Avenir Book" pitchFamily="34" charset="-120"/>
               </a:rPr>
-              <a:t>−3.0</a:t>
+              <a:t>−2.5</a:t>
             </a:r>
             <a:endParaRPr lang="en-US" sz="6000" dirty="0"/>
           </a:p>
@@ -3373,7 +3373,7 @@
                 <a:ea typeface="Avenir Book" pitchFamily="34" charset="-122"/>
                 <a:cs typeface="Avenir Book" pitchFamily="34" charset="-120"/>
               </a:rPr>
-              <a:t>(95% CI −19.5 to +13.6)</a:t>
+              <a:t>(95% CI −18.3 to +13.4)</a:t>
             </a:r>
             <a:endParaRPr lang="en-US" sz="1400" dirty="0"/>
           </a:p>
@@ -3412,7 +3412,7 @@
                 <a:ea typeface="Avenir Book" pitchFamily="34" charset="-122"/>
                 <a:cs typeface="Avenir Book" pitchFamily="34" charset="-120"/>
               </a:rPr>
-              <a:t>Depression: +21.9 vs +2.8   ·   Anxiety: +16.6 vs −4.4</a:t>
+              <a:t>Depression: +24.1 vs +3.5   ·   Anxiety: +17.8 vs −4.0</a:t>
             </a:r>
             <a:endParaRPr lang="en-US" sz="1600" dirty="0"/>
           </a:p>
@@ -3525,7 +3525,7 @@
                 <a:ea typeface="Avenir Book" pitchFamily="34" charset="-122"/>
                 <a:cs typeface="Avenir Book" pitchFamily="34" charset="-120"/>
               </a:rPr>
-              <a:t>Alternative thresholds (PCL-5≥33, PHQ-9≥15, GAD-7≥7): all p≤0.0001</a:t>
+              <a:t>Alternative thresholds (PCL-5≥33, PHQ-9≥15, GAD-7≥7): all p≤0.0002</a:t>
             </a:r>
             <a:endParaRPr lang="en-US" sz="2000" dirty="0"/>
           </a:p>
@@ -4639,7 +4639,7 @@
                 <a:ea typeface="Avenir Book" pitchFamily="34" charset="-122"/>
                 <a:cs typeface="Avenir Book" pitchFamily="34" charset="-120"/>
               </a:rPr>
-              <a:t>1,766 adults, January–March 2024</a:t>
+              <a:t>1,729 adults, January–March 2024</a:t>
             </a:r>
             <a:endParaRPr lang="en-US" sz="2000" dirty="0"/>
           </a:p>
@@ -5356,7 +5356,7 @@
                           <a:ea typeface="Avenir Book" pitchFamily="34" charset="-122"/>
                           <a:cs typeface="Avenir Book" pitchFamily="34" charset="-120"/>
                         </a:rPr>
-                        <a:t>1.73 (1.37–2.18)</a:t>
+                        <a:t>1.97 (1.53–2.54)</a:t>
                       </a:r>
                       <a:endParaRPr lang="en-US" sz="1500" dirty="0">
                         <a:latin typeface="Avenir Book" charset="0"/>
@@ -5397,7 +5397,7 @@
                           <a:ea typeface="Avenir Book" pitchFamily="34" charset="-122"/>
                           <a:cs typeface="Avenir Book" pitchFamily="34" charset="-120"/>
                         </a:rPr>
-                        <a:t>1.53 (1.18–1.98)</a:t>
+                        <a:t>1.83 (1.46–2.30)</a:t>
                       </a:r>
                       <a:endParaRPr lang="en-US" sz="1500" dirty="0">
                         <a:latin typeface="Avenir Book" charset="0"/>
@@ -5438,7 +5438,7 @@
                           <a:ea typeface="Avenir Book" pitchFamily="34" charset="-122"/>
                           <a:cs typeface="Avenir Book" pitchFamily="34" charset="-120"/>
                         </a:rPr>
-                        <a:t>1.52 (1.22–1.89)</a:t>
+                        <a:t>1.71 (1.35–2.17)</a:t>
                       </a:r>
                       <a:endParaRPr lang="en-US" sz="1500" dirty="0">
                         <a:latin typeface="Avenir Book" charset="0"/>
@@ -6061,7 +6061,7 @@
                           <a:ea typeface="Avenir Book" pitchFamily="34" charset="-122"/>
                           <a:cs typeface="Avenir Book" pitchFamily="34" charset="-120"/>
                         </a:rPr>
-                        <a:t>0.0006</a:t>
+                        <a:t>&lt;0.0001</a:t>
                       </a:r>
                       <a:endParaRPr lang="en-US" sz="1500" dirty="0">
                         <a:latin typeface="Avenir Book" charset="0"/>
@@ -6102,7 +6102,7 @@
                           <a:ea typeface="Avenir Book" pitchFamily="34" charset="-122"/>
                           <a:cs typeface="Avenir Book" pitchFamily="34" charset="-120"/>
                         </a:rPr>
-                        <a:t>0.0001</a:t>
+                        <a:t>&lt;0.0001</a:t>
                       </a:r>
                       <a:endParaRPr lang="en-US" sz="1500" dirty="0">
                         <a:latin typeface="Avenir Book" charset="0"/>

</xml_diff>

<commit_message>
ISTSS deck: programmed paper title, CME disclosure slide
Co-Authored-By: Claude Fable 5 <noreply@anthropic.com>
Claude-Session: https://claude.ai/code/session_019BJ4u1WYcsA14q2B552n7R
</commit_message>
<xml_diff>
--- a/projects/marvin-stress-trauma/istss_trauma_saturation.pptx
+++ b/projects/marvin-stress-trauma/istss_trauma_saturation.pptx
@@ -21,9 +21,10 @@
     <p:sldId id="269" r:id="rId15"/>
     <p:sldId id="270" r:id="rId16"/>
     <p:sldId id="271" r:id="rId17"/>
+    <p:sldId id="272" r:id="rId18"/>
   </p:sldIdLst>
   <p:notesMasterIdLst>
-    <p:notesMasterId r:id="rId18"/>
+    <p:notesMasterId r:id="rId19"/>
   </p:notesMasterIdLst>
   <p:sldSz cx="9144000" cy="5143500"/>
   <p:notesSz cx="5143500" cy="9144000"/>
@@ -1292,7 +1293,7 @@
           <a:p>
             <a:r>
               <a:rPr lang="en-US" dirty="0"/>
-              <a:t>The same result as a picture. Each line is a trauma level; the horizontal axis is the stressor count; the vertical axis is adjusted PTSD prevalence. The red line — no trauma exposure — climbs from 7 percent to 28 percent and keeps going. The five-event line starts near 40 percent and does not move. The gradient belongs to the unexposed; the burden belongs to the exposed.</a:t>
+              <a:t>Read one row aloud. Among adults with no trauma exposure, each additional stressor nearly doubles PTSD prevalence — IRR 1.97. Among adults with five or more event types, nothing — a null. Depression and anxiety do the same. The interaction is below 0.0001 for all three outcomes. The red row is the finding: stress sensitivity is concentrated where trauma exposure is lowest.</a:t>
             </a:r>
             <a:endParaRPr lang="en-US" dirty="0"/>
           </a:p>
@@ -1380,7 +1381,7 @@
           <a:p>
             <a:r>
               <a:rPr lang="en-US" dirty="0"/>
-              <a:t>Why this matters for programming: the absolute scale. Going from zero to four stressors adds 22 percentage points of PTSD prevalence among adults with no trauma exposure — from 7 to 28 percent. The same contrast among adults with five event types adds nothing, minus two and a half points with a confidence interval straddling zero, against a baseline near 40 percent. Depression: plus 24 versus plus 4. Anxiety: plus 18 versus minus 4. All three nulls at high exposure.</a:t>
+              <a:t>The same result as a picture. Each line is a trauma level; the horizontal axis is the stressor count; the vertical axis is adjusted PTSD prevalence. The red line — no trauma exposure — climbs from 7 percent to 28 percent and keeps going. The five-event line starts near 40 percent and does not move. The gradient belongs to the unexposed; the burden belongs to the exposed.</a:t>
             </a:r>
             <a:endParaRPr lang="en-US" dirty="0"/>
           </a:p>
@@ -1468,7 +1469,7 @@
           <a:p>
             <a:r>
               <a:rPr lang="en-US" dirty="0"/>
-              <a:t>The result is not an artifact of any cutoff. PCL-5 at 33, PHQ-9 at 15, GAD-7 at 7, and the continuous symptom scores all show the interaction at p of 0.0002 or below. The categorical specification from earlier versions of this work agrees.</a:t>
+              <a:t>Why this matters for programming: the absolute scale. Going from zero to four stressors adds 22 percentage points of PTSD prevalence among adults with no trauma exposure — from 7 to 28 percent. The same contrast among adults with five event types adds nothing, minus two and a half points with a confidence interval straddling zero, against a baseline near 40 percent. Depression: plus 24 versus plus 4. Anxiety: plus 18 versus minus 4. All three nulls at high exposure.</a:t>
             </a:r>
             <a:endParaRPr lang="en-US" dirty="0"/>
           </a:p>
@@ -1556,7 +1557,7 @@
           <a:p>
             <a:r>
               <a:rPr lang="en-US" dirty="0"/>
-              <a:t>The finding in one line. Pause on this slide.</a:t>
+              <a:t>The result is not an artifact of any cutoff. PCL-5 at 33, PHQ-9 at 15, GAD-7 at 7, and the continuous symptom scores all show the interaction at p of 0.0002 or below. The categorical specification from earlier versions of this work agrees.</a:t>
             </a:r>
             <a:endParaRPr lang="en-US" dirty="0"/>
           </a:p>
@@ -1644,7 +1645,7 @@
           <a:p>
             <a:r>
               <a:rPr lang="en-US" dirty="0"/>
-              <a:t>What this means, and what it cannot mean.</a:t>
+              <a:t>The finding in one line. Pause on this slide.</a:t>
             </a:r>
             <a:endParaRPr lang="en-US" dirty="0"/>
           </a:p>
@@ -1732,7 +1733,7 @@
           <a:p>
             <a:r>
               <a:rPr lang="en-US" dirty="0"/>
-              <a:t>Implication: universal psychosocial programming aims stress reduction at people whose symptoms no longer track stress. Match the intervention to trauma history — stress-focused support where sensitivity is retained, trauma-focused therapies where exposure is extensive. Limits, stated plainly: cross-sectional data, so 'saturation' describes an association pattern, not a mechanism; recall of both events and stressors; few respondents above six events, so the extreme tail is unstable; and this is prevalence, not incidence.</a:t>
+              <a:t>What this means, and what it cannot mean.</a:t>
             </a:r>
             <a:endParaRPr lang="en-US" dirty="0"/>
           </a:p>
@@ -1820,7 +1821,7 @@
           <a:p>
             <a:r>
               <a:rPr lang="en-US" dirty="0"/>
-              <a:t>Thank collaborators and the field teams in the five states and Ogun. Invite questions.</a:t>
+              <a:t>Implication: universal psychosocial programming aims stress reduction at people whose symptoms no longer track stress. Match the intervention to trauma history — stress-focused support where sensitivity is retained, trauma-focused therapies where exposure is extensive. Limits, stated plainly: cross-sectional data, so 'saturation' describes an association pattern, not a mechanism; recall of both events and stressors; few respondents above six events, so the extreme tail is unstable; and this is prevalence, not incidence.</a:t>
             </a:r>
             <a:endParaRPr lang="en-US" dirty="0"/>
           </a:p>
@@ -1844,6 +1845,94 @@
             <a:fld id="{F7021451-1387-4CA6-816F-3879F97B5CBC}" type="slidenum">
               <a:rPr lang="en-US"/>
               <a:t>16</a:t>
+            </a:fld>
+            <a:endParaRPr lang="en-US"/>
+          </a:p>
+        </p:txBody>
+      </p:sp>
+    </p:spTree>
+    <p:extLst>
+      <p:ext uri="{BB962C8B-B14F-4D97-AF65-F5344CB8AC3E}">
+        <p14:creationId xmlns:p14="http://schemas.microsoft.com/office/powerpoint/2010/main" val="1024086991"/>
+      </p:ext>
+    </p:extLst>
+  </p:cSld>
+  <p:clrMapOvr>
+    <a:masterClrMapping/>
+  </p:clrMapOvr>
+</p:notes>
+</file>
+
+<file path=ppt/notesSlides/notesSlide17.xml><?xml version="1.0" encoding="utf-8"?>
+<p:notes xmlns:a="http://schemas.openxmlformats.org/drawingml/2006/main" xmlns:r="http://schemas.openxmlformats.org/officeDocument/2006/relationships" xmlns:p="http://schemas.openxmlformats.org/presentationml/2006/main">
+  <p:cSld>
+    <p:spTree>
+      <p:nvGrpSpPr>
+        <p:cNvPr id="1" name=""/>
+        <p:cNvGrpSpPr/>
+        <p:nvPr/>
+      </p:nvGrpSpPr>
+      <p:grpSpPr>
+        <a:xfrm>
+          <a:off x="0" y="0"/>
+          <a:ext cx="0" cy="0"/>
+          <a:chOff x="0" y="0"/>
+          <a:chExt cx="0" cy="0"/>
+        </a:xfrm>
+      </p:grpSpPr>
+      <p:sp>
+        <p:nvSpPr>
+          <p:cNvPr id="2" name="Slide Image Placeholder 1"/>
+          <p:cNvSpPr>
+            <a:spLocks noGrp="1" noRot="1" noChangeAspect="1"/>
+          </p:cNvSpPr>
+          <p:nvPr>
+            <p:ph type="sldImg"/>
+          </p:nvPr>
+        </p:nvSpPr>
+        <p:spPr/>
+      </p:sp>
+      <p:sp>
+        <p:nvSpPr>
+          <p:cNvPr id="3" name="Notes Placeholder 2"/>
+          <p:cNvSpPr>
+            <a:spLocks noGrp="1"/>
+          </p:cNvSpPr>
+          <p:nvPr>
+            <p:ph type="body" idx="1"/>
+          </p:nvPr>
+        </p:nvSpPr>
+        <p:spPr/>
+        <p:txBody>
+          <a:bodyPr/>
+          <a:lstStyle/>
+          <a:p>
+            <a:r>
+              <a:rPr lang="en-US" dirty="0"/>
+              <a:t>Thank collaborators and the field teams in the five states and Ogun. Invite questions.</a:t>
+            </a:r>
+            <a:endParaRPr lang="en-US" dirty="0"/>
+          </a:p>
+        </p:txBody>
+      </p:sp>
+      <p:sp>
+        <p:nvSpPr>
+          <p:cNvPr id="4" name="Slide Number Placeholder 3"/>
+          <p:cNvSpPr>
+            <a:spLocks noGrp="1"/>
+          </p:cNvSpPr>
+          <p:nvPr>
+            <p:ph type="sldNum" sz="quarter" idx="10"/>
+          </p:nvPr>
+        </p:nvSpPr>
+        <p:spPr/>
+        <p:txBody>
+          <a:bodyPr/>
+          <a:lstStyle/>
+          <a:p>
+            <a:fld id="{F7021451-1387-4CA6-816F-3879F97B5CBC}" type="slidenum">
+              <a:rPr lang="en-US"/>
+              <a:t>17</a:t>
             </a:fld>
             <a:endParaRPr lang="en-US"/>
           </a:p>
@@ -1908,7 +1997,7 @@
           <a:p>
             <a:r>
               <a:rPr lang="en-US" dirty="0"/>
-              <a:t>Roadmap: background, methods, results, discussion. We are here.</a:t>
+              <a:t>Read once, briefly: no financial relationships to disclose.</a:t>
             </a:r>
             <a:endParaRPr lang="en-US" dirty="0"/>
           </a:p>
@@ -1996,7 +2085,7 @@
           <a:p>
             <a:r>
               <a:rPr lang="en-US" dirty="0"/>
-              <a:t>Two traditions. Additive models: trauma and daily stressors each add risk, so everyone benefits from stress reduction. Effect-modification models: trauma changes stress reactivity itself. Conflict settings are where the two make sharply different predictions, and where the evidence is thinnest. Our earlier work documented roughly one in five adults with probable PTSD across conflict-affected Nigeria.</a:t>
+              <a:t>Roadmap: background, methods, results, discussion. We are here.</a:t>
             </a:r>
             <a:endParaRPr lang="en-US" dirty="0"/>
           </a:p>
@@ -2084,7 +2173,7 @@
           <a:p>
             <a:r>
               <a:rPr lang="en-US" dirty="0"/>
-              <a:t>The question in one line. If trauma exposure modifies stress sensitivity, universal psychosocial programming is aiming at the wrong target for a large share of the population.</a:t>
+              <a:t>Two traditions. Additive models: trauma and daily stressors each add risk, so everyone benefits from stress reduction. Effect-modification models: trauma changes stress reactivity itself. Conflict settings are where the two make sharply different predictions, and where the evidence is thinnest. Our earlier work documented roughly one in five adults with probable PTSD across conflict-affected Nigeria.</a:t>
             </a:r>
             <a:endParaRPr lang="en-US" dirty="0"/>
           </a:p>
@@ -2172,7 +2261,7 @@
           <a:p>
             <a:r>
               <a:rPr lang="en-US" dirty="0"/>
-              <a:t>Now the methods.</a:t>
+              <a:t>The question in one line. If trauma exposure modifies stress sensitivity, universal psychosocial programming is aiming at the wrong target for a large share of the population.</a:t>
             </a:r>
             <a:endParaRPr lang="en-US" dirty="0"/>
           </a:p>
@@ -2260,7 +2349,7 @@
           <a:p>
             <a:r>
               <a:rPr lang="en-US" dirty="0"/>
-              <a:t>Survey of 1,729 adults (37 who declined the trauma items are excluded), January to March 2024. Six states: five conflict-affected — Benue, Borno, Enugu, Rivers, Sokoto — and Ogun as a non-conflict comparison, which anchors the low end of the trauma gradient. Stratified multi-stage cluster design: state strata, 572 community clusters, community and IDP-camp settings. Analyses account for the design throughout.</a:t>
+              <a:t>Now the methods.</a:t>
             </a:r>
             <a:endParaRPr lang="en-US" dirty="0"/>
           </a:p>
@@ -2348,7 +2437,7 @@
           <a:p>
             <a:r>
               <a:rPr lang="en-US" dirty="0"/>
-              <a:t>Outcomes: probable PTSD, PCL-5 at 38 and above; depression, PHQ-9 at 10; anxiety, GAD-7 at 10 — instruments validated in this population in our first study. Exposure: count of traumatic event types, zero to twelve, modeled as a restricted cubic spline so the shape of any saturation is estimated, not imposed by categories. Stressors: a 0-to-10 count of socioeconomic challenges. Poisson models give prevalence ratios; adjusted for age, gender, education, state; variances account for the cluster design. The test is the trauma-by-stressor interaction. We also estimate absolute prevalence differences, because targeting claims live on the absolute scale.</a:t>
+              <a:t>Survey of 1,729 adults (37 who declined the trauma items are excluded), January to March 2024. Six states: five conflict-affected — Benue, Borno, Enugu, Rivers, Sokoto — and Ogun as a non-conflict comparison, which anchors the low end of the trauma gradient. Stratified multi-stage cluster design: state strata, 572 community clusters, community and IDP-camp settings. Analyses account for the design throughout.</a:t>
             </a:r>
             <a:endParaRPr lang="en-US" dirty="0"/>
           </a:p>
@@ -2436,7 +2525,7 @@
           <a:p>
             <a:r>
               <a:rPr lang="en-US" dirty="0"/>
-              <a:t>Results in three steps: the gradient, the picture, the absolute numbers.</a:t>
+              <a:t>Outcomes: probable PTSD, PCL-5 at 38 and above; depression, PHQ-9 at 10; anxiety, GAD-7 at 10 — instruments validated in this population in our first study. Exposure: count of traumatic event types, zero to twelve, modeled as a restricted cubic spline so the shape of any saturation is estimated, not imposed by categories. Stressors: a 0-to-10 count of socioeconomic challenges. Poisson models give prevalence ratios; adjusted for age, gender, education, state; variances account for the cluster design. The test is the trauma-by-stressor interaction. We also estimate absolute prevalence differences, because targeting claims live on the absolute scale.</a:t>
             </a:r>
             <a:endParaRPr lang="en-US" dirty="0"/>
           </a:p>
@@ -2524,7 +2613,7 @@
           <a:p>
             <a:r>
               <a:rPr lang="en-US" dirty="0"/>
-              <a:t>Read one row aloud. Among adults with no trauma exposure, each additional stressor nearly doubles PTSD prevalence — IRR 1.97. Among adults with five or more event types, nothing — a null. Depression and anxiety do the same. The interaction is below 0.0001 for all three outcomes. The red row is the finding: stress sensitivity is concentrated where trauma exposure is lowest.</a:t>
+              <a:t>Results in three steps: the gradient, the picture, the absolute numbers.</a:t>
             </a:r>
             <a:endParaRPr lang="en-US" dirty="0"/>
           </a:p>
@@ -2905,8 +2994,8 @@
         </p:nvSpPr>
         <p:spPr>
           <a:xfrm>
-            <a:off x="731520" y="1554480"/>
-            <a:ext cx="7680960" cy="1371600"/>
+            <a:off x="640080" y="1371600"/>
+            <a:ext cx="7863840" cy="822960"/>
           </a:xfrm>
           <a:prstGeom prst="rect">
             <a:avLst/>
@@ -2922,7 +3011,7 @@
               <a:buNone/>
             </a:pPr>
             <a:r>
-              <a:rPr lang="en-US" sz="3400" dirty="0">
+              <a:rPr lang="en-US" sz="3000" dirty="0">
                 <a:solidFill>
                   <a:srgbClr val="000000"/>
                 </a:solidFill>
@@ -2930,26 +3019,9 @@
                 <a:ea typeface="Avenir Book" pitchFamily="34" charset="-122"/>
                 <a:cs typeface="Avenir Book" pitchFamily="34" charset="-120"/>
               </a:rPr>
-              <a:t>Trauma Saturation and</a:t>
-            </a:r>
-            <a:endParaRPr lang="en-US" sz="3400" dirty="0"/>
-          </a:p>
-          <a:p>
-            <a:pPr algn="ctr" indent="0" marL="0">
-              <a:buNone/>
-            </a:pPr>
-            <a:r>
-              <a:rPr lang="en-US" sz="3400" dirty="0">
-                <a:solidFill>
-                  <a:srgbClr val="000000"/>
-                </a:solidFill>
-                <a:latin typeface="Avenir Book" pitchFamily="34" charset="0"/>
-                <a:ea typeface="Avenir Book" pitchFamily="34" charset="-122"/>
-                <a:cs typeface="Avenir Book" pitchFamily="34" charset="-120"/>
-              </a:rPr>
-              <a:t>Differential Stress Sensitivity</a:t>
-            </a:r>
-            <a:endParaRPr lang="en-US" sz="3400" dirty="0"/>
+              <a:t>When More Trauma Means Less Stress Sensitivity</a:t>
+            </a:r>
+            <a:endParaRPr lang="en-US" sz="3000" dirty="0"/>
           </a:p>
         </p:txBody>
       </p:sp>
@@ -2961,8 +3033,8 @@
         </p:nvSpPr>
         <p:spPr>
           <a:xfrm>
-            <a:off x="731520" y="2880360"/>
-            <a:ext cx="7680960" cy="457200"/>
+            <a:off x="731520" y="2240280"/>
+            <a:ext cx="7680960" cy="822960"/>
           </a:xfrm>
           <a:prstGeom prst="rect">
             <a:avLst/>
@@ -2986,7 +3058,24 @@
                 <a:ea typeface="Avenir Book" pitchFamily="34" charset="-122"/>
                 <a:cs typeface="Avenir Book" pitchFamily="34" charset="-120"/>
               </a:rPr>
-              <a:t>Evidence from six Nigerian states</a:t>
+              <a:t>Evidence for a Trauma Saturation Effect Among</a:t>
+            </a:r>
+            <a:endParaRPr lang="en-US" sz="1800" dirty="0"/>
+          </a:p>
+          <a:p>
+            <a:pPr algn="ctr" indent="0" marL="0">
+              <a:buNone/>
+            </a:pPr>
+            <a:r>
+              <a:rPr lang="en-US" sz="1800" dirty="0">
+                <a:solidFill>
+                  <a:srgbClr val="000000"/>
+                </a:solidFill>
+                <a:latin typeface="Avenir Book" pitchFamily="34" charset="0"/>
+                <a:ea typeface="Avenir Book" pitchFamily="34" charset="-122"/>
+                <a:cs typeface="Avenir Book" pitchFamily="34" charset="-120"/>
+              </a:rPr>
+              <a:t>Violence-Exposed Populations in Nigeria</a:t>
             </a:r>
             <a:endParaRPr lang="en-US" sz="1800" dirty="0"/>
           </a:p>
@@ -3000,7 +3089,7 @@
         </p:nvSpPr>
         <p:spPr>
           <a:xfrm>
-            <a:off x="731520" y="3520440"/>
+            <a:off x="731520" y="3291840"/>
             <a:ext cx="7680960" cy="365760"/>
           </a:xfrm>
           <a:prstGeom prst="rect">
@@ -3025,9 +3114,48 @@
                 <a:ea typeface="Avenir Book" pitchFamily="34" charset="-122"/>
                 <a:cs typeface="Avenir Book" pitchFamily="34" charset="-120"/>
               </a:rPr>
-              <a:t>Mohammed Abba-Aji  ·  Washington University in St. Louis  ·  ISTSS 2026</a:t>
+              <a:t>Mohammed Abba-Aji  ·  Washington University in St. Louis</a:t>
             </a:r>
             <a:endParaRPr lang="en-US" sz="1400" dirty="0"/>
+          </a:p>
+        </p:txBody>
+      </p:sp>
+      <p:sp>
+        <p:nvSpPr>
+          <p:cNvPr id="6" name="Text 3"/>
+          <p:cNvSpPr txBox="1"/>
+          <p:nvPr/>
+        </p:nvSpPr>
+        <p:spPr>
+          <a:xfrm>
+            <a:off x="731520" y="3703320"/>
+            <a:ext cx="7680960" cy="365760"/>
+          </a:xfrm>
+          <a:prstGeom prst="rect">
+            <a:avLst/>
+          </a:prstGeom>
+          <a:noFill/>
+          <a:ln/>
+        </p:spPr>
+        <p:txBody>
+          <a:bodyPr wrap="square" lIns="0" tIns="0" rIns="0" bIns="0" rtlCol="0" anchor="ctr"/>
+          <a:lstStyle/>
+          <a:p>
+            <a:pPr algn="ctr" indent="0" marL="0">
+              <a:buNone/>
+            </a:pPr>
+            <a:r>
+              <a:rPr lang="en-US" sz="1200" dirty="0">
+                <a:solidFill>
+                  <a:srgbClr val="898989"/>
+                </a:solidFill>
+                <a:latin typeface="Avenir Book" pitchFamily="34" charset="0"/>
+                <a:ea typeface="Avenir Book" pitchFamily="34" charset="-122"/>
+                <a:cs typeface="Avenir Book" pitchFamily="34" charset="-120"/>
+              </a:rPr>
+              <a:t>ISTSS 42nd Annual Meeting  ·  San Antonio, TX  ·  September 24, 2026</a:t>
+            </a:r>
+            <a:endParaRPr lang="en-US" sz="1200" dirty="0"/>
           </a:p>
         </p:txBody>
       </p:sp>
@@ -3096,7 +3224,7 @@
                 <a:ea typeface="Avenir Book" pitchFamily="34" charset="-122"/>
                 <a:cs typeface="Avenir Book" pitchFamily="34" charset="-120"/>
               </a:rPr>
-              <a:t>Adjusted PTSD prevalence</a:t>
+              <a:t>Per-stressor prevalence ratio, by trauma exposure</a:t>
             </a:r>
             <a:endParaRPr lang="en-US" sz="2800" dirty="0"/>
           </a:p>
@@ -3104,2008 +3232,7 @@
       </p:sp>
       <p:graphicFrame>
         <p:nvGraphicFramePr>
-          <p:cNvPr id="4" name="Chart 0" descr=""/>
-          <p:cNvGraphicFramePr/>
-          <p:nvPr/>
-        </p:nvGraphicFramePr>
-        <p:xfrm>
-          <a:off x="548640" y="1234440"/>
-          <a:ext cx="8046720" cy="3291840"/>
-        </p:xfrm>
-        <a:graphic xmlns:a="http://schemas.openxmlformats.org/drawingml/2006/main">
-          <a:graphicData uri="http://schemas.openxmlformats.org/drawingml/2006/chart">
-            <c:chart xmlns:c="http://schemas.openxmlformats.org/drawingml/2006/chart" r:id="rId1"/>
-          </a:graphicData>
-        </a:graphic>
-      </p:graphicFrame>
-    </p:spTree>
-  </p:cSld>
-  <p:clrMapOvr>
-    <a:masterClrMapping/>
-  </p:clrMapOvr>
-</p:sld>
-</file>
-
-<file path=ppt/slides/slide11.xml><?xml version="1.0" encoding="utf-8"?>
-<p:sld xmlns:a="http://schemas.openxmlformats.org/drawingml/2006/main" xmlns:r="http://schemas.openxmlformats.org/officeDocument/2006/relationships" xmlns:p="http://schemas.openxmlformats.org/presentationml/2006/main">
-  <p:cSld name="Slide 11">
-    <p:bg>
-      <p:bgPr>
-        <a:solidFill>
-          <a:srgbClr val="FFFFFF"/>
-        </a:solidFill>
-      </p:bgPr>
-    </p:bg>
-    <p:spTree>
-      <p:nvGrpSpPr>
-        <p:cNvPr id="1" name=""/>
-        <p:cNvGrpSpPr/>
-        <p:nvPr/>
-      </p:nvGrpSpPr>
-      <p:grpSpPr>
-        <a:xfrm>
-          <a:off x="0" y="0"/>
-          <a:ext cx="0" cy="0"/>
-          <a:chOff x="0" y="0"/>
-          <a:chExt cx="0" cy="0"/>
-        </a:xfrm>
-      </p:grpSpPr>
-      <p:sp>
-        <p:nvSpPr>
-          <p:cNvPr id="3" name="Text 0"/>
-          <p:cNvSpPr txBox="1"/>
-          <p:nvPr/>
-        </p:nvSpPr>
-        <p:spPr>
-          <a:xfrm>
-            <a:off x="548640" y="411480"/>
-            <a:ext cx="8046720" cy="640080"/>
-          </a:xfrm>
-          <a:prstGeom prst="rect">
-            <a:avLst/>
-          </a:prstGeom>
-          <a:noFill/>
-          <a:ln/>
-        </p:spPr>
-        <p:txBody>
-          <a:bodyPr wrap="square" lIns="0" tIns="0" rIns="0" bIns="0" rtlCol="0" anchor="ctr"/>
-          <a:lstStyle/>
-          <a:p>
-            <a:pPr indent="0" marL="0">
-              <a:buNone/>
-            </a:pPr>
-            <a:r>
-              <a:rPr lang="en-US" sz="2800" dirty="0">
-                <a:solidFill>
-                  <a:srgbClr val="000000"/>
-                </a:solidFill>
-                <a:latin typeface="Avenir Book" pitchFamily="34" charset="0"/>
-                <a:ea typeface="Avenir Book" pitchFamily="34" charset="-122"/>
-                <a:cs typeface="Avenir Book" pitchFamily="34" charset="-120"/>
-              </a:rPr>
-              <a:t>Four additional stressors, in percentage points</a:t>
-            </a:r>
-            <a:endParaRPr lang="en-US" sz="2800" dirty="0"/>
-          </a:p>
-        </p:txBody>
-      </p:sp>
-      <p:sp>
-        <p:nvSpPr>
-          <p:cNvPr id="4" name="Text 1"/>
-          <p:cNvSpPr txBox="1"/>
-          <p:nvPr/>
-        </p:nvSpPr>
-        <p:spPr>
-          <a:xfrm>
-            <a:off x="1097280" y="1554480"/>
-            <a:ext cx="3108960" cy="1097280"/>
-          </a:xfrm>
-          <a:prstGeom prst="rect">
-            <a:avLst/>
-          </a:prstGeom>
-          <a:noFill/>
-          <a:ln/>
-        </p:spPr>
-        <p:txBody>
-          <a:bodyPr wrap="square" lIns="0" tIns="0" rIns="0" bIns="0" rtlCol="0" anchor="ctr"/>
-          <a:lstStyle/>
-          <a:p>
-            <a:pPr algn="ctr" indent="0" marL="0">
-              <a:buNone/>
-            </a:pPr>
-            <a:r>
-              <a:rPr lang="en-US" sz="6000" dirty="0">
-                <a:solidFill>
-                  <a:srgbClr val="FF0000"/>
-                </a:solidFill>
-                <a:latin typeface="Avenir Book" pitchFamily="34" charset="0"/>
-                <a:ea typeface="Avenir Book" pitchFamily="34" charset="-122"/>
-                <a:cs typeface="Avenir Book" pitchFamily="34" charset="-120"/>
-              </a:rPr>
-              <a:t>+21.8</a:t>
-            </a:r>
-            <a:endParaRPr lang="en-US" sz="6000" dirty="0"/>
-          </a:p>
-        </p:txBody>
-      </p:sp>
-      <p:sp>
-        <p:nvSpPr>
-          <p:cNvPr id="5" name="Text 2"/>
-          <p:cNvSpPr txBox="1"/>
-          <p:nvPr/>
-        </p:nvSpPr>
-        <p:spPr>
-          <a:xfrm>
-            <a:off x="1097280" y="2651760"/>
-            <a:ext cx="3108960" cy="731520"/>
-          </a:xfrm>
-          <a:prstGeom prst="rect">
-            <a:avLst/>
-          </a:prstGeom>
-          <a:noFill/>
-          <a:ln/>
-        </p:spPr>
-        <p:txBody>
-          <a:bodyPr wrap="square" lIns="0" tIns="0" rIns="0" bIns="0" rtlCol="0" anchor="ctr"/>
-          <a:lstStyle/>
-          <a:p>
-            <a:pPr algn="ctr" indent="0" marL="0">
-              <a:buNone/>
-            </a:pPr>
-            <a:r>
-              <a:rPr lang="en-US" sz="1400" dirty="0">
-                <a:solidFill>
-                  <a:srgbClr val="000000"/>
-                </a:solidFill>
-                <a:latin typeface="Avenir Book" pitchFamily="34" charset="0"/>
-                <a:ea typeface="Avenir Book" pitchFamily="34" charset="-122"/>
-                <a:cs typeface="Avenir Book" pitchFamily="34" charset="-120"/>
-              </a:rPr>
-              <a:t>no trauma exposure</a:t>
-            </a:r>
-            <a:endParaRPr lang="en-US" sz="1400" dirty="0"/>
-          </a:p>
-          <a:p>
-            <a:pPr algn="ctr" indent="0" marL="0">
-              <a:buNone/>
-            </a:pPr>
-            <a:r>
-              <a:rPr lang="en-US" sz="1400" dirty="0">
-                <a:solidFill>
-                  <a:srgbClr val="000000"/>
-                </a:solidFill>
-                <a:latin typeface="Avenir Book" pitchFamily="34" charset="0"/>
-                <a:ea typeface="Avenir Book" pitchFamily="34" charset="-122"/>
-                <a:cs typeface="Avenir Book" pitchFamily="34" charset="-120"/>
-              </a:rPr>
-              <a:t>(95% CI 7.2–36.5)</a:t>
-            </a:r>
-            <a:endParaRPr lang="en-US" sz="1400" dirty="0"/>
-          </a:p>
-        </p:txBody>
-      </p:sp>
-      <p:sp>
-        <p:nvSpPr>
-          <p:cNvPr id="6" name="Text 3"/>
-          <p:cNvSpPr txBox="1"/>
-          <p:nvPr/>
-        </p:nvSpPr>
-        <p:spPr>
-          <a:xfrm>
-            <a:off x="4937760" y="1554480"/>
-            <a:ext cx="3108960" cy="1097280"/>
-          </a:xfrm>
-          <a:prstGeom prst="rect">
-            <a:avLst/>
-          </a:prstGeom>
-          <a:noFill/>
-          <a:ln/>
-        </p:spPr>
-        <p:txBody>
-          <a:bodyPr wrap="square" lIns="0" tIns="0" rIns="0" bIns="0" rtlCol="0" anchor="ctr"/>
-          <a:lstStyle/>
-          <a:p>
-            <a:pPr algn="ctr" indent="0" marL="0">
-              <a:buNone/>
-            </a:pPr>
-            <a:r>
-              <a:rPr lang="en-US" sz="6000" dirty="0">
-                <a:solidFill>
-                  <a:srgbClr val="000000"/>
-                </a:solidFill>
-                <a:latin typeface="Avenir Book" pitchFamily="34" charset="0"/>
-                <a:ea typeface="Avenir Book" pitchFamily="34" charset="-122"/>
-                <a:cs typeface="Avenir Book" pitchFamily="34" charset="-120"/>
-              </a:rPr>
-              <a:t>−2.5</a:t>
-            </a:r>
-            <a:endParaRPr lang="en-US" sz="6000" dirty="0"/>
-          </a:p>
-        </p:txBody>
-      </p:sp>
-      <p:sp>
-        <p:nvSpPr>
-          <p:cNvPr id="7" name="Text 4"/>
-          <p:cNvSpPr txBox="1"/>
-          <p:nvPr/>
-        </p:nvSpPr>
-        <p:spPr>
-          <a:xfrm>
-            <a:off x="4937760" y="2651760"/>
-            <a:ext cx="3108960" cy="731520"/>
-          </a:xfrm>
-          <a:prstGeom prst="rect">
-            <a:avLst/>
-          </a:prstGeom>
-          <a:noFill/>
-          <a:ln/>
-        </p:spPr>
-        <p:txBody>
-          <a:bodyPr wrap="square" lIns="0" tIns="0" rIns="0" bIns="0" rtlCol="0" anchor="ctr"/>
-          <a:lstStyle/>
-          <a:p>
-            <a:pPr algn="ctr" indent="0" marL="0">
-              <a:buNone/>
-            </a:pPr>
-            <a:r>
-              <a:rPr lang="en-US" sz="1400" dirty="0">
-                <a:solidFill>
-                  <a:srgbClr val="000000"/>
-                </a:solidFill>
-                <a:latin typeface="Avenir Book" pitchFamily="34" charset="0"/>
-                <a:ea typeface="Avenir Book" pitchFamily="34" charset="-122"/>
-                <a:cs typeface="Avenir Book" pitchFamily="34" charset="-120"/>
-              </a:rPr>
-              <a:t>five or more events</a:t>
-            </a:r>
-            <a:endParaRPr lang="en-US" sz="1400" dirty="0"/>
-          </a:p>
-          <a:p>
-            <a:pPr algn="ctr" indent="0" marL="0">
-              <a:buNone/>
-            </a:pPr>
-            <a:r>
-              <a:rPr lang="en-US" sz="1400" dirty="0">
-                <a:solidFill>
-                  <a:srgbClr val="000000"/>
-                </a:solidFill>
-                <a:latin typeface="Avenir Book" pitchFamily="34" charset="0"/>
-                <a:ea typeface="Avenir Book" pitchFamily="34" charset="-122"/>
-                <a:cs typeface="Avenir Book" pitchFamily="34" charset="-120"/>
-              </a:rPr>
-              <a:t>(95% CI −18.3 to +13.4)</a:t>
-            </a:r>
-            <a:endParaRPr lang="en-US" sz="1400" dirty="0"/>
-          </a:p>
-        </p:txBody>
-      </p:sp>
-      <p:sp>
-        <p:nvSpPr>
-          <p:cNvPr id="8" name="Text 5"/>
-          <p:cNvSpPr txBox="1"/>
-          <p:nvPr/>
-        </p:nvSpPr>
-        <p:spPr>
-          <a:xfrm>
-            <a:off x="548640" y="3840480"/>
-            <a:ext cx="8046720" cy="457200"/>
-          </a:xfrm>
-          <a:prstGeom prst="rect">
-            <a:avLst/>
-          </a:prstGeom>
-          <a:noFill/>
-          <a:ln/>
-        </p:spPr>
-        <p:txBody>
-          <a:bodyPr wrap="square" lIns="0" tIns="0" rIns="0" bIns="0" rtlCol="0" anchor="ctr"/>
-          <a:lstStyle/>
-          <a:p>
-            <a:pPr algn="ctr" indent="0" marL="0">
-              <a:buNone/>
-            </a:pPr>
-            <a:r>
-              <a:rPr lang="en-US" sz="1600" dirty="0">
-                <a:solidFill>
-                  <a:srgbClr val="000000"/>
-                </a:solidFill>
-                <a:latin typeface="Avenir Book" pitchFamily="34" charset="0"/>
-                <a:ea typeface="Avenir Book" pitchFamily="34" charset="-122"/>
-                <a:cs typeface="Avenir Book" pitchFamily="34" charset="-120"/>
-              </a:rPr>
-              <a:t>Depression: +24.1 vs +3.5   ·   Anxiety: +17.8 vs −4.0</a:t>
-            </a:r>
-            <a:endParaRPr lang="en-US" sz="1600" dirty="0"/>
-          </a:p>
-        </p:txBody>
-      </p:sp>
-    </p:spTree>
-  </p:cSld>
-  <p:clrMapOvr>
-    <a:masterClrMapping/>
-  </p:clrMapOvr>
-</p:sld>
-</file>
-
-<file path=ppt/slides/slide12.xml><?xml version="1.0" encoding="utf-8"?>
-<p:sld xmlns:a="http://schemas.openxmlformats.org/drawingml/2006/main" xmlns:r="http://schemas.openxmlformats.org/officeDocument/2006/relationships" xmlns:p="http://schemas.openxmlformats.org/presentationml/2006/main">
-  <p:cSld name="Slide 12">
-    <p:bg>
-      <p:bgPr>
-        <a:solidFill>
-          <a:srgbClr val="FFFFFF"/>
-        </a:solidFill>
-      </p:bgPr>
-    </p:bg>
-    <p:spTree>
-      <p:nvGrpSpPr>
-        <p:cNvPr id="1" name=""/>
-        <p:cNvGrpSpPr/>
-        <p:nvPr/>
-      </p:nvGrpSpPr>
-      <p:grpSpPr>
-        <a:xfrm>
-          <a:off x="0" y="0"/>
-          <a:ext cx="0" cy="0"/>
-          <a:chOff x="0" y="0"/>
-          <a:chExt cx="0" cy="0"/>
-        </a:xfrm>
-      </p:grpSpPr>
-      <p:sp>
-        <p:nvSpPr>
-          <p:cNvPr id="3" name="Text 0"/>
-          <p:cNvSpPr txBox="1"/>
-          <p:nvPr/>
-        </p:nvSpPr>
-        <p:spPr>
-          <a:xfrm>
-            <a:off x="548640" y="411480"/>
-            <a:ext cx="8046720" cy="640080"/>
-          </a:xfrm>
-          <a:prstGeom prst="rect">
-            <a:avLst/>
-          </a:prstGeom>
-          <a:noFill/>
-          <a:ln/>
-        </p:spPr>
-        <p:txBody>
-          <a:bodyPr wrap="square" lIns="0" tIns="0" rIns="0" bIns="0" rtlCol="0" anchor="ctr"/>
-          <a:lstStyle/>
-          <a:p>
-            <a:pPr indent="0" marL="0">
-              <a:buNone/>
-            </a:pPr>
-            <a:r>
-              <a:rPr lang="en-US" sz="2800" dirty="0">
-                <a:solidFill>
-                  <a:srgbClr val="000000"/>
-                </a:solidFill>
-                <a:latin typeface="Avenir Book" pitchFamily="34" charset="0"/>
-                <a:ea typeface="Avenir Book" pitchFamily="34" charset="-122"/>
-                <a:cs typeface="Avenir Book" pitchFamily="34" charset="-120"/>
-              </a:rPr>
-              <a:t>Robustness</a:t>
-            </a:r>
-            <a:endParaRPr lang="en-US" sz="2800" dirty="0"/>
-          </a:p>
-        </p:txBody>
-      </p:sp>
-      <p:sp>
-        <p:nvSpPr>
-          <p:cNvPr id="4" name="Text 1"/>
-          <p:cNvSpPr txBox="1"/>
-          <p:nvPr/>
-        </p:nvSpPr>
-        <p:spPr>
-          <a:xfrm>
-            <a:off x="548640" y="1371600"/>
-            <a:ext cx="8046720" cy="3291840"/>
-          </a:xfrm>
-          <a:prstGeom prst="rect">
-            <a:avLst/>
-          </a:prstGeom>
-          <a:noFill/>
-          <a:ln/>
-        </p:spPr>
-        <p:txBody>
-          <a:bodyPr wrap="square" lIns="0" tIns="0" rIns="0" bIns="0" rtlCol="0" anchor="t"/>
-          <a:lstStyle/>
-          <a:p>
-            <a:pPr indent="0" marL="0">
-              <a:spcAft>
-                <a:spcPts val="1400"/>
-              </a:spcAft>
-              <a:buNone/>
-            </a:pPr>
-            <a:r>
-              <a:rPr lang="en-US" sz="2000" dirty="0">
-                <a:solidFill>
-                  <a:srgbClr val="000000"/>
-                </a:solidFill>
-                <a:latin typeface="Avenir Book" pitchFamily="34" charset="0"/>
-                <a:ea typeface="Avenir Book" pitchFamily="34" charset="-122"/>
-                <a:cs typeface="Avenir Book" pitchFamily="34" charset="-120"/>
-              </a:rPr>
-              <a:t>Alternative thresholds (PCL-5≥33, PHQ-9≥15, GAD-7≥7): all p≤0.0002</a:t>
-            </a:r>
-            <a:endParaRPr lang="en-US" sz="2000" dirty="0"/>
-          </a:p>
-          <a:p>
-            <a:pPr indent="0" marL="0">
-              <a:spcAft>
-                <a:spcPts val="1400"/>
-              </a:spcAft>
-              <a:buNone/>
-            </a:pPr>
-            <a:r>
-              <a:rPr lang="en-US" sz="2000" dirty="0">
-                <a:solidFill>
-                  <a:srgbClr val="000000"/>
-                </a:solidFill>
-                <a:latin typeface="Avenir Book" pitchFamily="34" charset="0"/>
-                <a:ea typeface="Avenir Book" pitchFamily="34" charset="-122"/>
-                <a:cs typeface="Avenir Book" pitchFamily="34" charset="-120"/>
-              </a:rPr>
-              <a:t>Continuous symptom scores: all p≤0.0001</a:t>
-            </a:r>
-            <a:endParaRPr lang="en-US" sz="2000" dirty="0"/>
-          </a:p>
-          <a:p>
-            <a:pPr indent="0" marL="0">
-              <a:spcAft>
-                <a:spcPts val="1400"/>
-              </a:spcAft>
-              <a:buNone/>
-            </a:pPr>
-            <a:r>
-              <a:rPr lang="en-US" sz="2000" dirty="0">
-                <a:solidFill>
-                  <a:srgbClr val="000000"/>
-                </a:solidFill>
-                <a:latin typeface="Avenir Book" pitchFamily="34" charset="0"/>
-                <a:ea typeface="Avenir Book" pitchFamily="34" charset="-122"/>
-                <a:cs typeface="Avenir Book" pitchFamily="34" charset="-120"/>
-              </a:rPr>
-              <a:t>Categorical trauma specification: same pattern</a:t>
-            </a:r>
-            <a:endParaRPr lang="en-US" sz="2000" dirty="0"/>
-          </a:p>
-        </p:txBody>
-      </p:sp>
-    </p:spTree>
-  </p:cSld>
-  <p:clrMapOvr>
-    <a:masterClrMapping/>
-  </p:clrMapOvr>
-</p:sld>
-</file>
-
-<file path=ppt/slides/slide13.xml><?xml version="1.0" encoding="utf-8"?>
-<p:sld xmlns:a="http://schemas.openxmlformats.org/drawingml/2006/main" xmlns:r="http://schemas.openxmlformats.org/officeDocument/2006/relationships" xmlns:p="http://schemas.openxmlformats.org/presentationml/2006/main">
-  <p:cSld name="Slide 13">
-    <p:bg>
-      <p:bgPr>
-        <a:solidFill>
-          <a:srgbClr val="FFFFFF"/>
-        </a:solidFill>
-      </p:bgPr>
-    </p:bg>
-    <p:spTree>
-      <p:nvGrpSpPr>
-        <p:cNvPr id="1" name=""/>
-        <p:cNvGrpSpPr/>
-        <p:nvPr/>
-      </p:nvGrpSpPr>
-      <p:grpSpPr>
-        <a:xfrm>
-          <a:off x="0" y="0"/>
-          <a:ext cx="0" cy="0"/>
-          <a:chOff x="0" y="0"/>
-          <a:chExt cx="0" cy="0"/>
-        </a:xfrm>
-      </p:grpSpPr>
-      <p:sp>
-        <p:nvSpPr>
-          <p:cNvPr id="3" name="Text 0"/>
-          <p:cNvSpPr txBox="1"/>
-          <p:nvPr/>
-        </p:nvSpPr>
-        <p:spPr>
-          <a:xfrm>
-            <a:off x="731520" y="2011680"/>
-            <a:ext cx="7680960" cy="1097280"/>
-          </a:xfrm>
-          <a:prstGeom prst="rect">
-            <a:avLst/>
-          </a:prstGeom>
-          <a:noFill/>
-          <a:ln/>
-        </p:spPr>
-        <p:txBody>
-          <a:bodyPr wrap="square" lIns="0" tIns="0" rIns="0" bIns="0" rtlCol="0" anchor="ctr"/>
-          <a:lstStyle/>
-          <a:p>
-            <a:pPr algn="ctr" indent="0" marL="0">
-              <a:buNone/>
-            </a:pPr>
-            <a:r>
-              <a:rPr lang="en-US" sz="3000" dirty="0">
-                <a:solidFill>
-                  <a:srgbClr val="000000"/>
-                </a:solidFill>
-                <a:latin typeface="Avenir Book" pitchFamily="34" charset="0"/>
-                <a:ea typeface="Avenir Book" pitchFamily="34" charset="-122"/>
-                <a:cs typeface="Avenir Book" pitchFamily="34" charset="-120"/>
-              </a:rPr>
-              <a:t>The stress gradient lives among the least trauma-exposed.</a:t>
-            </a:r>
-            <a:endParaRPr lang="en-US" sz="3000" dirty="0"/>
-          </a:p>
-        </p:txBody>
-      </p:sp>
-    </p:spTree>
-  </p:cSld>
-  <p:clrMapOvr>
-    <a:masterClrMapping/>
-  </p:clrMapOvr>
-</p:sld>
-</file>
-
-<file path=ppt/slides/slide14.xml><?xml version="1.0" encoding="utf-8"?>
-<p:sld xmlns:a="http://schemas.openxmlformats.org/drawingml/2006/main" xmlns:r="http://schemas.openxmlformats.org/officeDocument/2006/relationships" xmlns:p="http://schemas.openxmlformats.org/presentationml/2006/main">
-  <p:cSld name="Slide 14">
-    <p:bg>
-      <p:bgPr>
-        <a:solidFill>
-          <a:srgbClr val="FFFFFF"/>
-        </a:solidFill>
-      </p:bgPr>
-    </p:bg>
-    <p:spTree>
-      <p:nvGrpSpPr>
-        <p:cNvPr id="1" name=""/>
-        <p:cNvGrpSpPr/>
-        <p:nvPr/>
-      </p:nvGrpSpPr>
-      <p:grpSpPr>
-        <a:xfrm>
-          <a:off x="0" y="0"/>
-          <a:ext cx="0" cy="0"/>
-          <a:chOff x="0" y="0"/>
-          <a:chExt cx="0" cy="0"/>
-        </a:xfrm>
-      </p:grpSpPr>
-      <p:sp>
-        <p:nvSpPr>
-          <p:cNvPr id="3" name="Text 0"/>
-          <p:cNvSpPr txBox="1"/>
-          <p:nvPr/>
-        </p:nvSpPr>
-        <p:spPr>
-          <a:xfrm>
-            <a:off x="3108960" y="1463040"/>
-            <a:ext cx="3657600" cy="2377440"/>
-          </a:xfrm>
-          <a:prstGeom prst="rect">
-            <a:avLst/>
-          </a:prstGeom>
-          <a:noFill/>
-          <a:ln/>
-        </p:spPr>
-        <p:txBody>
-          <a:bodyPr wrap="square" lIns="0" tIns="0" rIns="0" bIns="0" rtlCol="0" anchor="ctr"/>
-          <a:lstStyle/>
-          <a:p>
-            <a:pPr indent="0" marL="0">
-              <a:spcAft>
-                <a:spcPts val="1800"/>
-              </a:spcAft>
-              <a:buNone/>
-            </a:pPr>
-            <a:r>
-              <a:rPr lang="en-US" sz="2400" dirty="0">
-                <a:solidFill>
-                  <a:srgbClr val="000000"/>
-                </a:solidFill>
-                <a:latin typeface="Avenir Book" pitchFamily="34" charset="0"/>
-                <a:ea typeface="Avenir Book" pitchFamily="34" charset="-122"/>
-                <a:cs typeface="Avenir Book" pitchFamily="34" charset="-120"/>
-              </a:rPr>
-              <a:t>1. Background</a:t>
-            </a:r>
-            <a:endParaRPr lang="en-US" sz="2400" dirty="0"/>
-          </a:p>
-          <a:p>
-            <a:pPr indent="0" marL="0">
-              <a:spcAft>
-                <a:spcPts val="1800"/>
-              </a:spcAft>
-              <a:buNone/>
-            </a:pPr>
-            <a:r>
-              <a:rPr lang="en-US" sz="2400" dirty="0">
-                <a:solidFill>
-                  <a:srgbClr val="000000"/>
-                </a:solidFill>
-                <a:latin typeface="Avenir Book" pitchFamily="34" charset="0"/>
-                <a:ea typeface="Avenir Book" pitchFamily="34" charset="-122"/>
-                <a:cs typeface="Avenir Book" pitchFamily="34" charset="-120"/>
-              </a:rPr>
-              <a:t>2. Methods</a:t>
-            </a:r>
-            <a:endParaRPr lang="en-US" sz="2400" dirty="0"/>
-          </a:p>
-          <a:p>
-            <a:pPr indent="0" marL="0">
-              <a:spcAft>
-                <a:spcPts val="1800"/>
-              </a:spcAft>
-              <a:buNone/>
-            </a:pPr>
-            <a:r>
-              <a:rPr lang="en-US" sz="2400" dirty="0">
-                <a:solidFill>
-                  <a:srgbClr val="000000"/>
-                </a:solidFill>
-                <a:latin typeface="Avenir Book" pitchFamily="34" charset="0"/>
-                <a:ea typeface="Avenir Book" pitchFamily="34" charset="-122"/>
-                <a:cs typeface="Avenir Book" pitchFamily="34" charset="-120"/>
-              </a:rPr>
-              <a:t>3. Results</a:t>
-            </a:r>
-            <a:endParaRPr lang="en-US" sz="2400" dirty="0"/>
-          </a:p>
-          <a:p>
-            <a:pPr indent="0" marL="0">
-              <a:spcAft>
-                <a:spcPts val="1800"/>
-              </a:spcAft>
-              <a:buNone/>
-            </a:pPr>
-            <a:r>
-              <a:rPr lang="en-US" sz="2400" dirty="0">
-                <a:solidFill>
-                  <a:srgbClr val="FF0000"/>
-                </a:solidFill>
-                <a:latin typeface="Avenir Book" pitchFamily="34" charset="0"/>
-                <a:ea typeface="Avenir Book" pitchFamily="34" charset="-122"/>
-                <a:cs typeface="Avenir Book" pitchFamily="34" charset="-120"/>
-              </a:rPr>
-              <a:t>4. Discussion</a:t>
-            </a:r>
-            <a:endParaRPr lang="en-US" sz="2400" dirty="0"/>
-          </a:p>
-        </p:txBody>
-      </p:sp>
-    </p:spTree>
-  </p:cSld>
-  <p:clrMapOvr>
-    <a:masterClrMapping/>
-  </p:clrMapOvr>
-</p:sld>
-</file>
-
-<file path=ppt/slides/slide15.xml><?xml version="1.0" encoding="utf-8"?>
-<p:sld xmlns:a="http://schemas.openxmlformats.org/drawingml/2006/main" xmlns:r="http://schemas.openxmlformats.org/officeDocument/2006/relationships" xmlns:p="http://schemas.openxmlformats.org/presentationml/2006/main">
-  <p:cSld name="Slide 15">
-    <p:bg>
-      <p:bgPr>
-        <a:solidFill>
-          <a:srgbClr val="FFFFFF"/>
-        </a:solidFill>
-      </p:bgPr>
-    </p:bg>
-    <p:spTree>
-      <p:nvGrpSpPr>
-        <p:cNvPr id="1" name=""/>
-        <p:cNvGrpSpPr/>
-        <p:nvPr/>
-      </p:nvGrpSpPr>
-      <p:grpSpPr>
-        <a:xfrm>
-          <a:off x="0" y="0"/>
-          <a:ext cx="0" cy="0"/>
-          <a:chOff x="0" y="0"/>
-          <a:chExt cx="0" cy="0"/>
-        </a:xfrm>
-      </p:grpSpPr>
-      <p:sp>
-        <p:nvSpPr>
-          <p:cNvPr id="3" name="Text 0"/>
-          <p:cNvSpPr txBox="1"/>
-          <p:nvPr/>
-        </p:nvSpPr>
-        <p:spPr>
-          <a:xfrm>
-            <a:off x="548640" y="411480"/>
-            <a:ext cx="8046720" cy="640080"/>
-          </a:xfrm>
-          <a:prstGeom prst="rect">
-            <a:avLst/>
-          </a:prstGeom>
-          <a:noFill/>
-          <a:ln/>
-        </p:spPr>
-        <p:txBody>
-          <a:bodyPr wrap="square" lIns="0" tIns="0" rIns="0" bIns="0" rtlCol="0" anchor="ctr"/>
-          <a:lstStyle/>
-          <a:p>
-            <a:pPr indent="0" marL="0">
-              <a:buNone/>
-            </a:pPr>
-            <a:r>
-              <a:rPr lang="en-US" sz="2800" dirty="0">
-                <a:solidFill>
-                  <a:srgbClr val="000000"/>
-                </a:solidFill>
-                <a:latin typeface="Avenir Book" pitchFamily="34" charset="0"/>
-                <a:ea typeface="Avenir Book" pitchFamily="34" charset="-122"/>
-                <a:cs typeface="Avenir Book" pitchFamily="34" charset="-120"/>
-              </a:rPr>
-              <a:t>What this means</a:t>
-            </a:r>
-            <a:endParaRPr lang="en-US" sz="2800" dirty="0"/>
-          </a:p>
-        </p:txBody>
-      </p:sp>
-      <p:sp>
-        <p:nvSpPr>
-          <p:cNvPr id="4" name="Text 1"/>
-          <p:cNvSpPr txBox="1"/>
-          <p:nvPr/>
-        </p:nvSpPr>
-        <p:spPr>
-          <a:xfrm>
-            <a:off x="548640" y="1371600"/>
-            <a:ext cx="8046720" cy="3291840"/>
-          </a:xfrm>
-          <a:prstGeom prst="rect">
-            <a:avLst/>
-          </a:prstGeom>
-          <a:noFill/>
-          <a:ln/>
-        </p:spPr>
-        <p:txBody>
-          <a:bodyPr wrap="square" lIns="0" tIns="0" rIns="0" bIns="0" rtlCol="0" anchor="t"/>
-          <a:lstStyle/>
-          <a:p>
-            <a:pPr indent="0" marL="0">
-              <a:spcAft>
-                <a:spcPts val="1400"/>
-              </a:spcAft>
-              <a:buNone/>
-            </a:pPr>
-            <a:r>
-              <a:rPr lang="en-US" sz="2000" dirty="0">
-                <a:solidFill>
-                  <a:srgbClr val="000000"/>
-                </a:solidFill>
-                <a:latin typeface="Avenir Book" pitchFamily="34" charset="0"/>
-                <a:ea typeface="Avenir Book" pitchFamily="34" charset="-122"/>
-                <a:cs typeface="Avenir Book" pitchFamily="34" charset="-120"/>
-              </a:rPr>
-              <a:t>Match intervention to trauma history, not one program for all</a:t>
-            </a:r>
-            <a:endParaRPr lang="en-US" sz="2000" dirty="0"/>
-          </a:p>
-          <a:p>
-            <a:pPr indent="0" marL="0">
-              <a:spcAft>
-                <a:spcPts val="1400"/>
-              </a:spcAft>
-              <a:buNone/>
-            </a:pPr>
-            <a:r>
-              <a:rPr lang="en-US" sz="2000" dirty="0">
-                <a:solidFill>
-                  <a:srgbClr val="000000"/>
-                </a:solidFill>
-                <a:latin typeface="Avenir Book" pitchFamily="34" charset="0"/>
-                <a:ea typeface="Avenir Book" pitchFamily="34" charset="-122"/>
-                <a:cs typeface="Avenir Book" pitchFamily="34" charset="-120"/>
-              </a:rPr>
-              <a:t>Stress-focused support where sensitivity is retained</a:t>
-            </a:r>
-            <a:endParaRPr lang="en-US" sz="2000" dirty="0"/>
-          </a:p>
-          <a:p>
-            <a:pPr indent="0" marL="0">
-              <a:spcAft>
-                <a:spcPts val="1400"/>
-              </a:spcAft>
-              <a:buNone/>
-            </a:pPr>
-            <a:r>
-              <a:rPr lang="en-US" sz="2000" dirty="0">
-                <a:solidFill>
-                  <a:srgbClr val="000000"/>
-                </a:solidFill>
-                <a:latin typeface="Avenir Book" pitchFamily="34" charset="0"/>
-                <a:ea typeface="Avenir Book" pitchFamily="34" charset="-122"/>
-                <a:cs typeface="Avenir Book" pitchFamily="34" charset="-120"/>
-              </a:rPr>
-              <a:t>Trauma-focused therapies where exposure is extensive</a:t>
-            </a:r>
-            <a:endParaRPr lang="en-US" sz="2000" dirty="0"/>
-          </a:p>
-          <a:p>
-            <a:pPr indent="0" marL="0">
-              <a:spcAft>
-                <a:spcPts val="200"/>
-              </a:spcAft>
-              <a:buNone/>
-            </a:pPr>
-            <a:r>
-              <a:rPr lang="en-US" sz="2000" dirty="0">
-                <a:solidFill>
-                  <a:srgbClr val="000000"/>
-                </a:solidFill>
-                <a:latin typeface="Avenir Book" pitchFamily="34" charset="0"/>
-                <a:ea typeface="Avenir Book" pitchFamily="34" charset="-122"/>
-                <a:cs typeface="Avenir Book" pitchFamily="34" charset="-120"/>
-              </a:rPr>
-              <a:t>Limits: cross-sectional; recall; sparse data above six events</a:t>
-            </a:r>
-            <a:endParaRPr lang="en-US" sz="2000" dirty="0"/>
-          </a:p>
-        </p:txBody>
-      </p:sp>
-    </p:spTree>
-  </p:cSld>
-  <p:clrMapOvr>
-    <a:masterClrMapping/>
-  </p:clrMapOvr>
-</p:sld>
-</file>
-
-<file path=ppt/slides/slide16.xml><?xml version="1.0" encoding="utf-8"?>
-<p:sld xmlns:a="http://schemas.openxmlformats.org/drawingml/2006/main" xmlns:r="http://schemas.openxmlformats.org/officeDocument/2006/relationships" xmlns:p="http://schemas.openxmlformats.org/presentationml/2006/main">
-  <p:cSld name="Slide 16">
-    <p:bg>
-      <p:bgPr>
-        <a:solidFill>
-          <a:srgbClr val="FFFFFF"/>
-        </a:solidFill>
-      </p:bgPr>
-    </p:bg>
-    <p:spTree>
-      <p:nvGrpSpPr>
-        <p:cNvPr id="1" name=""/>
-        <p:cNvGrpSpPr/>
-        <p:nvPr/>
-      </p:nvGrpSpPr>
-      <p:grpSpPr>
-        <a:xfrm>
-          <a:off x="0" y="0"/>
-          <a:ext cx="0" cy="0"/>
-          <a:chOff x="0" y="0"/>
-          <a:chExt cx="0" cy="0"/>
-        </a:xfrm>
-      </p:grpSpPr>
-      <p:sp>
-        <p:nvSpPr>
-          <p:cNvPr id="3" name="Text 0"/>
-          <p:cNvSpPr txBox="1"/>
-          <p:nvPr/>
-        </p:nvSpPr>
-        <p:spPr>
-          <a:xfrm>
-            <a:off x="731520" y="2286000"/>
-            <a:ext cx="7680960" cy="548640"/>
-          </a:xfrm>
-          <a:prstGeom prst="rect">
-            <a:avLst/>
-          </a:prstGeom>
-          <a:noFill/>
-          <a:ln/>
-        </p:spPr>
-        <p:txBody>
-          <a:bodyPr wrap="square" lIns="0" tIns="0" rIns="0" bIns="0" rtlCol="0" anchor="ctr"/>
-          <a:lstStyle/>
-          <a:p>
-            <a:pPr algn="ctr" indent="0" marL="0">
-              <a:buNone/>
-            </a:pPr>
-            <a:r>
-              <a:rPr lang="en-US" sz="2200" dirty="0">
-                <a:solidFill>
-                  <a:srgbClr val="000000"/>
-                </a:solidFill>
-                <a:latin typeface="Avenir Book" pitchFamily="34" charset="0"/>
-                <a:ea typeface="Avenir Book" pitchFamily="34" charset="-122"/>
-                <a:cs typeface="Avenir Book" pitchFamily="34" charset="-120"/>
-              </a:rPr>
-              <a:t>[your preferred email]</a:t>
-            </a:r>
-            <a:endParaRPr lang="en-US" sz="2200" dirty="0"/>
-          </a:p>
-        </p:txBody>
-      </p:sp>
-    </p:spTree>
-  </p:cSld>
-  <p:clrMapOvr>
-    <a:masterClrMapping/>
-  </p:clrMapOvr>
-</p:sld>
-</file>
-
-<file path=ppt/slides/slide2.xml><?xml version="1.0" encoding="utf-8"?>
-<p:sld xmlns:a="http://schemas.openxmlformats.org/drawingml/2006/main" xmlns:r="http://schemas.openxmlformats.org/officeDocument/2006/relationships" xmlns:p="http://schemas.openxmlformats.org/presentationml/2006/main">
-  <p:cSld name="Slide 2">
-    <p:bg>
-      <p:bgPr>
-        <a:solidFill>
-          <a:srgbClr val="FFFFFF"/>
-        </a:solidFill>
-      </p:bgPr>
-    </p:bg>
-    <p:spTree>
-      <p:nvGrpSpPr>
-        <p:cNvPr id="1" name=""/>
-        <p:cNvGrpSpPr/>
-        <p:nvPr/>
-      </p:nvGrpSpPr>
-      <p:grpSpPr>
-        <a:xfrm>
-          <a:off x="0" y="0"/>
-          <a:ext cx="0" cy="0"/>
-          <a:chOff x="0" y="0"/>
-          <a:chExt cx="0" cy="0"/>
-        </a:xfrm>
-      </p:grpSpPr>
-      <p:sp>
-        <p:nvSpPr>
-          <p:cNvPr id="3" name="Text 0"/>
-          <p:cNvSpPr txBox="1"/>
-          <p:nvPr/>
-        </p:nvSpPr>
-        <p:spPr>
-          <a:xfrm>
-            <a:off x="3108960" y="1463040"/>
-            <a:ext cx="3657600" cy="2377440"/>
-          </a:xfrm>
-          <a:prstGeom prst="rect">
-            <a:avLst/>
-          </a:prstGeom>
-          <a:noFill/>
-          <a:ln/>
-        </p:spPr>
-        <p:txBody>
-          <a:bodyPr wrap="square" lIns="0" tIns="0" rIns="0" bIns="0" rtlCol="0" anchor="ctr"/>
-          <a:lstStyle/>
-          <a:p>
-            <a:pPr indent="0" marL="0">
-              <a:spcAft>
-                <a:spcPts val="1800"/>
-              </a:spcAft>
-              <a:buNone/>
-            </a:pPr>
-            <a:r>
-              <a:rPr lang="en-US" sz="2400" dirty="0">
-                <a:solidFill>
-                  <a:srgbClr val="FF0000"/>
-                </a:solidFill>
-                <a:latin typeface="Avenir Book" pitchFamily="34" charset="0"/>
-                <a:ea typeface="Avenir Book" pitchFamily="34" charset="-122"/>
-                <a:cs typeface="Avenir Book" pitchFamily="34" charset="-120"/>
-              </a:rPr>
-              <a:t>1. Background</a:t>
-            </a:r>
-            <a:endParaRPr lang="en-US" sz="2400" dirty="0"/>
-          </a:p>
-          <a:p>
-            <a:pPr indent="0" marL="0">
-              <a:spcAft>
-                <a:spcPts val="1800"/>
-              </a:spcAft>
-              <a:buNone/>
-            </a:pPr>
-            <a:r>
-              <a:rPr lang="en-US" sz="2400" dirty="0">
-                <a:solidFill>
-                  <a:srgbClr val="000000"/>
-                </a:solidFill>
-                <a:latin typeface="Avenir Book" pitchFamily="34" charset="0"/>
-                <a:ea typeface="Avenir Book" pitchFamily="34" charset="-122"/>
-                <a:cs typeface="Avenir Book" pitchFamily="34" charset="-120"/>
-              </a:rPr>
-              <a:t>2. Methods</a:t>
-            </a:r>
-            <a:endParaRPr lang="en-US" sz="2400" dirty="0"/>
-          </a:p>
-          <a:p>
-            <a:pPr indent="0" marL="0">
-              <a:spcAft>
-                <a:spcPts val="1800"/>
-              </a:spcAft>
-              <a:buNone/>
-            </a:pPr>
-            <a:r>
-              <a:rPr lang="en-US" sz="2400" dirty="0">
-                <a:solidFill>
-                  <a:srgbClr val="000000"/>
-                </a:solidFill>
-                <a:latin typeface="Avenir Book" pitchFamily="34" charset="0"/>
-                <a:ea typeface="Avenir Book" pitchFamily="34" charset="-122"/>
-                <a:cs typeface="Avenir Book" pitchFamily="34" charset="-120"/>
-              </a:rPr>
-              <a:t>3. Results</a:t>
-            </a:r>
-            <a:endParaRPr lang="en-US" sz="2400" dirty="0"/>
-          </a:p>
-          <a:p>
-            <a:pPr indent="0" marL="0">
-              <a:spcAft>
-                <a:spcPts val="1800"/>
-              </a:spcAft>
-              <a:buNone/>
-            </a:pPr>
-            <a:r>
-              <a:rPr lang="en-US" sz="2400" dirty="0">
-                <a:solidFill>
-                  <a:srgbClr val="000000"/>
-                </a:solidFill>
-                <a:latin typeface="Avenir Book" pitchFamily="34" charset="0"/>
-                <a:ea typeface="Avenir Book" pitchFamily="34" charset="-122"/>
-                <a:cs typeface="Avenir Book" pitchFamily="34" charset="-120"/>
-              </a:rPr>
-              <a:t>4. Discussion</a:t>
-            </a:r>
-            <a:endParaRPr lang="en-US" sz="2400" dirty="0"/>
-          </a:p>
-        </p:txBody>
-      </p:sp>
-    </p:spTree>
-  </p:cSld>
-  <p:clrMapOvr>
-    <a:masterClrMapping/>
-  </p:clrMapOvr>
-</p:sld>
-</file>
-
-<file path=ppt/slides/slide3.xml><?xml version="1.0" encoding="utf-8"?>
-<p:sld xmlns:a="http://schemas.openxmlformats.org/drawingml/2006/main" xmlns:r="http://schemas.openxmlformats.org/officeDocument/2006/relationships" xmlns:p="http://schemas.openxmlformats.org/presentationml/2006/main">
-  <p:cSld name="Slide 3">
-    <p:bg>
-      <p:bgPr>
-        <a:solidFill>
-          <a:srgbClr val="FFFFFF"/>
-        </a:solidFill>
-      </p:bgPr>
-    </p:bg>
-    <p:spTree>
-      <p:nvGrpSpPr>
-        <p:cNvPr id="1" name=""/>
-        <p:cNvGrpSpPr/>
-        <p:nvPr/>
-      </p:nvGrpSpPr>
-      <p:grpSpPr>
-        <a:xfrm>
-          <a:off x="0" y="0"/>
-          <a:ext cx="0" cy="0"/>
-          <a:chOff x="0" y="0"/>
-          <a:chExt cx="0" cy="0"/>
-        </a:xfrm>
-      </p:grpSpPr>
-      <p:sp>
-        <p:nvSpPr>
-          <p:cNvPr id="3" name="Text 0"/>
-          <p:cNvSpPr txBox="1"/>
-          <p:nvPr/>
-        </p:nvSpPr>
-        <p:spPr>
-          <a:xfrm>
-            <a:off x="548640" y="411480"/>
-            <a:ext cx="8046720" cy="640080"/>
-          </a:xfrm>
-          <a:prstGeom prst="rect">
-            <a:avLst/>
-          </a:prstGeom>
-          <a:noFill/>
-          <a:ln/>
-        </p:spPr>
-        <p:txBody>
-          <a:bodyPr wrap="square" lIns="0" tIns="0" rIns="0" bIns="0" rtlCol="0" anchor="ctr"/>
-          <a:lstStyle/>
-          <a:p>
-            <a:pPr indent="0" marL="0">
-              <a:buNone/>
-            </a:pPr>
-            <a:r>
-              <a:rPr lang="en-US" sz="2800" dirty="0">
-                <a:solidFill>
-                  <a:srgbClr val="000000"/>
-                </a:solidFill>
-                <a:latin typeface="Avenir Book" pitchFamily="34" charset="0"/>
-                <a:ea typeface="Avenir Book" pitchFamily="34" charset="-122"/>
-                <a:cs typeface="Avenir Book" pitchFamily="34" charset="-120"/>
-              </a:rPr>
-              <a:t>Two views of trauma and daily stress</a:t>
-            </a:r>
-            <a:endParaRPr lang="en-US" sz="2800" dirty="0"/>
-          </a:p>
-        </p:txBody>
-      </p:sp>
-      <p:sp>
-        <p:nvSpPr>
-          <p:cNvPr id="4" name="Text 1"/>
-          <p:cNvSpPr txBox="1"/>
-          <p:nvPr/>
-        </p:nvSpPr>
-        <p:spPr>
-          <a:xfrm>
-            <a:off x="548640" y="1371600"/>
-            <a:ext cx="8046720" cy="3291840"/>
-          </a:xfrm>
-          <a:prstGeom prst="rect">
-            <a:avLst/>
-          </a:prstGeom>
-          <a:noFill/>
-          <a:ln/>
-        </p:spPr>
-        <p:txBody>
-          <a:bodyPr wrap="square" lIns="0" tIns="0" rIns="0" bIns="0" rtlCol="0" anchor="t"/>
-          <a:lstStyle/>
-          <a:p>
-            <a:pPr indent="0" marL="0">
-              <a:spcAft>
-                <a:spcPts val="1400"/>
-              </a:spcAft>
-              <a:buNone/>
-            </a:pPr>
-            <a:r>
-              <a:rPr lang="en-US" sz="2000" dirty="0">
-                <a:solidFill>
-                  <a:srgbClr val="000000"/>
-                </a:solidFill>
-                <a:latin typeface="Avenir Book" pitchFamily="34" charset="0"/>
-                <a:ea typeface="Avenir Book" pitchFamily="34" charset="-122"/>
-                <a:cs typeface="Avenir Book" pitchFamily="34" charset="-120"/>
-              </a:rPr>
-              <a:t>Additive: each stressor adds the same risk to everyone</a:t>
-            </a:r>
-            <a:endParaRPr lang="en-US" sz="2000" dirty="0"/>
-          </a:p>
-          <a:p>
-            <a:pPr indent="0" marL="0">
-              <a:spcAft>
-                <a:spcPts val="1400"/>
-              </a:spcAft>
-              <a:buNone/>
-            </a:pPr>
-            <a:r>
-              <a:rPr lang="en-US" sz="2000" dirty="0">
-                <a:solidFill>
-                  <a:srgbClr val="000000"/>
-                </a:solidFill>
-                <a:latin typeface="Avenir Book" pitchFamily="34" charset="0"/>
-                <a:ea typeface="Avenir Book" pitchFamily="34" charset="-122"/>
-                <a:cs typeface="Avenir Book" pitchFamily="34" charset="-120"/>
-              </a:rPr>
-              <a:t>Effect modification: trauma changes stress sensitivity itself</a:t>
-            </a:r>
-            <a:endParaRPr lang="en-US" sz="2000" dirty="0"/>
-          </a:p>
-          <a:p>
-            <a:pPr indent="0" marL="0">
-              <a:spcAft>
-                <a:spcPts val="1400"/>
-              </a:spcAft>
-              <a:buNone/>
-            </a:pPr>
-            <a:r>
-              <a:rPr lang="en-US" sz="2000" dirty="0">
-                <a:solidFill>
-                  <a:srgbClr val="000000"/>
-                </a:solidFill>
-                <a:latin typeface="Avenir Book" pitchFamily="34" charset="0"/>
-                <a:ea typeface="Avenir Book" pitchFamily="34" charset="-122"/>
-                <a:cs typeface="Avenir Book" pitchFamily="34" charset="-120"/>
-              </a:rPr>
-              <a:t>Conflict settings make these predictions diverge</a:t>
-            </a:r>
-            <a:endParaRPr lang="en-US" sz="2000" dirty="0"/>
-          </a:p>
-          <a:p>
-            <a:pPr indent="0" marL="0">
-              <a:spcAft>
-                <a:spcPts val="1400"/>
-              </a:spcAft>
-              <a:buNone/>
-            </a:pPr>
-            <a:r>
-              <a:rPr lang="en-US" sz="2000" dirty="0">
-                <a:solidFill>
-                  <a:srgbClr val="000000"/>
-                </a:solidFill>
-                <a:latin typeface="Avenir Book" pitchFamily="34" charset="0"/>
-                <a:ea typeface="Avenir Book" pitchFamily="34" charset="-122"/>
-                <a:cs typeface="Avenir Book" pitchFamily="34" charset="-120"/>
-              </a:rPr>
-              <a:t>Nigeria: ~1 in 5 adults with probable PTSD in conflict-affected states</a:t>
-            </a:r>
-            <a:endParaRPr lang="en-US" sz="2000" dirty="0"/>
-          </a:p>
-        </p:txBody>
-      </p:sp>
-    </p:spTree>
-  </p:cSld>
-  <p:clrMapOvr>
-    <a:masterClrMapping/>
-  </p:clrMapOvr>
-</p:sld>
-</file>
-
-<file path=ppt/slides/slide4.xml><?xml version="1.0" encoding="utf-8"?>
-<p:sld xmlns:a="http://schemas.openxmlformats.org/drawingml/2006/main" xmlns:r="http://schemas.openxmlformats.org/officeDocument/2006/relationships" xmlns:p="http://schemas.openxmlformats.org/presentationml/2006/main">
-  <p:cSld name="Slide 4">
-    <p:bg>
-      <p:bgPr>
-        <a:solidFill>
-          <a:srgbClr val="FFFFFF"/>
-        </a:solidFill>
-      </p:bgPr>
-    </p:bg>
-    <p:spTree>
-      <p:nvGrpSpPr>
-        <p:cNvPr id="1" name=""/>
-        <p:cNvGrpSpPr/>
-        <p:nvPr/>
-      </p:nvGrpSpPr>
-      <p:grpSpPr>
-        <a:xfrm>
-          <a:off x="0" y="0"/>
-          <a:ext cx="0" cy="0"/>
-          <a:chOff x="0" y="0"/>
-          <a:chExt cx="0" cy="0"/>
-        </a:xfrm>
-      </p:grpSpPr>
-      <p:sp>
-        <p:nvSpPr>
-          <p:cNvPr id="3" name="Text 0"/>
-          <p:cNvSpPr txBox="1"/>
-          <p:nvPr/>
-        </p:nvSpPr>
-        <p:spPr>
-          <a:xfrm>
-            <a:off x="731520" y="2011680"/>
-            <a:ext cx="7680960" cy="1097280"/>
-          </a:xfrm>
-          <a:prstGeom prst="rect">
-            <a:avLst/>
-          </a:prstGeom>
-          <a:noFill/>
-          <a:ln/>
-        </p:spPr>
-        <p:txBody>
-          <a:bodyPr wrap="square" lIns="0" tIns="0" rIns="0" bIns="0" rtlCol="0" anchor="ctr"/>
-          <a:lstStyle/>
-          <a:p>
-            <a:pPr algn="ctr" indent="0" marL="0">
-              <a:buNone/>
-            </a:pPr>
-            <a:r>
-              <a:rPr lang="en-US" sz="3000" dirty="0">
-                <a:solidFill>
-                  <a:srgbClr val="000000"/>
-                </a:solidFill>
-                <a:latin typeface="Avenir Book" pitchFamily="34" charset="0"/>
-                <a:ea typeface="Avenir Book" pitchFamily="34" charset="-122"/>
-                <a:cs typeface="Avenir Book" pitchFamily="34" charset="-120"/>
-              </a:rPr>
-              <a:t>Does trauma change what stress does?</a:t>
-            </a:r>
-            <a:endParaRPr lang="en-US" sz="3000" dirty="0"/>
-          </a:p>
-        </p:txBody>
-      </p:sp>
-    </p:spTree>
-  </p:cSld>
-  <p:clrMapOvr>
-    <a:masterClrMapping/>
-  </p:clrMapOvr>
-</p:sld>
-</file>
-
-<file path=ppt/slides/slide5.xml><?xml version="1.0" encoding="utf-8"?>
-<p:sld xmlns:a="http://schemas.openxmlformats.org/drawingml/2006/main" xmlns:r="http://schemas.openxmlformats.org/officeDocument/2006/relationships" xmlns:p="http://schemas.openxmlformats.org/presentationml/2006/main">
-  <p:cSld name="Slide 5">
-    <p:bg>
-      <p:bgPr>
-        <a:solidFill>
-          <a:srgbClr val="FFFFFF"/>
-        </a:solidFill>
-      </p:bgPr>
-    </p:bg>
-    <p:spTree>
-      <p:nvGrpSpPr>
-        <p:cNvPr id="1" name=""/>
-        <p:cNvGrpSpPr/>
-        <p:nvPr/>
-      </p:nvGrpSpPr>
-      <p:grpSpPr>
-        <a:xfrm>
-          <a:off x="0" y="0"/>
-          <a:ext cx="0" cy="0"/>
-          <a:chOff x="0" y="0"/>
-          <a:chExt cx="0" cy="0"/>
-        </a:xfrm>
-      </p:grpSpPr>
-      <p:sp>
-        <p:nvSpPr>
-          <p:cNvPr id="3" name="Text 0"/>
-          <p:cNvSpPr txBox="1"/>
-          <p:nvPr/>
-        </p:nvSpPr>
-        <p:spPr>
-          <a:xfrm>
-            <a:off x="3108960" y="1463040"/>
-            <a:ext cx="3657600" cy="2377440"/>
-          </a:xfrm>
-          <a:prstGeom prst="rect">
-            <a:avLst/>
-          </a:prstGeom>
-          <a:noFill/>
-          <a:ln/>
-        </p:spPr>
-        <p:txBody>
-          <a:bodyPr wrap="square" lIns="0" tIns="0" rIns="0" bIns="0" rtlCol="0" anchor="ctr"/>
-          <a:lstStyle/>
-          <a:p>
-            <a:pPr indent="0" marL="0">
-              <a:spcAft>
-                <a:spcPts val="1800"/>
-              </a:spcAft>
-              <a:buNone/>
-            </a:pPr>
-            <a:r>
-              <a:rPr lang="en-US" sz="2400" dirty="0">
-                <a:solidFill>
-                  <a:srgbClr val="000000"/>
-                </a:solidFill>
-                <a:latin typeface="Avenir Book" pitchFamily="34" charset="0"/>
-                <a:ea typeface="Avenir Book" pitchFamily="34" charset="-122"/>
-                <a:cs typeface="Avenir Book" pitchFamily="34" charset="-120"/>
-              </a:rPr>
-              <a:t>1. Background</a:t>
-            </a:r>
-            <a:endParaRPr lang="en-US" sz="2400" dirty="0"/>
-          </a:p>
-          <a:p>
-            <a:pPr indent="0" marL="0">
-              <a:spcAft>
-                <a:spcPts val="1800"/>
-              </a:spcAft>
-              <a:buNone/>
-            </a:pPr>
-            <a:r>
-              <a:rPr lang="en-US" sz="2400" dirty="0">
-                <a:solidFill>
-                  <a:srgbClr val="FF0000"/>
-                </a:solidFill>
-                <a:latin typeface="Avenir Book" pitchFamily="34" charset="0"/>
-                <a:ea typeface="Avenir Book" pitchFamily="34" charset="-122"/>
-                <a:cs typeface="Avenir Book" pitchFamily="34" charset="-120"/>
-              </a:rPr>
-              <a:t>2. Methods</a:t>
-            </a:r>
-            <a:endParaRPr lang="en-US" sz="2400" dirty="0"/>
-          </a:p>
-          <a:p>
-            <a:pPr indent="0" marL="0">
-              <a:spcAft>
-                <a:spcPts val="1800"/>
-              </a:spcAft>
-              <a:buNone/>
-            </a:pPr>
-            <a:r>
-              <a:rPr lang="en-US" sz="2400" dirty="0">
-                <a:solidFill>
-                  <a:srgbClr val="000000"/>
-                </a:solidFill>
-                <a:latin typeface="Avenir Book" pitchFamily="34" charset="0"/>
-                <a:ea typeface="Avenir Book" pitchFamily="34" charset="-122"/>
-                <a:cs typeface="Avenir Book" pitchFamily="34" charset="-120"/>
-              </a:rPr>
-              <a:t>3. Results</a:t>
-            </a:r>
-            <a:endParaRPr lang="en-US" sz="2400" dirty="0"/>
-          </a:p>
-          <a:p>
-            <a:pPr indent="0" marL="0">
-              <a:spcAft>
-                <a:spcPts val="1800"/>
-              </a:spcAft>
-              <a:buNone/>
-            </a:pPr>
-            <a:r>
-              <a:rPr lang="en-US" sz="2400" dirty="0">
-                <a:solidFill>
-                  <a:srgbClr val="000000"/>
-                </a:solidFill>
-                <a:latin typeface="Avenir Book" pitchFamily="34" charset="0"/>
-                <a:ea typeface="Avenir Book" pitchFamily="34" charset="-122"/>
-                <a:cs typeface="Avenir Book" pitchFamily="34" charset="-120"/>
-              </a:rPr>
-              <a:t>4. Discussion</a:t>
-            </a:r>
-            <a:endParaRPr lang="en-US" sz="2400" dirty="0"/>
-          </a:p>
-        </p:txBody>
-      </p:sp>
-    </p:spTree>
-  </p:cSld>
-  <p:clrMapOvr>
-    <a:masterClrMapping/>
-  </p:clrMapOvr>
-</p:sld>
-</file>
-
-<file path=ppt/slides/slide6.xml><?xml version="1.0" encoding="utf-8"?>
-<p:sld xmlns:a="http://schemas.openxmlformats.org/drawingml/2006/main" xmlns:r="http://schemas.openxmlformats.org/officeDocument/2006/relationships" xmlns:p="http://schemas.openxmlformats.org/presentationml/2006/main">
-  <p:cSld name="Slide 6">
-    <p:bg>
-      <p:bgPr>
-        <a:solidFill>
-          <a:srgbClr val="FFFFFF"/>
-        </a:solidFill>
-      </p:bgPr>
-    </p:bg>
-    <p:spTree>
-      <p:nvGrpSpPr>
-        <p:cNvPr id="1" name=""/>
-        <p:cNvGrpSpPr/>
-        <p:nvPr/>
-      </p:nvGrpSpPr>
-      <p:grpSpPr>
-        <a:xfrm>
-          <a:off x="0" y="0"/>
-          <a:ext cx="0" cy="0"/>
-          <a:chOff x="0" y="0"/>
-          <a:chExt cx="0" cy="0"/>
-        </a:xfrm>
-      </p:grpSpPr>
-      <p:sp>
-        <p:nvSpPr>
-          <p:cNvPr id="3" name="Text 0"/>
-          <p:cNvSpPr txBox="1"/>
-          <p:nvPr/>
-        </p:nvSpPr>
-        <p:spPr>
-          <a:xfrm>
-            <a:off x="548640" y="411480"/>
-            <a:ext cx="8046720" cy="640080"/>
-          </a:xfrm>
-          <a:prstGeom prst="rect">
-            <a:avLst/>
-          </a:prstGeom>
-          <a:noFill/>
-          <a:ln/>
-        </p:spPr>
-        <p:txBody>
-          <a:bodyPr wrap="square" lIns="0" tIns="0" rIns="0" bIns="0" rtlCol="0" anchor="ctr"/>
-          <a:lstStyle/>
-          <a:p>
-            <a:pPr indent="0" marL="0">
-              <a:buNone/>
-            </a:pPr>
-            <a:r>
-              <a:rPr lang="en-US" sz="2800" dirty="0">
-                <a:solidFill>
-                  <a:srgbClr val="000000"/>
-                </a:solidFill>
-                <a:latin typeface="Avenir Book" pitchFamily="34" charset="0"/>
-                <a:ea typeface="Avenir Book" pitchFamily="34" charset="-122"/>
-                <a:cs typeface="Avenir Book" pitchFamily="34" charset="-120"/>
-              </a:rPr>
-              <a:t>Sample</a:t>
-            </a:r>
-            <a:endParaRPr lang="en-US" sz="2800" dirty="0"/>
-          </a:p>
-        </p:txBody>
-      </p:sp>
-      <p:sp>
-        <p:nvSpPr>
-          <p:cNvPr id="4" name="Text 1"/>
-          <p:cNvSpPr txBox="1"/>
-          <p:nvPr/>
-        </p:nvSpPr>
-        <p:spPr>
-          <a:xfrm>
-            <a:off x="548640" y="1371600"/>
-            <a:ext cx="8046720" cy="3291840"/>
-          </a:xfrm>
-          <a:prstGeom prst="rect">
-            <a:avLst/>
-          </a:prstGeom>
-          <a:noFill/>
-          <a:ln/>
-        </p:spPr>
-        <p:txBody>
-          <a:bodyPr wrap="square" lIns="0" tIns="0" rIns="0" bIns="0" rtlCol="0" anchor="t"/>
-          <a:lstStyle/>
-          <a:p>
-            <a:pPr indent="0" marL="0">
-              <a:spcAft>
-                <a:spcPts val="1400"/>
-              </a:spcAft>
-              <a:buNone/>
-            </a:pPr>
-            <a:r>
-              <a:rPr lang="en-US" sz="2000" dirty="0">
-                <a:solidFill>
-                  <a:srgbClr val="000000"/>
-                </a:solidFill>
-                <a:latin typeface="Avenir Book" pitchFamily="34" charset="0"/>
-                <a:ea typeface="Avenir Book" pitchFamily="34" charset="-122"/>
-                <a:cs typeface="Avenir Book" pitchFamily="34" charset="-120"/>
-              </a:rPr>
-              <a:t>1,729 adults, January–March 2024</a:t>
-            </a:r>
-            <a:endParaRPr lang="en-US" sz="2000" dirty="0"/>
-          </a:p>
-          <a:p>
-            <a:pPr indent="0" marL="0">
-              <a:spcAft>
-                <a:spcPts val="1400"/>
-              </a:spcAft>
-              <a:buNone/>
-            </a:pPr>
-            <a:r>
-              <a:rPr lang="en-US" sz="2000" dirty="0">
-                <a:solidFill>
-                  <a:srgbClr val="000000"/>
-                </a:solidFill>
-                <a:latin typeface="Avenir Book" pitchFamily="34" charset="0"/>
-                <a:ea typeface="Avenir Book" pitchFamily="34" charset="-122"/>
-                <a:cs typeface="Avenir Book" pitchFamily="34" charset="-120"/>
-              </a:rPr>
-              <a:t>Five conflict-affected states + Ogun (non-conflict comparison)</a:t>
-            </a:r>
-            <a:endParaRPr lang="en-US" sz="2000" dirty="0"/>
-          </a:p>
-          <a:p>
-            <a:pPr indent="0" marL="0">
-              <a:spcAft>
-                <a:spcPts val="1400"/>
-              </a:spcAft>
-              <a:buNone/>
-            </a:pPr>
-            <a:r>
-              <a:rPr lang="en-US" sz="2000" dirty="0">
-                <a:solidFill>
-                  <a:srgbClr val="000000"/>
-                </a:solidFill>
-                <a:latin typeface="Avenir Book" pitchFamily="34" charset="0"/>
-                <a:ea typeface="Avenir Book" pitchFamily="34" charset="-122"/>
-                <a:cs typeface="Avenir Book" pitchFamily="34" charset="-120"/>
-              </a:rPr>
-              <a:t>Stratified multi-stage cluster design; 572 communities</a:t>
-            </a:r>
-            <a:endParaRPr lang="en-US" sz="2000" dirty="0"/>
-          </a:p>
-          <a:p>
-            <a:pPr indent="0" marL="0">
-              <a:spcAft>
-                <a:spcPts val="1400"/>
-              </a:spcAft>
-              <a:buNone/>
-            </a:pPr>
-            <a:r>
-              <a:rPr lang="en-US" sz="2000" dirty="0">
-                <a:solidFill>
-                  <a:srgbClr val="000000"/>
-                </a:solidFill>
-                <a:latin typeface="Avenir Book" pitchFamily="34" charset="0"/>
-                <a:ea typeface="Avenir Book" pitchFamily="34" charset="-122"/>
-                <a:cs typeface="Avenir Book" pitchFamily="34" charset="-120"/>
-              </a:rPr>
-              <a:t>Community and displacement-camp settings</a:t>
-            </a:r>
-            <a:endParaRPr lang="en-US" sz="2000" dirty="0"/>
-          </a:p>
-        </p:txBody>
-      </p:sp>
-    </p:spTree>
-  </p:cSld>
-  <p:clrMapOvr>
-    <a:masterClrMapping/>
-  </p:clrMapOvr>
-</p:sld>
-</file>
-
-<file path=ppt/slides/slide7.xml><?xml version="1.0" encoding="utf-8"?>
-<p:sld xmlns:a="http://schemas.openxmlformats.org/drawingml/2006/main" xmlns:r="http://schemas.openxmlformats.org/officeDocument/2006/relationships" xmlns:p="http://schemas.openxmlformats.org/presentationml/2006/main">
-  <p:cSld name="Slide 7">
-    <p:bg>
-      <p:bgPr>
-        <a:solidFill>
-          <a:srgbClr val="FFFFFF"/>
-        </a:solidFill>
-      </p:bgPr>
-    </p:bg>
-    <p:spTree>
-      <p:nvGrpSpPr>
-        <p:cNvPr id="1" name=""/>
-        <p:cNvGrpSpPr/>
-        <p:nvPr/>
-      </p:nvGrpSpPr>
-      <p:grpSpPr>
-        <a:xfrm>
-          <a:off x="0" y="0"/>
-          <a:ext cx="0" cy="0"/>
-          <a:chOff x="0" y="0"/>
-          <a:chExt cx="0" cy="0"/>
-        </a:xfrm>
-      </p:grpSpPr>
-      <p:sp>
-        <p:nvSpPr>
-          <p:cNvPr id="3" name="Text 0"/>
-          <p:cNvSpPr txBox="1"/>
-          <p:nvPr/>
-        </p:nvSpPr>
-        <p:spPr>
-          <a:xfrm>
-            <a:off x="548640" y="411480"/>
-            <a:ext cx="8046720" cy="640080"/>
-          </a:xfrm>
-          <a:prstGeom prst="rect">
-            <a:avLst/>
-          </a:prstGeom>
-          <a:noFill/>
-          <a:ln/>
-        </p:spPr>
-        <p:txBody>
-          <a:bodyPr wrap="square" lIns="0" tIns="0" rIns="0" bIns="0" rtlCol="0" anchor="ctr"/>
-          <a:lstStyle/>
-          <a:p>
-            <a:pPr indent="0" marL="0">
-              <a:buNone/>
-            </a:pPr>
-            <a:r>
-              <a:rPr lang="en-US" sz="2800" dirty="0">
-                <a:solidFill>
-                  <a:srgbClr val="000000"/>
-                </a:solidFill>
-                <a:latin typeface="Avenir Book" pitchFamily="34" charset="0"/>
-                <a:ea typeface="Avenir Book" pitchFamily="34" charset="-122"/>
-                <a:cs typeface="Avenir Book" pitchFamily="34" charset="-120"/>
-              </a:rPr>
-              <a:t>Measures and model</a:t>
-            </a:r>
-            <a:endParaRPr lang="en-US" sz="2800" dirty="0"/>
-          </a:p>
-        </p:txBody>
-      </p:sp>
-      <p:sp>
-        <p:nvSpPr>
-          <p:cNvPr id="4" name="Text 1"/>
-          <p:cNvSpPr txBox="1"/>
-          <p:nvPr/>
-        </p:nvSpPr>
-        <p:spPr>
-          <a:xfrm>
-            <a:off x="548640" y="1371600"/>
-            <a:ext cx="8046720" cy="3291840"/>
-          </a:xfrm>
-          <a:prstGeom prst="rect">
-            <a:avLst/>
-          </a:prstGeom>
-          <a:noFill/>
-          <a:ln/>
-        </p:spPr>
-        <p:txBody>
-          <a:bodyPr wrap="square" lIns="0" tIns="0" rIns="0" bIns="0" rtlCol="0" anchor="t"/>
-          <a:lstStyle/>
-          <a:p>
-            <a:pPr indent="0" marL="0">
-              <a:spcAft>
-                <a:spcPts val="1400"/>
-              </a:spcAft>
-              <a:buNone/>
-            </a:pPr>
-            <a:r>
-              <a:rPr lang="en-US" sz="1800" dirty="0">
-                <a:solidFill>
-                  <a:srgbClr val="000000"/>
-                </a:solidFill>
-                <a:latin typeface="Avenir Book" pitchFamily="34" charset="0"/>
-                <a:ea typeface="Avenir Book" pitchFamily="34" charset="-122"/>
-                <a:cs typeface="Avenir Book" pitchFamily="34" charset="-120"/>
-              </a:rPr>
-              <a:t>PCL-5 ≥ 38  ·  PHQ-9 ≥ 10  ·  GAD-7 ≥ 10 (locally validated)</a:t>
-            </a:r>
-            <a:endParaRPr lang="en-US" sz="1800" dirty="0"/>
-          </a:p>
-          <a:p>
-            <a:pPr indent="0" marL="0">
-              <a:spcAft>
-                <a:spcPts val="1400"/>
-              </a:spcAft>
-              <a:buNone/>
-            </a:pPr>
-            <a:r>
-              <a:rPr lang="en-US" sz="1800" dirty="0">
-                <a:solidFill>
-                  <a:srgbClr val="000000"/>
-                </a:solidFill>
-                <a:latin typeface="Avenir Book" pitchFamily="34" charset="0"/>
-                <a:ea typeface="Avenir Book" pitchFamily="34" charset="-122"/>
-                <a:cs typeface="Avenir Book" pitchFamily="34" charset="-120"/>
-              </a:rPr>
-              <a:t>Trauma: 0–12 event types, restricted cubic spline</a:t>
-            </a:r>
-            <a:endParaRPr lang="en-US" sz="1800" dirty="0"/>
-          </a:p>
-          <a:p>
-            <a:pPr indent="0" marL="0">
-              <a:spcAft>
-                <a:spcPts val="1400"/>
-              </a:spcAft>
-              <a:buNone/>
-            </a:pPr>
-            <a:r>
-              <a:rPr lang="en-US" sz="1800" dirty="0">
-                <a:solidFill>
-                  <a:srgbClr val="000000"/>
-                </a:solidFill>
-                <a:latin typeface="Avenir Book" pitchFamily="34" charset="0"/>
-                <a:ea typeface="Avenir Book" pitchFamily="34" charset="-122"/>
-                <a:cs typeface="Avenir Book" pitchFamily="34" charset="-120"/>
-              </a:rPr>
-              <a:t>Stressors: socioeconomic challenge count (0–10)</a:t>
-            </a:r>
-            <a:endParaRPr lang="en-US" sz="1800" dirty="0"/>
-          </a:p>
-          <a:p>
-            <a:pPr indent="0" marL="0">
-              <a:spcAft>
-                <a:spcPts val="1400"/>
-              </a:spcAft>
-              <a:buNone/>
-            </a:pPr>
-            <a:r>
-              <a:rPr lang="en-US" sz="1800" dirty="0">
-                <a:solidFill>
-                  <a:srgbClr val="000000"/>
-                </a:solidFill>
-                <a:latin typeface="Avenir Book" pitchFamily="34" charset="0"/>
-                <a:ea typeface="Avenir Book" pitchFamily="34" charset="-122"/>
-                <a:cs typeface="Avenir Book" pitchFamily="34" charset="-120"/>
-              </a:rPr>
-              <a:t>Poisson prevalence ratios; adjusted; design-based variances</a:t>
-            </a:r>
-            <a:endParaRPr lang="en-US" sz="1800" dirty="0"/>
-          </a:p>
-          <a:p>
-            <a:pPr indent="0" marL="0">
-              <a:spcAft>
-                <a:spcPts val="1400"/>
-              </a:spcAft>
-              <a:buNone/>
-            </a:pPr>
-            <a:r>
-              <a:rPr lang="en-US" sz="1800" dirty="0">
-                <a:solidFill>
-                  <a:srgbClr val="000000"/>
-                </a:solidFill>
-                <a:latin typeface="Avenir Book" pitchFamily="34" charset="0"/>
-                <a:ea typeface="Avenir Book" pitchFamily="34" charset="-122"/>
-                <a:cs typeface="Avenir Book" pitchFamily="34" charset="-120"/>
-              </a:rPr>
-              <a:t>Test: trauma × stressor interaction, both scales</a:t>
-            </a:r>
-            <a:endParaRPr lang="en-US" sz="1800" dirty="0"/>
-          </a:p>
-        </p:txBody>
-      </p:sp>
-    </p:spTree>
-  </p:cSld>
-  <p:clrMapOvr>
-    <a:masterClrMapping/>
-  </p:clrMapOvr>
-</p:sld>
-</file>
-
-<file path=ppt/slides/slide8.xml><?xml version="1.0" encoding="utf-8"?>
-<p:sld xmlns:a="http://schemas.openxmlformats.org/drawingml/2006/main" xmlns:r="http://schemas.openxmlformats.org/officeDocument/2006/relationships" xmlns:p="http://schemas.openxmlformats.org/presentationml/2006/main">
-  <p:cSld name="Slide 8">
-    <p:bg>
-      <p:bgPr>
-        <a:solidFill>
-          <a:srgbClr val="FFFFFF"/>
-        </a:solidFill>
-      </p:bgPr>
-    </p:bg>
-    <p:spTree>
-      <p:nvGrpSpPr>
-        <p:cNvPr id="1" name=""/>
-        <p:cNvGrpSpPr/>
-        <p:nvPr/>
-      </p:nvGrpSpPr>
-      <p:grpSpPr>
-        <a:xfrm>
-          <a:off x="0" y="0"/>
-          <a:ext cx="0" cy="0"/>
-          <a:chOff x="0" y="0"/>
-          <a:chExt cx="0" cy="0"/>
-        </a:xfrm>
-      </p:grpSpPr>
-      <p:sp>
-        <p:nvSpPr>
-          <p:cNvPr id="3" name="Text 0"/>
-          <p:cNvSpPr txBox="1"/>
-          <p:nvPr/>
-        </p:nvSpPr>
-        <p:spPr>
-          <a:xfrm>
-            <a:off x="3108960" y="1463040"/>
-            <a:ext cx="3657600" cy="2377440"/>
-          </a:xfrm>
-          <a:prstGeom prst="rect">
-            <a:avLst/>
-          </a:prstGeom>
-          <a:noFill/>
-          <a:ln/>
-        </p:spPr>
-        <p:txBody>
-          <a:bodyPr wrap="square" lIns="0" tIns="0" rIns="0" bIns="0" rtlCol="0" anchor="ctr"/>
-          <a:lstStyle/>
-          <a:p>
-            <a:pPr indent="0" marL="0">
-              <a:spcAft>
-                <a:spcPts val="1800"/>
-              </a:spcAft>
-              <a:buNone/>
-            </a:pPr>
-            <a:r>
-              <a:rPr lang="en-US" sz="2400" dirty="0">
-                <a:solidFill>
-                  <a:srgbClr val="000000"/>
-                </a:solidFill>
-                <a:latin typeface="Avenir Book" pitchFamily="34" charset="0"/>
-                <a:ea typeface="Avenir Book" pitchFamily="34" charset="-122"/>
-                <a:cs typeface="Avenir Book" pitchFamily="34" charset="-120"/>
-              </a:rPr>
-              <a:t>1. Background</a:t>
-            </a:r>
-            <a:endParaRPr lang="en-US" sz="2400" dirty="0"/>
-          </a:p>
-          <a:p>
-            <a:pPr indent="0" marL="0">
-              <a:spcAft>
-                <a:spcPts val="1800"/>
-              </a:spcAft>
-              <a:buNone/>
-            </a:pPr>
-            <a:r>
-              <a:rPr lang="en-US" sz="2400" dirty="0">
-                <a:solidFill>
-                  <a:srgbClr val="000000"/>
-                </a:solidFill>
-                <a:latin typeface="Avenir Book" pitchFamily="34" charset="0"/>
-                <a:ea typeface="Avenir Book" pitchFamily="34" charset="-122"/>
-                <a:cs typeface="Avenir Book" pitchFamily="34" charset="-120"/>
-              </a:rPr>
-              <a:t>2. Methods</a:t>
-            </a:r>
-            <a:endParaRPr lang="en-US" sz="2400" dirty="0"/>
-          </a:p>
-          <a:p>
-            <a:pPr indent="0" marL="0">
-              <a:spcAft>
-                <a:spcPts val="1800"/>
-              </a:spcAft>
-              <a:buNone/>
-            </a:pPr>
-            <a:r>
-              <a:rPr lang="en-US" sz="2400" dirty="0">
-                <a:solidFill>
-                  <a:srgbClr val="FF0000"/>
-                </a:solidFill>
-                <a:latin typeface="Avenir Book" pitchFamily="34" charset="0"/>
-                <a:ea typeface="Avenir Book" pitchFamily="34" charset="-122"/>
-                <a:cs typeface="Avenir Book" pitchFamily="34" charset="-120"/>
-              </a:rPr>
-              <a:t>3. Results</a:t>
-            </a:r>
-            <a:endParaRPr lang="en-US" sz="2400" dirty="0"/>
-          </a:p>
-          <a:p>
-            <a:pPr indent="0" marL="0">
-              <a:spcAft>
-                <a:spcPts val="1800"/>
-              </a:spcAft>
-              <a:buNone/>
-            </a:pPr>
-            <a:r>
-              <a:rPr lang="en-US" sz="2400" dirty="0">
-                <a:solidFill>
-                  <a:srgbClr val="000000"/>
-                </a:solidFill>
-                <a:latin typeface="Avenir Book" pitchFamily="34" charset="0"/>
-                <a:ea typeface="Avenir Book" pitchFamily="34" charset="-122"/>
-                <a:cs typeface="Avenir Book" pitchFamily="34" charset="-120"/>
-              </a:rPr>
-              <a:t>4. Discussion</a:t>
-            </a:r>
-            <a:endParaRPr lang="en-US" sz="2400" dirty="0"/>
-          </a:p>
-        </p:txBody>
-      </p:sp>
-    </p:spTree>
-  </p:cSld>
-  <p:clrMapOvr>
-    <a:masterClrMapping/>
-  </p:clrMapOvr>
-</p:sld>
-</file>
-
-<file path=ppt/slides/slide9.xml><?xml version="1.0" encoding="utf-8"?>
-<p:sld xmlns:a="http://schemas.openxmlformats.org/drawingml/2006/main" xmlns:r="http://schemas.openxmlformats.org/officeDocument/2006/relationships" xmlns:p="http://schemas.openxmlformats.org/presentationml/2006/main">
-  <p:cSld name="Slide 9">
-    <p:bg>
-      <p:bgPr>
-        <a:solidFill>
-          <a:srgbClr val="FFFFFF"/>
-        </a:solidFill>
-      </p:bgPr>
-    </p:bg>
-    <p:spTree>
-      <p:nvGrpSpPr>
-        <p:cNvPr id="1" name=""/>
-        <p:cNvGrpSpPr/>
-        <p:nvPr/>
-      </p:nvGrpSpPr>
-      <p:grpSpPr>
-        <a:xfrm>
-          <a:off x="0" y="0"/>
-          <a:ext cx="0" cy="0"/>
-          <a:chOff x="0" y="0"/>
-          <a:chExt cx="0" cy="0"/>
-        </a:xfrm>
-      </p:grpSpPr>
-      <p:sp>
-        <p:nvSpPr>
-          <p:cNvPr id="3" name="Text 0"/>
-          <p:cNvSpPr txBox="1"/>
-          <p:nvPr/>
-        </p:nvSpPr>
-        <p:spPr>
-          <a:xfrm>
-            <a:off x="548640" y="411480"/>
-            <a:ext cx="8046720" cy="640080"/>
-          </a:xfrm>
-          <a:prstGeom prst="rect">
-            <a:avLst/>
-          </a:prstGeom>
-          <a:noFill/>
-          <a:ln/>
-        </p:spPr>
-        <p:txBody>
-          <a:bodyPr wrap="square" lIns="0" tIns="0" rIns="0" bIns="0" rtlCol="0" anchor="ctr"/>
-          <a:lstStyle/>
-          <a:p>
-            <a:pPr indent="0" marL="0">
-              <a:buNone/>
-            </a:pPr>
-            <a:r>
-              <a:rPr lang="en-US" sz="2800" dirty="0">
-                <a:solidFill>
-                  <a:srgbClr val="000000"/>
-                </a:solidFill>
-                <a:latin typeface="Avenir Book" pitchFamily="34" charset="0"/>
-                <a:ea typeface="Avenir Book" pitchFamily="34" charset="-122"/>
-                <a:cs typeface="Avenir Book" pitchFamily="34" charset="-120"/>
-              </a:rPr>
-              <a:t>Per-stressor prevalence ratio, by trauma exposure</a:t>
-            </a:r>
-            <a:endParaRPr lang="en-US" sz="2800" dirty="0"/>
-          </a:p>
-        </p:txBody>
-      </p:sp>
-      <p:graphicFrame>
-        <p:nvGraphicFramePr>
-          <p:cNvPr id="10" name="Table 0"/>
+          <p:cNvPr id="11" name="Table 0"/>
           <p:cNvGraphicFramePr>
             <a:graphicFrameLocks noGrp="1"/>
           </p:cNvGraphicFramePr>
@@ -6131,6 +4258,2140 @@
           </a:graphicData>
         </a:graphic>
       </p:graphicFrame>
+    </p:spTree>
+  </p:cSld>
+  <p:clrMapOvr>
+    <a:masterClrMapping/>
+  </p:clrMapOvr>
+</p:sld>
+</file>
+
+<file path=ppt/slides/slide11.xml><?xml version="1.0" encoding="utf-8"?>
+<p:sld xmlns:a="http://schemas.openxmlformats.org/drawingml/2006/main" xmlns:r="http://schemas.openxmlformats.org/officeDocument/2006/relationships" xmlns:p="http://schemas.openxmlformats.org/presentationml/2006/main">
+  <p:cSld name="Slide 11">
+    <p:bg>
+      <p:bgPr>
+        <a:solidFill>
+          <a:srgbClr val="FFFFFF"/>
+        </a:solidFill>
+      </p:bgPr>
+    </p:bg>
+    <p:spTree>
+      <p:nvGrpSpPr>
+        <p:cNvPr id="1" name=""/>
+        <p:cNvGrpSpPr/>
+        <p:nvPr/>
+      </p:nvGrpSpPr>
+      <p:grpSpPr>
+        <a:xfrm>
+          <a:off x="0" y="0"/>
+          <a:ext cx="0" cy="0"/>
+          <a:chOff x="0" y="0"/>
+          <a:chExt cx="0" cy="0"/>
+        </a:xfrm>
+      </p:grpSpPr>
+      <p:sp>
+        <p:nvSpPr>
+          <p:cNvPr id="3" name="Text 0"/>
+          <p:cNvSpPr txBox="1"/>
+          <p:nvPr/>
+        </p:nvSpPr>
+        <p:spPr>
+          <a:xfrm>
+            <a:off x="548640" y="411480"/>
+            <a:ext cx="8046720" cy="640080"/>
+          </a:xfrm>
+          <a:prstGeom prst="rect">
+            <a:avLst/>
+          </a:prstGeom>
+          <a:noFill/>
+          <a:ln/>
+        </p:spPr>
+        <p:txBody>
+          <a:bodyPr wrap="square" lIns="0" tIns="0" rIns="0" bIns="0" rtlCol="0" anchor="ctr"/>
+          <a:lstStyle/>
+          <a:p>
+            <a:pPr indent="0" marL="0">
+              <a:buNone/>
+            </a:pPr>
+            <a:r>
+              <a:rPr lang="en-US" sz="2800" dirty="0">
+                <a:solidFill>
+                  <a:srgbClr val="000000"/>
+                </a:solidFill>
+                <a:latin typeface="Avenir Book" pitchFamily="34" charset="0"/>
+                <a:ea typeface="Avenir Book" pitchFamily="34" charset="-122"/>
+                <a:cs typeface="Avenir Book" pitchFamily="34" charset="-120"/>
+              </a:rPr>
+              <a:t>Adjusted PTSD prevalence</a:t>
+            </a:r>
+            <a:endParaRPr lang="en-US" sz="2800" dirty="0"/>
+          </a:p>
+        </p:txBody>
+      </p:sp>
+      <p:graphicFrame>
+        <p:nvGraphicFramePr>
+          <p:cNvPr id="4" name="Chart 0" descr=""/>
+          <p:cNvGraphicFramePr/>
+          <p:nvPr/>
+        </p:nvGraphicFramePr>
+        <p:xfrm>
+          <a:off x="548640" y="1234440"/>
+          <a:ext cx="8046720" cy="3291840"/>
+        </p:xfrm>
+        <a:graphic xmlns:a="http://schemas.openxmlformats.org/drawingml/2006/main">
+          <a:graphicData uri="http://schemas.openxmlformats.org/drawingml/2006/chart">
+            <c:chart xmlns:c="http://schemas.openxmlformats.org/drawingml/2006/chart" r:id="rId1"/>
+          </a:graphicData>
+        </a:graphic>
+      </p:graphicFrame>
+    </p:spTree>
+  </p:cSld>
+  <p:clrMapOvr>
+    <a:masterClrMapping/>
+  </p:clrMapOvr>
+</p:sld>
+</file>
+
+<file path=ppt/slides/slide12.xml><?xml version="1.0" encoding="utf-8"?>
+<p:sld xmlns:a="http://schemas.openxmlformats.org/drawingml/2006/main" xmlns:r="http://schemas.openxmlformats.org/officeDocument/2006/relationships" xmlns:p="http://schemas.openxmlformats.org/presentationml/2006/main">
+  <p:cSld name="Slide 12">
+    <p:bg>
+      <p:bgPr>
+        <a:solidFill>
+          <a:srgbClr val="FFFFFF"/>
+        </a:solidFill>
+      </p:bgPr>
+    </p:bg>
+    <p:spTree>
+      <p:nvGrpSpPr>
+        <p:cNvPr id="1" name=""/>
+        <p:cNvGrpSpPr/>
+        <p:nvPr/>
+      </p:nvGrpSpPr>
+      <p:grpSpPr>
+        <a:xfrm>
+          <a:off x="0" y="0"/>
+          <a:ext cx="0" cy="0"/>
+          <a:chOff x="0" y="0"/>
+          <a:chExt cx="0" cy="0"/>
+        </a:xfrm>
+      </p:grpSpPr>
+      <p:sp>
+        <p:nvSpPr>
+          <p:cNvPr id="3" name="Text 0"/>
+          <p:cNvSpPr txBox="1"/>
+          <p:nvPr/>
+        </p:nvSpPr>
+        <p:spPr>
+          <a:xfrm>
+            <a:off x="548640" y="411480"/>
+            <a:ext cx="8046720" cy="640080"/>
+          </a:xfrm>
+          <a:prstGeom prst="rect">
+            <a:avLst/>
+          </a:prstGeom>
+          <a:noFill/>
+          <a:ln/>
+        </p:spPr>
+        <p:txBody>
+          <a:bodyPr wrap="square" lIns="0" tIns="0" rIns="0" bIns="0" rtlCol="0" anchor="ctr"/>
+          <a:lstStyle/>
+          <a:p>
+            <a:pPr indent="0" marL="0">
+              <a:buNone/>
+            </a:pPr>
+            <a:r>
+              <a:rPr lang="en-US" sz="2800" dirty="0">
+                <a:solidFill>
+                  <a:srgbClr val="000000"/>
+                </a:solidFill>
+                <a:latin typeface="Avenir Book" pitchFamily="34" charset="0"/>
+                <a:ea typeface="Avenir Book" pitchFamily="34" charset="-122"/>
+                <a:cs typeface="Avenir Book" pitchFamily="34" charset="-120"/>
+              </a:rPr>
+              <a:t>Four additional stressors, in percentage points</a:t>
+            </a:r>
+            <a:endParaRPr lang="en-US" sz="2800" dirty="0"/>
+          </a:p>
+        </p:txBody>
+      </p:sp>
+      <p:sp>
+        <p:nvSpPr>
+          <p:cNvPr id="4" name="Text 1"/>
+          <p:cNvSpPr txBox="1"/>
+          <p:nvPr/>
+        </p:nvSpPr>
+        <p:spPr>
+          <a:xfrm>
+            <a:off x="1097280" y="1554480"/>
+            <a:ext cx="3108960" cy="1097280"/>
+          </a:xfrm>
+          <a:prstGeom prst="rect">
+            <a:avLst/>
+          </a:prstGeom>
+          <a:noFill/>
+          <a:ln/>
+        </p:spPr>
+        <p:txBody>
+          <a:bodyPr wrap="square" lIns="0" tIns="0" rIns="0" bIns="0" rtlCol="0" anchor="ctr"/>
+          <a:lstStyle/>
+          <a:p>
+            <a:pPr algn="ctr" indent="0" marL="0">
+              <a:buNone/>
+            </a:pPr>
+            <a:r>
+              <a:rPr lang="en-US" sz="6000" dirty="0">
+                <a:solidFill>
+                  <a:srgbClr val="FF0000"/>
+                </a:solidFill>
+                <a:latin typeface="Avenir Book" pitchFamily="34" charset="0"/>
+                <a:ea typeface="Avenir Book" pitchFamily="34" charset="-122"/>
+                <a:cs typeface="Avenir Book" pitchFamily="34" charset="-120"/>
+              </a:rPr>
+              <a:t>+21.8</a:t>
+            </a:r>
+            <a:endParaRPr lang="en-US" sz="6000" dirty="0"/>
+          </a:p>
+        </p:txBody>
+      </p:sp>
+      <p:sp>
+        <p:nvSpPr>
+          <p:cNvPr id="5" name="Text 2"/>
+          <p:cNvSpPr txBox="1"/>
+          <p:nvPr/>
+        </p:nvSpPr>
+        <p:spPr>
+          <a:xfrm>
+            <a:off x="1097280" y="2651760"/>
+            <a:ext cx="3108960" cy="731520"/>
+          </a:xfrm>
+          <a:prstGeom prst="rect">
+            <a:avLst/>
+          </a:prstGeom>
+          <a:noFill/>
+          <a:ln/>
+        </p:spPr>
+        <p:txBody>
+          <a:bodyPr wrap="square" lIns="0" tIns="0" rIns="0" bIns="0" rtlCol="0" anchor="ctr"/>
+          <a:lstStyle/>
+          <a:p>
+            <a:pPr algn="ctr" indent="0" marL="0">
+              <a:buNone/>
+            </a:pPr>
+            <a:r>
+              <a:rPr lang="en-US" sz="1400" dirty="0">
+                <a:solidFill>
+                  <a:srgbClr val="000000"/>
+                </a:solidFill>
+                <a:latin typeface="Avenir Book" pitchFamily="34" charset="0"/>
+                <a:ea typeface="Avenir Book" pitchFamily="34" charset="-122"/>
+                <a:cs typeface="Avenir Book" pitchFamily="34" charset="-120"/>
+              </a:rPr>
+              <a:t>no trauma exposure</a:t>
+            </a:r>
+            <a:endParaRPr lang="en-US" sz="1400" dirty="0"/>
+          </a:p>
+          <a:p>
+            <a:pPr algn="ctr" indent="0" marL="0">
+              <a:buNone/>
+            </a:pPr>
+            <a:r>
+              <a:rPr lang="en-US" sz="1400" dirty="0">
+                <a:solidFill>
+                  <a:srgbClr val="000000"/>
+                </a:solidFill>
+                <a:latin typeface="Avenir Book" pitchFamily="34" charset="0"/>
+                <a:ea typeface="Avenir Book" pitchFamily="34" charset="-122"/>
+                <a:cs typeface="Avenir Book" pitchFamily="34" charset="-120"/>
+              </a:rPr>
+              <a:t>(95% CI 7.2–36.5)</a:t>
+            </a:r>
+            <a:endParaRPr lang="en-US" sz="1400" dirty="0"/>
+          </a:p>
+        </p:txBody>
+      </p:sp>
+      <p:sp>
+        <p:nvSpPr>
+          <p:cNvPr id="6" name="Text 3"/>
+          <p:cNvSpPr txBox="1"/>
+          <p:nvPr/>
+        </p:nvSpPr>
+        <p:spPr>
+          <a:xfrm>
+            <a:off x="4937760" y="1554480"/>
+            <a:ext cx="3108960" cy="1097280"/>
+          </a:xfrm>
+          <a:prstGeom prst="rect">
+            <a:avLst/>
+          </a:prstGeom>
+          <a:noFill/>
+          <a:ln/>
+        </p:spPr>
+        <p:txBody>
+          <a:bodyPr wrap="square" lIns="0" tIns="0" rIns="0" bIns="0" rtlCol="0" anchor="ctr"/>
+          <a:lstStyle/>
+          <a:p>
+            <a:pPr algn="ctr" indent="0" marL="0">
+              <a:buNone/>
+            </a:pPr>
+            <a:r>
+              <a:rPr lang="en-US" sz="6000" dirty="0">
+                <a:solidFill>
+                  <a:srgbClr val="000000"/>
+                </a:solidFill>
+                <a:latin typeface="Avenir Book" pitchFamily="34" charset="0"/>
+                <a:ea typeface="Avenir Book" pitchFamily="34" charset="-122"/>
+                <a:cs typeface="Avenir Book" pitchFamily="34" charset="-120"/>
+              </a:rPr>
+              <a:t>−2.5</a:t>
+            </a:r>
+            <a:endParaRPr lang="en-US" sz="6000" dirty="0"/>
+          </a:p>
+        </p:txBody>
+      </p:sp>
+      <p:sp>
+        <p:nvSpPr>
+          <p:cNvPr id="7" name="Text 4"/>
+          <p:cNvSpPr txBox="1"/>
+          <p:nvPr/>
+        </p:nvSpPr>
+        <p:spPr>
+          <a:xfrm>
+            <a:off x="4937760" y="2651760"/>
+            <a:ext cx="3108960" cy="731520"/>
+          </a:xfrm>
+          <a:prstGeom prst="rect">
+            <a:avLst/>
+          </a:prstGeom>
+          <a:noFill/>
+          <a:ln/>
+        </p:spPr>
+        <p:txBody>
+          <a:bodyPr wrap="square" lIns="0" tIns="0" rIns="0" bIns="0" rtlCol="0" anchor="ctr"/>
+          <a:lstStyle/>
+          <a:p>
+            <a:pPr algn="ctr" indent="0" marL="0">
+              <a:buNone/>
+            </a:pPr>
+            <a:r>
+              <a:rPr lang="en-US" sz="1400" dirty="0">
+                <a:solidFill>
+                  <a:srgbClr val="000000"/>
+                </a:solidFill>
+                <a:latin typeface="Avenir Book" pitchFamily="34" charset="0"/>
+                <a:ea typeface="Avenir Book" pitchFamily="34" charset="-122"/>
+                <a:cs typeface="Avenir Book" pitchFamily="34" charset="-120"/>
+              </a:rPr>
+              <a:t>five or more events</a:t>
+            </a:r>
+            <a:endParaRPr lang="en-US" sz="1400" dirty="0"/>
+          </a:p>
+          <a:p>
+            <a:pPr algn="ctr" indent="0" marL="0">
+              <a:buNone/>
+            </a:pPr>
+            <a:r>
+              <a:rPr lang="en-US" sz="1400" dirty="0">
+                <a:solidFill>
+                  <a:srgbClr val="000000"/>
+                </a:solidFill>
+                <a:latin typeface="Avenir Book" pitchFamily="34" charset="0"/>
+                <a:ea typeface="Avenir Book" pitchFamily="34" charset="-122"/>
+                <a:cs typeface="Avenir Book" pitchFamily="34" charset="-120"/>
+              </a:rPr>
+              <a:t>(95% CI −18.3 to +13.4)</a:t>
+            </a:r>
+            <a:endParaRPr lang="en-US" sz="1400" dirty="0"/>
+          </a:p>
+        </p:txBody>
+      </p:sp>
+      <p:sp>
+        <p:nvSpPr>
+          <p:cNvPr id="8" name="Text 5"/>
+          <p:cNvSpPr txBox="1"/>
+          <p:nvPr/>
+        </p:nvSpPr>
+        <p:spPr>
+          <a:xfrm>
+            <a:off x="548640" y="3840480"/>
+            <a:ext cx="8046720" cy="457200"/>
+          </a:xfrm>
+          <a:prstGeom prst="rect">
+            <a:avLst/>
+          </a:prstGeom>
+          <a:noFill/>
+          <a:ln/>
+        </p:spPr>
+        <p:txBody>
+          <a:bodyPr wrap="square" lIns="0" tIns="0" rIns="0" bIns="0" rtlCol="0" anchor="ctr"/>
+          <a:lstStyle/>
+          <a:p>
+            <a:pPr algn="ctr" indent="0" marL="0">
+              <a:buNone/>
+            </a:pPr>
+            <a:r>
+              <a:rPr lang="en-US" sz="1600" dirty="0">
+                <a:solidFill>
+                  <a:srgbClr val="000000"/>
+                </a:solidFill>
+                <a:latin typeface="Avenir Book" pitchFamily="34" charset="0"/>
+                <a:ea typeface="Avenir Book" pitchFamily="34" charset="-122"/>
+                <a:cs typeface="Avenir Book" pitchFamily="34" charset="-120"/>
+              </a:rPr>
+              <a:t>Depression: +24.1 vs +3.5   ·   Anxiety: +17.8 vs −4.0</a:t>
+            </a:r>
+            <a:endParaRPr lang="en-US" sz="1600" dirty="0"/>
+          </a:p>
+        </p:txBody>
+      </p:sp>
+    </p:spTree>
+  </p:cSld>
+  <p:clrMapOvr>
+    <a:masterClrMapping/>
+  </p:clrMapOvr>
+</p:sld>
+</file>
+
+<file path=ppt/slides/slide13.xml><?xml version="1.0" encoding="utf-8"?>
+<p:sld xmlns:a="http://schemas.openxmlformats.org/drawingml/2006/main" xmlns:r="http://schemas.openxmlformats.org/officeDocument/2006/relationships" xmlns:p="http://schemas.openxmlformats.org/presentationml/2006/main">
+  <p:cSld name="Slide 13">
+    <p:bg>
+      <p:bgPr>
+        <a:solidFill>
+          <a:srgbClr val="FFFFFF"/>
+        </a:solidFill>
+      </p:bgPr>
+    </p:bg>
+    <p:spTree>
+      <p:nvGrpSpPr>
+        <p:cNvPr id="1" name=""/>
+        <p:cNvGrpSpPr/>
+        <p:nvPr/>
+      </p:nvGrpSpPr>
+      <p:grpSpPr>
+        <a:xfrm>
+          <a:off x="0" y="0"/>
+          <a:ext cx="0" cy="0"/>
+          <a:chOff x="0" y="0"/>
+          <a:chExt cx="0" cy="0"/>
+        </a:xfrm>
+      </p:grpSpPr>
+      <p:sp>
+        <p:nvSpPr>
+          <p:cNvPr id="3" name="Text 0"/>
+          <p:cNvSpPr txBox="1"/>
+          <p:nvPr/>
+        </p:nvSpPr>
+        <p:spPr>
+          <a:xfrm>
+            <a:off x="548640" y="411480"/>
+            <a:ext cx="8046720" cy="640080"/>
+          </a:xfrm>
+          <a:prstGeom prst="rect">
+            <a:avLst/>
+          </a:prstGeom>
+          <a:noFill/>
+          <a:ln/>
+        </p:spPr>
+        <p:txBody>
+          <a:bodyPr wrap="square" lIns="0" tIns="0" rIns="0" bIns="0" rtlCol="0" anchor="ctr"/>
+          <a:lstStyle/>
+          <a:p>
+            <a:pPr indent="0" marL="0">
+              <a:buNone/>
+            </a:pPr>
+            <a:r>
+              <a:rPr lang="en-US" sz="2800" dirty="0">
+                <a:solidFill>
+                  <a:srgbClr val="000000"/>
+                </a:solidFill>
+                <a:latin typeface="Avenir Book" pitchFamily="34" charset="0"/>
+                <a:ea typeface="Avenir Book" pitchFamily="34" charset="-122"/>
+                <a:cs typeface="Avenir Book" pitchFamily="34" charset="-120"/>
+              </a:rPr>
+              <a:t>Robustness</a:t>
+            </a:r>
+            <a:endParaRPr lang="en-US" sz="2800" dirty="0"/>
+          </a:p>
+        </p:txBody>
+      </p:sp>
+      <p:sp>
+        <p:nvSpPr>
+          <p:cNvPr id="4" name="Text 1"/>
+          <p:cNvSpPr txBox="1"/>
+          <p:nvPr/>
+        </p:nvSpPr>
+        <p:spPr>
+          <a:xfrm>
+            <a:off x="548640" y="1371600"/>
+            <a:ext cx="8046720" cy="3291840"/>
+          </a:xfrm>
+          <a:prstGeom prst="rect">
+            <a:avLst/>
+          </a:prstGeom>
+          <a:noFill/>
+          <a:ln/>
+        </p:spPr>
+        <p:txBody>
+          <a:bodyPr wrap="square" lIns="0" tIns="0" rIns="0" bIns="0" rtlCol="0" anchor="t"/>
+          <a:lstStyle/>
+          <a:p>
+            <a:pPr indent="0" marL="0">
+              <a:spcAft>
+                <a:spcPts val="1400"/>
+              </a:spcAft>
+              <a:buNone/>
+            </a:pPr>
+            <a:r>
+              <a:rPr lang="en-US" sz="2000" dirty="0">
+                <a:solidFill>
+                  <a:srgbClr val="000000"/>
+                </a:solidFill>
+                <a:latin typeface="Avenir Book" pitchFamily="34" charset="0"/>
+                <a:ea typeface="Avenir Book" pitchFamily="34" charset="-122"/>
+                <a:cs typeface="Avenir Book" pitchFamily="34" charset="-120"/>
+              </a:rPr>
+              <a:t>Alternative thresholds (PCL-5≥33, PHQ-9≥15, GAD-7≥7): all p≤0.0002</a:t>
+            </a:r>
+            <a:endParaRPr lang="en-US" sz="2000" dirty="0"/>
+          </a:p>
+          <a:p>
+            <a:pPr indent="0" marL="0">
+              <a:spcAft>
+                <a:spcPts val="1400"/>
+              </a:spcAft>
+              <a:buNone/>
+            </a:pPr>
+            <a:r>
+              <a:rPr lang="en-US" sz="2000" dirty="0">
+                <a:solidFill>
+                  <a:srgbClr val="000000"/>
+                </a:solidFill>
+                <a:latin typeface="Avenir Book" pitchFamily="34" charset="0"/>
+                <a:ea typeface="Avenir Book" pitchFamily="34" charset="-122"/>
+                <a:cs typeface="Avenir Book" pitchFamily="34" charset="-120"/>
+              </a:rPr>
+              <a:t>Continuous symptom scores: all p≤0.0001</a:t>
+            </a:r>
+            <a:endParaRPr lang="en-US" sz="2000" dirty="0"/>
+          </a:p>
+          <a:p>
+            <a:pPr indent="0" marL="0">
+              <a:spcAft>
+                <a:spcPts val="1400"/>
+              </a:spcAft>
+              <a:buNone/>
+            </a:pPr>
+            <a:r>
+              <a:rPr lang="en-US" sz="2000" dirty="0">
+                <a:solidFill>
+                  <a:srgbClr val="000000"/>
+                </a:solidFill>
+                <a:latin typeface="Avenir Book" pitchFamily="34" charset="0"/>
+                <a:ea typeface="Avenir Book" pitchFamily="34" charset="-122"/>
+                <a:cs typeface="Avenir Book" pitchFamily="34" charset="-120"/>
+              </a:rPr>
+              <a:t>Categorical trauma specification: same pattern</a:t>
+            </a:r>
+            <a:endParaRPr lang="en-US" sz="2000" dirty="0"/>
+          </a:p>
+        </p:txBody>
+      </p:sp>
+    </p:spTree>
+  </p:cSld>
+  <p:clrMapOvr>
+    <a:masterClrMapping/>
+  </p:clrMapOvr>
+</p:sld>
+</file>
+
+<file path=ppt/slides/slide14.xml><?xml version="1.0" encoding="utf-8"?>
+<p:sld xmlns:a="http://schemas.openxmlformats.org/drawingml/2006/main" xmlns:r="http://schemas.openxmlformats.org/officeDocument/2006/relationships" xmlns:p="http://schemas.openxmlformats.org/presentationml/2006/main">
+  <p:cSld name="Slide 14">
+    <p:bg>
+      <p:bgPr>
+        <a:solidFill>
+          <a:srgbClr val="FFFFFF"/>
+        </a:solidFill>
+      </p:bgPr>
+    </p:bg>
+    <p:spTree>
+      <p:nvGrpSpPr>
+        <p:cNvPr id="1" name=""/>
+        <p:cNvGrpSpPr/>
+        <p:nvPr/>
+      </p:nvGrpSpPr>
+      <p:grpSpPr>
+        <a:xfrm>
+          <a:off x="0" y="0"/>
+          <a:ext cx="0" cy="0"/>
+          <a:chOff x="0" y="0"/>
+          <a:chExt cx="0" cy="0"/>
+        </a:xfrm>
+      </p:grpSpPr>
+      <p:sp>
+        <p:nvSpPr>
+          <p:cNvPr id="3" name="Text 0"/>
+          <p:cNvSpPr txBox="1"/>
+          <p:nvPr/>
+        </p:nvSpPr>
+        <p:spPr>
+          <a:xfrm>
+            <a:off x="731520" y="2011680"/>
+            <a:ext cx="7680960" cy="1097280"/>
+          </a:xfrm>
+          <a:prstGeom prst="rect">
+            <a:avLst/>
+          </a:prstGeom>
+          <a:noFill/>
+          <a:ln/>
+        </p:spPr>
+        <p:txBody>
+          <a:bodyPr wrap="square" lIns="0" tIns="0" rIns="0" bIns="0" rtlCol="0" anchor="ctr"/>
+          <a:lstStyle/>
+          <a:p>
+            <a:pPr algn="ctr" indent="0" marL="0">
+              <a:buNone/>
+            </a:pPr>
+            <a:r>
+              <a:rPr lang="en-US" sz="3000" dirty="0">
+                <a:solidFill>
+                  <a:srgbClr val="000000"/>
+                </a:solidFill>
+                <a:latin typeface="Avenir Book" pitchFamily="34" charset="0"/>
+                <a:ea typeface="Avenir Book" pitchFamily="34" charset="-122"/>
+                <a:cs typeface="Avenir Book" pitchFamily="34" charset="-120"/>
+              </a:rPr>
+              <a:t>The stress gradient lives among the least trauma-exposed.</a:t>
+            </a:r>
+            <a:endParaRPr lang="en-US" sz="3000" dirty="0"/>
+          </a:p>
+        </p:txBody>
+      </p:sp>
+    </p:spTree>
+  </p:cSld>
+  <p:clrMapOvr>
+    <a:masterClrMapping/>
+  </p:clrMapOvr>
+</p:sld>
+</file>
+
+<file path=ppt/slides/slide15.xml><?xml version="1.0" encoding="utf-8"?>
+<p:sld xmlns:a="http://schemas.openxmlformats.org/drawingml/2006/main" xmlns:r="http://schemas.openxmlformats.org/officeDocument/2006/relationships" xmlns:p="http://schemas.openxmlformats.org/presentationml/2006/main">
+  <p:cSld name="Slide 15">
+    <p:bg>
+      <p:bgPr>
+        <a:solidFill>
+          <a:srgbClr val="FFFFFF"/>
+        </a:solidFill>
+      </p:bgPr>
+    </p:bg>
+    <p:spTree>
+      <p:nvGrpSpPr>
+        <p:cNvPr id="1" name=""/>
+        <p:cNvGrpSpPr/>
+        <p:nvPr/>
+      </p:nvGrpSpPr>
+      <p:grpSpPr>
+        <a:xfrm>
+          <a:off x="0" y="0"/>
+          <a:ext cx="0" cy="0"/>
+          <a:chOff x="0" y="0"/>
+          <a:chExt cx="0" cy="0"/>
+        </a:xfrm>
+      </p:grpSpPr>
+      <p:sp>
+        <p:nvSpPr>
+          <p:cNvPr id="3" name="Text 0"/>
+          <p:cNvSpPr txBox="1"/>
+          <p:nvPr/>
+        </p:nvSpPr>
+        <p:spPr>
+          <a:xfrm>
+            <a:off x="3108960" y="1463040"/>
+            <a:ext cx="3657600" cy="2377440"/>
+          </a:xfrm>
+          <a:prstGeom prst="rect">
+            <a:avLst/>
+          </a:prstGeom>
+          <a:noFill/>
+          <a:ln/>
+        </p:spPr>
+        <p:txBody>
+          <a:bodyPr wrap="square" lIns="0" tIns="0" rIns="0" bIns="0" rtlCol="0" anchor="ctr"/>
+          <a:lstStyle/>
+          <a:p>
+            <a:pPr indent="0" marL="0">
+              <a:spcAft>
+                <a:spcPts val="1800"/>
+              </a:spcAft>
+              <a:buNone/>
+            </a:pPr>
+            <a:r>
+              <a:rPr lang="en-US" sz="2400" dirty="0">
+                <a:solidFill>
+                  <a:srgbClr val="000000"/>
+                </a:solidFill>
+                <a:latin typeface="Avenir Book" pitchFamily="34" charset="0"/>
+                <a:ea typeface="Avenir Book" pitchFamily="34" charset="-122"/>
+                <a:cs typeface="Avenir Book" pitchFamily="34" charset="-120"/>
+              </a:rPr>
+              <a:t>1. Background</a:t>
+            </a:r>
+            <a:endParaRPr lang="en-US" sz="2400" dirty="0"/>
+          </a:p>
+          <a:p>
+            <a:pPr indent="0" marL="0">
+              <a:spcAft>
+                <a:spcPts val="1800"/>
+              </a:spcAft>
+              <a:buNone/>
+            </a:pPr>
+            <a:r>
+              <a:rPr lang="en-US" sz="2400" dirty="0">
+                <a:solidFill>
+                  <a:srgbClr val="000000"/>
+                </a:solidFill>
+                <a:latin typeface="Avenir Book" pitchFamily="34" charset="0"/>
+                <a:ea typeface="Avenir Book" pitchFamily="34" charset="-122"/>
+                <a:cs typeface="Avenir Book" pitchFamily="34" charset="-120"/>
+              </a:rPr>
+              <a:t>2. Methods</a:t>
+            </a:r>
+            <a:endParaRPr lang="en-US" sz="2400" dirty="0"/>
+          </a:p>
+          <a:p>
+            <a:pPr indent="0" marL="0">
+              <a:spcAft>
+                <a:spcPts val="1800"/>
+              </a:spcAft>
+              <a:buNone/>
+            </a:pPr>
+            <a:r>
+              <a:rPr lang="en-US" sz="2400" dirty="0">
+                <a:solidFill>
+                  <a:srgbClr val="000000"/>
+                </a:solidFill>
+                <a:latin typeface="Avenir Book" pitchFamily="34" charset="0"/>
+                <a:ea typeface="Avenir Book" pitchFamily="34" charset="-122"/>
+                <a:cs typeface="Avenir Book" pitchFamily="34" charset="-120"/>
+              </a:rPr>
+              <a:t>3. Results</a:t>
+            </a:r>
+            <a:endParaRPr lang="en-US" sz="2400" dirty="0"/>
+          </a:p>
+          <a:p>
+            <a:pPr indent="0" marL="0">
+              <a:spcAft>
+                <a:spcPts val="1800"/>
+              </a:spcAft>
+              <a:buNone/>
+            </a:pPr>
+            <a:r>
+              <a:rPr lang="en-US" sz="2400" dirty="0">
+                <a:solidFill>
+                  <a:srgbClr val="FF0000"/>
+                </a:solidFill>
+                <a:latin typeface="Avenir Book" pitchFamily="34" charset="0"/>
+                <a:ea typeface="Avenir Book" pitchFamily="34" charset="-122"/>
+                <a:cs typeface="Avenir Book" pitchFamily="34" charset="-120"/>
+              </a:rPr>
+              <a:t>4. Discussion</a:t>
+            </a:r>
+            <a:endParaRPr lang="en-US" sz="2400" dirty="0"/>
+          </a:p>
+        </p:txBody>
+      </p:sp>
+    </p:spTree>
+  </p:cSld>
+  <p:clrMapOvr>
+    <a:masterClrMapping/>
+  </p:clrMapOvr>
+</p:sld>
+</file>
+
+<file path=ppt/slides/slide16.xml><?xml version="1.0" encoding="utf-8"?>
+<p:sld xmlns:a="http://schemas.openxmlformats.org/drawingml/2006/main" xmlns:r="http://schemas.openxmlformats.org/officeDocument/2006/relationships" xmlns:p="http://schemas.openxmlformats.org/presentationml/2006/main">
+  <p:cSld name="Slide 16">
+    <p:bg>
+      <p:bgPr>
+        <a:solidFill>
+          <a:srgbClr val="FFFFFF"/>
+        </a:solidFill>
+      </p:bgPr>
+    </p:bg>
+    <p:spTree>
+      <p:nvGrpSpPr>
+        <p:cNvPr id="1" name=""/>
+        <p:cNvGrpSpPr/>
+        <p:nvPr/>
+      </p:nvGrpSpPr>
+      <p:grpSpPr>
+        <a:xfrm>
+          <a:off x="0" y="0"/>
+          <a:ext cx="0" cy="0"/>
+          <a:chOff x="0" y="0"/>
+          <a:chExt cx="0" cy="0"/>
+        </a:xfrm>
+      </p:grpSpPr>
+      <p:sp>
+        <p:nvSpPr>
+          <p:cNvPr id="3" name="Text 0"/>
+          <p:cNvSpPr txBox="1"/>
+          <p:nvPr/>
+        </p:nvSpPr>
+        <p:spPr>
+          <a:xfrm>
+            <a:off x="548640" y="411480"/>
+            <a:ext cx="8046720" cy="640080"/>
+          </a:xfrm>
+          <a:prstGeom prst="rect">
+            <a:avLst/>
+          </a:prstGeom>
+          <a:noFill/>
+          <a:ln/>
+        </p:spPr>
+        <p:txBody>
+          <a:bodyPr wrap="square" lIns="0" tIns="0" rIns="0" bIns="0" rtlCol="0" anchor="ctr"/>
+          <a:lstStyle/>
+          <a:p>
+            <a:pPr indent="0" marL="0">
+              <a:buNone/>
+            </a:pPr>
+            <a:r>
+              <a:rPr lang="en-US" sz="2800" dirty="0">
+                <a:solidFill>
+                  <a:srgbClr val="000000"/>
+                </a:solidFill>
+                <a:latin typeface="Avenir Book" pitchFamily="34" charset="0"/>
+                <a:ea typeface="Avenir Book" pitchFamily="34" charset="-122"/>
+                <a:cs typeface="Avenir Book" pitchFamily="34" charset="-120"/>
+              </a:rPr>
+              <a:t>What this means</a:t>
+            </a:r>
+            <a:endParaRPr lang="en-US" sz="2800" dirty="0"/>
+          </a:p>
+        </p:txBody>
+      </p:sp>
+      <p:sp>
+        <p:nvSpPr>
+          <p:cNvPr id="4" name="Text 1"/>
+          <p:cNvSpPr txBox="1"/>
+          <p:nvPr/>
+        </p:nvSpPr>
+        <p:spPr>
+          <a:xfrm>
+            <a:off x="548640" y="1371600"/>
+            <a:ext cx="8046720" cy="3291840"/>
+          </a:xfrm>
+          <a:prstGeom prst="rect">
+            <a:avLst/>
+          </a:prstGeom>
+          <a:noFill/>
+          <a:ln/>
+        </p:spPr>
+        <p:txBody>
+          <a:bodyPr wrap="square" lIns="0" tIns="0" rIns="0" bIns="0" rtlCol="0" anchor="t"/>
+          <a:lstStyle/>
+          <a:p>
+            <a:pPr indent="0" marL="0">
+              <a:spcAft>
+                <a:spcPts val="1400"/>
+              </a:spcAft>
+              <a:buNone/>
+            </a:pPr>
+            <a:r>
+              <a:rPr lang="en-US" sz="2000" dirty="0">
+                <a:solidFill>
+                  <a:srgbClr val="000000"/>
+                </a:solidFill>
+                <a:latin typeface="Avenir Book" pitchFamily="34" charset="0"/>
+                <a:ea typeface="Avenir Book" pitchFamily="34" charset="-122"/>
+                <a:cs typeface="Avenir Book" pitchFamily="34" charset="-120"/>
+              </a:rPr>
+              <a:t>Match intervention to trauma history, not one program for all</a:t>
+            </a:r>
+            <a:endParaRPr lang="en-US" sz="2000" dirty="0"/>
+          </a:p>
+          <a:p>
+            <a:pPr indent="0" marL="0">
+              <a:spcAft>
+                <a:spcPts val="1400"/>
+              </a:spcAft>
+              <a:buNone/>
+            </a:pPr>
+            <a:r>
+              <a:rPr lang="en-US" sz="2000" dirty="0">
+                <a:solidFill>
+                  <a:srgbClr val="000000"/>
+                </a:solidFill>
+                <a:latin typeface="Avenir Book" pitchFamily="34" charset="0"/>
+                <a:ea typeface="Avenir Book" pitchFamily="34" charset="-122"/>
+                <a:cs typeface="Avenir Book" pitchFamily="34" charset="-120"/>
+              </a:rPr>
+              <a:t>Stress-focused support where sensitivity is retained</a:t>
+            </a:r>
+            <a:endParaRPr lang="en-US" sz="2000" dirty="0"/>
+          </a:p>
+          <a:p>
+            <a:pPr indent="0" marL="0">
+              <a:spcAft>
+                <a:spcPts val="1400"/>
+              </a:spcAft>
+              <a:buNone/>
+            </a:pPr>
+            <a:r>
+              <a:rPr lang="en-US" sz="2000" dirty="0">
+                <a:solidFill>
+                  <a:srgbClr val="000000"/>
+                </a:solidFill>
+                <a:latin typeface="Avenir Book" pitchFamily="34" charset="0"/>
+                <a:ea typeface="Avenir Book" pitchFamily="34" charset="-122"/>
+                <a:cs typeface="Avenir Book" pitchFamily="34" charset="-120"/>
+              </a:rPr>
+              <a:t>Trauma-focused therapies where exposure is extensive</a:t>
+            </a:r>
+            <a:endParaRPr lang="en-US" sz="2000" dirty="0"/>
+          </a:p>
+          <a:p>
+            <a:pPr indent="0" marL="0">
+              <a:spcAft>
+                <a:spcPts val="200"/>
+              </a:spcAft>
+              <a:buNone/>
+            </a:pPr>
+            <a:r>
+              <a:rPr lang="en-US" sz="2000" dirty="0">
+                <a:solidFill>
+                  <a:srgbClr val="000000"/>
+                </a:solidFill>
+                <a:latin typeface="Avenir Book" pitchFamily="34" charset="0"/>
+                <a:ea typeface="Avenir Book" pitchFamily="34" charset="-122"/>
+                <a:cs typeface="Avenir Book" pitchFamily="34" charset="-120"/>
+              </a:rPr>
+              <a:t>Limits: cross-sectional; recall; sparse data above six events</a:t>
+            </a:r>
+            <a:endParaRPr lang="en-US" sz="2000" dirty="0"/>
+          </a:p>
+        </p:txBody>
+      </p:sp>
+    </p:spTree>
+  </p:cSld>
+  <p:clrMapOvr>
+    <a:masterClrMapping/>
+  </p:clrMapOvr>
+</p:sld>
+</file>
+
+<file path=ppt/slides/slide17.xml><?xml version="1.0" encoding="utf-8"?>
+<p:sld xmlns:a="http://schemas.openxmlformats.org/drawingml/2006/main" xmlns:r="http://schemas.openxmlformats.org/officeDocument/2006/relationships" xmlns:p="http://schemas.openxmlformats.org/presentationml/2006/main">
+  <p:cSld name="Slide 17">
+    <p:bg>
+      <p:bgPr>
+        <a:solidFill>
+          <a:srgbClr val="FFFFFF"/>
+        </a:solidFill>
+      </p:bgPr>
+    </p:bg>
+    <p:spTree>
+      <p:nvGrpSpPr>
+        <p:cNvPr id="1" name=""/>
+        <p:cNvGrpSpPr/>
+        <p:nvPr/>
+      </p:nvGrpSpPr>
+      <p:grpSpPr>
+        <a:xfrm>
+          <a:off x="0" y="0"/>
+          <a:ext cx="0" cy="0"/>
+          <a:chOff x="0" y="0"/>
+          <a:chExt cx="0" cy="0"/>
+        </a:xfrm>
+      </p:grpSpPr>
+      <p:sp>
+        <p:nvSpPr>
+          <p:cNvPr id="3" name="Text 0"/>
+          <p:cNvSpPr txBox="1"/>
+          <p:nvPr/>
+        </p:nvSpPr>
+        <p:spPr>
+          <a:xfrm>
+            <a:off x="731520" y="2286000"/>
+            <a:ext cx="7680960" cy="548640"/>
+          </a:xfrm>
+          <a:prstGeom prst="rect">
+            <a:avLst/>
+          </a:prstGeom>
+          <a:noFill/>
+          <a:ln/>
+        </p:spPr>
+        <p:txBody>
+          <a:bodyPr wrap="square" lIns="0" tIns="0" rIns="0" bIns="0" rtlCol="0" anchor="ctr"/>
+          <a:lstStyle/>
+          <a:p>
+            <a:pPr algn="ctr" indent="0" marL="0">
+              <a:buNone/>
+            </a:pPr>
+            <a:r>
+              <a:rPr lang="en-US" sz="2200" dirty="0">
+                <a:solidFill>
+                  <a:srgbClr val="000000"/>
+                </a:solidFill>
+                <a:latin typeface="Avenir Book" pitchFamily="34" charset="0"/>
+                <a:ea typeface="Avenir Book" pitchFamily="34" charset="-122"/>
+                <a:cs typeface="Avenir Book" pitchFamily="34" charset="-120"/>
+              </a:rPr>
+              <a:t>[your preferred email]</a:t>
+            </a:r>
+            <a:endParaRPr lang="en-US" sz="2200" dirty="0"/>
+          </a:p>
+        </p:txBody>
+      </p:sp>
+    </p:spTree>
+  </p:cSld>
+  <p:clrMapOvr>
+    <a:masterClrMapping/>
+  </p:clrMapOvr>
+</p:sld>
+</file>
+
+<file path=ppt/slides/slide2.xml><?xml version="1.0" encoding="utf-8"?>
+<p:sld xmlns:a="http://schemas.openxmlformats.org/drawingml/2006/main" xmlns:r="http://schemas.openxmlformats.org/officeDocument/2006/relationships" xmlns:p="http://schemas.openxmlformats.org/presentationml/2006/main">
+  <p:cSld name="Slide 2">
+    <p:bg>
+      <p:bgPr>
+        <a:solidFill>
+          <a:srgbClr val="FFFFFF"/>
+        </a:solidFill>
+      </p:bgPr>
+    </p:bg>
+    <p:spTree>
+      <p:nvGrpSpPr>
+        <p:cNvPr id="1" name=""/>
+        <p:cNvGrpSpPr/>
+        <p:nvPr/>
+      </p:nvGrpSpPr>
+      <p:grpSpPr>
+        <a:xfrm>
+          <a:off x="0" y="0"/>
+          <a:ext cx="0" cy="0"/>
+          <a:chOff x="0" y="0"/>
+          <a:chExt cx="0" cy="0"/>
+        </a:xfrm>
+      </p:grpSpPr>
+      <p:sp>
+        <p:nvSpPr>
+          <p:cNvPr id="3" name="Text 0"/>
+          <p:cNvSpPr txBox="1"/>
+          <p:nvPr/>
+        </p:nvSpPr>
+        <p:spPr>
+          <a:xfrm>
+            <a:off x="548640" y="411480"/>
+            <a:ext cx="8046720" cy="640080"/>
+          </a:xfrm>
+          <a:prstGeom prst="rect">
+            <a:avLst/>
+          </a:prstGeom>
+          <a:noFill/>
+          <a:ln/>
+        </p:spPr>
+        <p:txBody>
+          <a:bodyPr wrap="square" lIns="0" tIns="0" rIns="0" bIns="0" rtlCol="0" anchor="ctr"/>
+          <a:lstStyle/>
+          <a:p>
+            <a:pPr indent="0" marL="0">
+              <a:buNone/>
+            </a:pPr>
+            <a:r>
+              <a:rPr lang="en-US" sz="2800" dirty="0">
+                <a:solidFill>
+                  <a:srgbClr val="000000"/>
+                </a:solidFill>
+                <a:latin typeface="Avenir Book" pitchFamily="34" charset="0"/>
+                <a:ea typeface="Avenir Book" pitchFamily="34" charset="-122"/>
+                <a:cs typeface="Avenir Book" pitchFamily="34" charset="-120"/>
+              </a:rPr>
+              <a:t>Financial disclosure</a:t>
+            </a:r>
+            <a:endParaRPr lang="en-US" sz="2800" dirty="0"/>
+          </a:p>
+        </p:txBody>
+      </p:sp>
+      <p:sp>
+        <p:nvSpPr>
+          <p:cNvPr id="4" name="Text 1"/>
+          <p:cNvSpPr txBox="1"/>
+          <p:nvPr/>
+        </p:nvSpPr>
+        <p:spPr>
+          <a:xfrm>
+            <a:off x="548640" y="1371600"/>
+            <a:ext cx="8046720" cy="3291840"/>
+          </a:xfrm>
+          <a:prstGeom prst="rect">
+            <a:avLst/>
+          </a:prstGeom>
+          <a:noFill/>
+          <a:ln/>
+        </p:spPr>
+        <p:txBody>
+          <a:bodyPr wrap="square" lIns="0" tIns="0" rIns="0" bIns="0" rtlCol="0" anchor="t"/>
+          <a:lstStyle/>
+          <a:p>
+            <a:pPr indent="0" marL="0">
+              <a:spcAft>
+                <a:spcPts val="1400"/>
+              </a:spcAft>
+              <a:buNone/>
+            </a:pPr>
+            <a:r>
+              <a:rPr lang="en-US" sz="1800" dirty="0">
+                <a:solidFill>
+                  <a:srgbClr val="000000"/>
+                </a:solidFill>
+                <a:latin typeface="Avenir Book" pitchFamily="34" charset="0"/>
+                <a:ea typeface="Avenir Book" pitchFamily="34" charset="-122"/>
+                <a:cs typeface="Avenir Book" pitchFamily="34" charset="-120"/>
+              </a:rPr>
+              <a:t>In the past 24 months, I, Mohammed Abba-Aji, have not had financial relationships with any ineligible companies.</a:t>
+            </a:r>
+            <a:endParaRPr lang="en-US" sz="1800" dirty="0"/>
+          </a:p>
+          <a:p>
+            <a:pPr indent="0" marL="0">
+              <a:spcAft>
+                <a:spcPts val="1400"/>
+              </a:spcAft>
+              <a:buNone/>
+            </a:pPr>
+            <a:r>
+              <a:rPr lang="en-US" sz="1800" dirty="0">
+                <a:solidFill>
+                  <a:srgbClr val="000000"/>
+                </a:solidFill>
+                <a:latin typeface="Avenir Book" pitchFamily="34" charset="0"/>
+                <a:ea typeface="Avenir Book" pitchFamily="34" charset="-122"/>
+                <a:cs typeface="Avenir Book" pitchFamily="34" charset="-120"/>
+              </a:rPr>
+              <a:t>No discussion of unapproved uses of pharmaceuticals or devices.</a:t>
+            </a:r>
+            <a:endParaRPr lang="en-US" sz="1800" dirty="0"/>
+          </a:p>
+        </p:txBody>
+      </p:sp>
+    </p:spTree>
+  </p:cSld>
+  <p:clrMapOvr>
+    <a:masterClrMapping/>
+  </p:clrMapOvr>
+</p:sld>
+</file>
+
+<file path=ppt/slides/slide3.xml><?xml version="1.0" encoding="utf-8"?>
+<p:sld xmlns:a="http://schemas.openxmlformats.org/drawingml/2006/main" xmlns:r="http://schemas.openxmlformats.org/officeDocument/2006/relationships" xmlns:p="http://schemas.openxmlformats.org/presentationml/2006/main">
+  <p:cSld name="Slide 3">
+    <p:bg>
+      <p:bgPr>
+        <a:solidFill>
+          <a:srgbClr val="FFFFFF"/>
+        </a:solidFill>
+      </p:bgPr>
+    </p:bg>
+    <p:spTree>
+      <p:nvGrpSpPr>
+        <p:cNvPr id="1" name=""/>
+        <p:cNvGrpSpPr/>
+        <p:nvPr/>
+      </p:nvGrpSpPr>
+      <p:grpSpPr>
+        <a:xfrm>
+          <a:off x="0" y="0"/>
+          <a:ext cx="0" cy="0"/>
+          <a:chOff x="0" y="0"/>
+          <a:chExt cx="0" cy="0"/>
+        </a:xfrm>
+      </p:grpSpPr>
+      <p:sp>
+        <p:nvSpPr>
+          <p:cNvPr id="3" name="Text 0"/>
+          <p:cNvSpPr txBox="1"/>
+          <p:nvPr/>
+        </p:nvSpPr>
+        <p:spPr>
+          <a:xfrm>
+            <a:off x="3108960" y="1463040"/>
+            <a:ext cx="3657600" cy="2377440"/>
+          </a:xfrm>
+          <a:prstGeom prst="rect">
+            <a:avLst/>
+          </a:prstGeom>
+          <a:noFill/>
+          <a:ln/>
+        </p:spPr>
+        <p:txBody>
+          <a:bodyPr wrap="square" lIns="0" tIns="0" rIns="0" bIns="0" rtlCol="0" anchor="ctr"/>
+          <a:lstStyle/>
+          <a:p>
+            <a:pPr indent="0" marL="0">
+              <a:spcAft>
+                <a:spcPts val="1800"/>
+              </a:spcAft>
+              <a:buNone/>
+            </a:pPr>
+            <a:r>
+              <a:rPr lang="en-US" sz="2400" dirty="0">
+                <a:solidFill>
+                  <a:srgbClr val="FF0000"/>
+                </a:solidFill>
+                <a:latin typeface="Avenir Book" pitchFamily="34" charset="0"/>
+                <a:ea typeface="Avenir Book" pitchFamily="34" charset="-122"/>
+                <a:cs typeface="Avenir Book" pitchFamily="34" charset="-120"/>
+              </a:rPr>
+              <a:t>1. Background</a:t>
+            </a:r>
+            <a:endParaRPr lang="en-US" sz="2400" dirty="0"/>
+          </a:p>
+          <a:p>
+            <a:pPr indent="0" marL="0">
+              <a:spcAft>
+                <a:spcPts val="1800"/>
+              </a:spcAft>
+              <a:buNone/>
+            </a:pPr>
+            <a:r>
+              <a:rPr lang="en-US" sz="2400" dirty="0">
+                <a:solidFill>
+                  <a:srgbClr val="000000"/>
+                </a:solidFill>
+                <a:latin typeface="Avenir Book" pitchFamily="34" charset="0"/>
+                <a:ea typeface="Avenir Book" pitchFamily="34" charset="-122"/>
+                <a:cs typeface="Avenir Book" pitchFamily="34" charset="-120"/>
+              </a:rPr>
+              <a:t>2. Methods</a:t>
+            </a:r>
+            <a:endParaRPr lang="en-US" sz="2400" dirty="0"/>
+          </a:p>
+          <a:p>
+            <a:pPr indent="0" marL="0">
+              <a:spcAft>
+                <a:spcPts val="1800"/>
+              </a:spcAft>
+              <a:buNone/>
+            </a:pPr>
+            <a:r>
+              <a:rPr lang="en-US" sz="2400" dirty="0">
+                <a:solidFill>
+                  <a:srgbClr val="000000"/>
+                </a:solidFill>
+                <a:latin typeface="Avenir Book" pitchFamily="34" charset="0"/>
+                <a:ea typeface="Avenir Book" pitchFamily="34" charset="-122"/>
+                <a:cs typeface="Avenir Book" pitchFamily="34" charset="-120"/>
+              </a:rPr>
+              <a:t>3. Results</a:t>
+            </a:r>
+            <a:endParaRPr lang="en-US" sz="2400" dirty="0"/>
+          </a:p>
+          <a:p>
+            <a:pPr indent="0" marL="0">
+              <a:spcAft>
+                <a:spcPts val="1800"/>
+              </a:spcAft>
+              <a:buNone/>
+            </a:pPr>
+            <a:r>
+              <a:rPr lang="en-US" sz="2400" dirty="0">
+                <a:solidFill>
+                  <a:srgbClr val="000000"/>
+                </a:solidFill>
+                <a:latin typeface="Avenir Book" pitchFamily="34" charset="0"/>
+                <a:ea typeface="Avenir Book" pitchFamily="34" charset="-122"/>
+                <a:cs typeface="Avenir Book" pitchFamily="34" charset="-120"/>
+              </a:rPr>
+              <a:t>4. Discussion</a:t>
+            </a:r>
+            <a:endParaRPr lang="en-US" sz="2400" dirty="0"/>
+          </a:p>
+        </p:txBody>
+      </p:sp>
+    </p:spTree>
+  </p:cSld>
+  <p:clrMapOvr>
+    <a:masterClrMapping/>
+  </p:clrMapOvr>
+</p:sld>
+</file>
+
+<file path=ppt/slides/slide4.xml><?xml version="1.0" encoding="utf-8"?>
+<p:sld xmlns:a="http://schemas.openxmlformats.org/drawingml/2006/main" xmlns:r="http://schemas.openxmlformats.org/officeDocument/2006/relationships" xmlns:p="http://schemas.openxmlformats.org/presentationml/2006/main">
+  <p:cSld name="Slide 4">
+    <p:bg>
+      <p:bgPr>
+        <a:solidFill>
+          <a:srgbClr val="FFFFFF"/>
+        </a:solidFill>
+      </p:bgPr>
+    </p:bg>
+    <p:spTree>
+      <p:nvGrpSpPr>
+        <p:cNvPr id="1" name=""/>
+        <p:cNvGrpSpPr/>
+        <p:nvPr/>
+      </p:nvGrpSpPr>
+      <p:grpSpPr>
+        <a:xfrm>
+          <a:off x="0" y="0"/>
+          <a:ext cx="0" cy="0"/>
+          <a:chOff x="0" y="0"/>
+          <a:chExt cx="0" cy="0"/>
+        </a:xfrm>
+      </p:grpSpPr>
+      <p:sp>
+        <p:nvSpPr>
+          <p:cNvPr id="3" name="Text 0"/>
+          <p:cNvSpPr txBox="1"/>
+          <p:nvPr/>
+        </p:nvSpPr>
+        <p:spPr>
+          <a:xfrm>
+            <a:off x="548640" y="411480"/>
+            <a:ext cx="8046720" cy="640080"/>
+          </a:xfrm>
+          <a:prstGeom prst="rect">
+            <a:avLst/>
+          </a:prstGeom>
+          <a:noFill/>
+          <a:ln/>
+        </p:spPr>
+        <p:txBody>
+          <a:bodyPr wrap="square" lIns="0" tIns="0" rIns="0" bIns="0" rtlCol="0" anchor="ctr"/>
+          <a:lstStyle/>
+          <a:p>
+            <a:pPr indent="0" marL="0">
+              <a:buNone/>
+            </a:pPr>
+            <a:r>
+              <a:rPr lang="en-US" sz="2800" dirty="0">
+                <a:solidFill>
+                  <a:srgbClr val="000000"/>
+                </a:solidFill>
+                <a:latin typeface="Avenir Book" pitchFamily="34" charset="0"/>
+                <a:ea typeface="Avenir Book" pitchFamily="34" charset="-122"/>
+                <a:cs typeface="Avenir Book" pitchFamily="34" charset="-120"/>
+              </a:rPr>
+              <a:t>Two views of trauma and daily stress</a:t>
+            </a:r>
+            <a:endParaRPr lang="en-US" sz="2800" dirty="0"/>
+          </a:p>
+        </p:txBody>
+      </p:sp>
+      <p:sp>
+        <p:nvSpPr>
+          <p:cNvPr id="4" name="Text 1"/>
+          <p:cNvSpPr txBox="1"/>
+          <p:nvPr/>
+        </p:nvSpPr>
+        <p:spPr>
+          <a:xfrm>
+            <a:off x="548640" y="1371600"/>
+            <a:ext cx="8046720" cy="3291840"/>
+          </a:xfrm>
+          <a:prstGeom prst="rect">
+            <a:avLst/>
+          </a:prstGeom>
+          <a:noFill/>
+          <a:ln/>
+        </p:spPr>
+        <p:txBody>
+          <a:bodyPr wrap="square" lIns="0" tIns="0" rIns="0" bIns="0" rtlCol="0" anchor="t"/>
+          <a:lstStyle/>
+          <a:p>
+            <a:pPr indent="0" marL="0">
+              <a:spcAft>
+                <a:spcPts val="1400"/>
+              </a:spcAft>
+              <a:buNone/>
+            </a:pPr>
+            <a:r>
+              <a:rPr lang="en-US" sz="2000" dirty="0">
+                <a:solidFill>
+                  <a:srgbClr val="000000"/>
+                </a:solidFill>
+                <a:latin typeface="Avenir Book" pitchFamily="34" charset="0"/>
+                <a:ea typeface="Avenir Book" pitchFamily="34" charset="-122"/>
+                <a:cs typeface="Avenir Book" pitchFamily="34" charset="-120"/>
+              </a:rPr>
+              <a:t>Additive: each stressor adds the same risk to everyone</a:t>
+            </a:r>
+            <a:endParaRPr lang="en-US" sz="2000" dirty="0"/>
+          </a:p>
+          <a:p>
+            <a:pPr indent="0" marL="0">
+              <a:spcAft>
+                <a:spcPts val="1400"/>
+              </a:spcAft>
+              <a:buNone/>
+            </a:pPr>
+            <a:r>
+              <a:rPr lang="en-US" sz="2000" dirty="0">
+                <a:solidFill>
+                  <a:srgbClr val="000000"/>
+                </a:solidFill>
+                <a:latin typeface="Avenir Book" pitchFamily="34" charset="0"/>
+                <a:ea typeface="Avenir Book" pitchFamily="34" charset="-122"/>
+                <a:cs typeface="Avenir Book" pitchFamily="34" charset="-120"/>
+              </a:rPr>
+              <a:t>Effect modification: trauma changes stress sensitivity itself</a:t>
+            </a:r>
+            <a:endParaRPr lang="en-US" sz="2000" dirty="0"/>
+          </a:p>
+          <a:p>
+            <a:pPr indent="0" marL="0">
+              <a:spcAft>
+                <a:spcPts val="1400"/>
+              </a:spcAft>
+              <a:buNone/>
+            </a:pPr>
+            <a:r>
+              <a:rPr lang="en-US" sz="2000" dirty="0">
+                <a:solidFill>
+                  <a:srgbClr val="000000"/>
+                </a:solidFill>
+                <a:latin typeface="Avenir Book" pitchFamily="34" charset="0"/>
+                <a:ea typeface="Avenir Book" pitchFamily="34" charset="-122"/>
+                <a:cs typeface="Avenir Book" pitchFamily="34" charset="-120"/>
+              </a:rPr>
+              <a:t>Conflict settings make these predictions diverge</a:t>
+            </a:r>
+            <a:endParaRPr lang="en-US" sz="2000" dirty="0"/>
+          </a:p>
+          <a:p>
+            <a:pPr indent="0" marL="0">
+              <a:spcAft>
+                <a:spcPts val="1400"/>
+              </a:spcAft>
+              <a:buNone/>
+            </a:pPr>
+            <a:r>
+              <a:rPr lang="en-US" sz="2000" dirty="0">
+                <a:solidFill>
+                  <a:srgbClr val="000000"/>
+                </a:solidFill>
+                <a:latin typeface="Avenir Book" pitchFamily="34" charset="0"/>
+                <a:ea typeface="Avenir Book" pitchFamily="34" charset="-122"/>
+                <a:cs typeface="Avenir Book" pitchFamily="34" charset="-120"/>
+              </a:rPr>
+              <a:t>Nigeria: ~1 in 5 adults with probable PTSD in conflict-affected states</a:t>
+            </a:r>
+            <a:endParaRPr lang="en-US" sz="2000" dirty="0"/>
+          </a:p>
+        </p:txBody>
+      </p:sp>
+    </p:spTree>
+  </p:cSld>
+  <p:clrMapOvr>
+    <a:masterClrMapping/>
+  </p:clrMapOvr>
+</p:sld>
+</file>
+
+<file path=ppt/slides/slide5.xml><?xml version="1.0" encoding="utf-8"?>
+<p:sld xmlns:a="http://schemas.openxmlformats.org/drawingml/2006/main" xmlns:r="http://schemas.openxmlformats.org/officeDocument/2006/relationships" xmlns:p="http://schemas.openxmlformats.org/presentationml/2006/main">
+  <p:cSld name="Slide 5">
+    <p:bg>
+      <p:bgPr>
+        <a:solidFill>
+          <a:srgbClr val="FFFFFF"/>
+        </a:solidFill>
+      </p:bgPr>
+    </p:bg>
+    <p:spTree>
+      <p:nvGrpSpPr>
+        <p:cNvPr id="1" name=""/>
+        <p:cNvGrpSpPr/>
+        <p:nvPr/>
+      </p:nvGrpSpPr>
+      <p:grpSpPr>
+        <a:xfrm>
+          <a:off x="0" y="0"/>
+          <a:ext cx="0" cy="0"/>
+          <a:chOff x="0" y="0"/>
+          <a:chExt cx="0" cy="0"/>
+        </a:xfrm>
+      </p:grpSpPr>
+      <p:sp>
+        <p:nvSpPr>
+          <p:cNvPr id="3" name="Text 0"/>
+          <p:cNvSpPr txBox="1"/>
+          <p:nvPr/>
+        </p:nvSpPr>
+        <p:spPr>
+          <a:xfrm>
+            <a:off x="731520" y="2011680"/>
+            <a:ext cx="7680960" cy="1097280"/>
+          </a:xfrm>
+          <a:prstGeom prst="rect">
+            <a:avLst/>
+          </a:prstGeom>
+          <a:noFill/>
+          <a:ln/>
+        </p:spPr>
+        <p:txBody>
+          <a:bodyPr wrap="square" lIns="0" tIns="0" rIns="0" bIns="0" rtlCol="0" anchor="ctr"/>
+          <a:lstStyle/>
+          <a:p>
+            <a:pPr algn="ctr" indent="0" marL="0">
+              <a:buNone/>
+            </a:pPr>
+            <a:r>
+              <a:rPr lang="en-US" sz="3000" dirty="0">
+                <a:solidFill>
+                  <a:srgbClr val="000000"/>
+                </a:solidFill>
+                <a:latin typeface="Avenir Book" pitchFamily="34" charset="0"/>
+                <a:ea typeface="Avenir Book" pitchFamily="34" charset="-122"/>
+                <a:cs typeface="Avenir Book" pitchFamily="34" charset="-120"/>
+              </a:rPr>
+              <a:t>Does trauma change what stress does?</a:t>
+            </a:r>
+            <a:endParaRPr lang="en-US" sz="3000" dirty="0"/>
+          </a:p>
+        </p:txBody>
+      </p:sp>
+    </p:spTree>
+  </p:cSld>
+  <p:clrMapOvr>
+    <a:masterClrMapping/>
+  </p:clrMapOvr>
+</p:sld>
+</file>
+
+<file path=ppt/slides/slide6.xml><?xml version="1.0" encoding="utf-8"?>
+<p:sld xmlns:a="http://schemas.openxmlformats.org/drawingml/2006/main" xmlns:r="http://schemas.openxmlformats.org/officeDocument/2006/relationships" xmlns:p="http://schemas.openxmlformats.org/presentationml/2006/main">
+  <p:cSld name="Slide 6">
+    <p:bg>
+      <p:bgPr>
+        <a:solidFill>
+          <a:srgbClr val="FFFFFF"/>
+        </a:solidFill>
+      </p:bgPr>
+    </p:bg>
+    <p:spTree>
+      <p:nvGrpSpPr>
+        <p:cNvPr id="1" name=""/>
+        <p:cNvGrpSpPr/>
+        <p:nvPr/>
+      </p:nvGrpSpPr>
+      <p:grpSpPr>
+        <a:xfrm>
+          <a:off x="0" y="0"/>
+          <a:ext cx="0" cy="0"/>
+          <a:chOff x="0" y="0"/>
+          <a:chExt cx="0" cy="0"/>
+        </a:xfrm>
+      </p:grpSpPr>
+      <p:sp>
+        <p:nvSpPr>
+          <p:cNvPr id="3" name="Text 0"/>
+          <p:cNvSpPr txBox="1"/>
+          <p:nvPr/>
+        </p:nvSpPr>
+        <p:spPr>
+          <a:xfrm>
+            <a:off x="3108960" y="1463040"/>
+            <a:ext cx="3657600" cy="2377440"/>
+          </a:xfrm>
+          <a:prstGeom prst="rect">
+            <a:avLst/>
+          </a:prstGeom>
+          <a:noFill/>
+          <a:ln/>
+        </p:spPr>
+        <p:txBody>
+          <a:bodyPr wrap="square" lIns="0" tIns="0" rIns="0" bIns="0" rtlCol="0" anchor="ctr"/>
+          <a:lstStyle/>
+          <a:p>
+            <a:pPr indent="0" marL="0">
+              <a:spcAft>
+                <a:spcPts val="1800"/>
+              </a:spcAft>
+              <a:buNone/>
+            </a:pPr>
+            <a:r>
+              <a:rPr lang="en-US" sz="2400" dirty="0">
+                <a:solidFill>
+                  <a:srgbClr val="000000"/>
+                </a:solidFill>
+                <a:latin typeface="Avenir Book" pitchFamily="34" charset="0"/>
+                <a:ea typeface="Avenir Book" pitchFamily="34" charset="-122"/>
+                <a:cs typeface="Avenir Book" pitchFamily="34" charset="-120"/>
+              </a:rPr>
+              <a:t>1. Background</a:t>
+            </a:r>
+            <a:endParaRPr lang="en-US" sz="2400" dirty="0"/>
+          </a:p>
+          <a:p>
+            <a:pPr indent="0" marL="0">
+              <a:spcAft>
+                <a:spcPts val="1800"/>
+              </a:spcAft>
+              <a:buNone/>
+            </a:pPr>
+            <a:r>
+              <a:rPr lang="en-US" sz="2400" dirty="0">
+                <a:solidFill>
+                  <a:srgbClr val="FF0000"/>
+                </a:solidFill>
+                <a:latin typeface="Avenir Book" pitchFamily="34" charset="0"/>
+                <a:ea typeface="Avenir Book" pitchFamily="34" charset="-122"/>
+                <a:cs typeface="Avenir Book" pitchFamily="34" charset="-120"/>
+              </a:rPr>
+              <a:t>2. Methods</a:t>
+            </a:r>
+            <a:endParaRPr lang="en-US" sz="2400" dirty="0"/>
+          </a:p>
+          <a:p>
+            <a:pPr indent="0" marL="0">
+              <a:spcAft>
+                <a:spcPts val="1800"/>
+              </a:spcAft>
+              <a:buNone/>
+            </a:pPr>
+            <a:r>
+              <a:rPr lang="en-US" sz="2400" dirty="0">
+                <a:solidFill>
+                  <a:srgbClr val="000000"/>
+                </a:solidFill>
+                <a:latin typeface="Avenir Book" pitchFamily="34" charset="0"/>
+                <a:ea typeface="Avenir Book" pitchFamily="34" charset="-122"/>
+                <a:cs typeface="Avenir Book" pitchFamily="34" charset="-120"/>
+              </a:rPr>
+              <a:t>3. Results</a:t>
+            </a:r>
+            <a:endParaRPr lang="en-US" sz="2400" dirty="0"/>
+          </a:p>
+          <a:p>
+            <a:pPr indent="0" marL="0">
+              <a:spcAft>
+                <a:spcPts val="1800"/>
+              </a:spcAft>
+              <a:buNone/>
+            </a:pPr>
+            <a:r>
+              <a:rPr lang="en-US" sz="2400" dirty="0">
+                <a:solidFill>
+                  <a:srgbClr val="000000"/>
+                </a:solidFill>
+                <a:latin typeface="Avenir Book" pitchFamily="34" charset="0"/>
+                <a:ea typeface="Avenir Book" pitchFamily="34" charset="-122"/>
+                <a:cs typeface="Avenir Book" pitchFamily="34" charset="-120"/>
+              </a:rPr>
+              <a:t>4. Discussion</a:t>
+            </a:r>
+            <a:endParaRPr lang="en-US" sz="2400" dirty="0"/>
+          </a:p>
+        </p:txBody>
+      </p:sp>
+    </p:spTree>
+  </p:cSld>
+  <p:clrMapOvr>
+    <a:masterClrMapping/>
+  </p:clrMapOvr>
+</p:sld>
+</file>
+
+<file path=ppt/slides/slide7.xml><?xml version="1.0" encoding="utf-8"?>
+<p:sld xmlns:a="http://schemas.openxmlformats.org/drawingml/2006/main" xmlns:r="http://schemas.openxmlformats.org/officeDocument/2006/relationships" xmlns:p="http://schemas.openxmlformats.org/presentationml/2006/main">
+  <p:cSld name="Slide 7">
+    <p:bg>
+      <p:bgPr>
+        <a:solidFill>
+          <a:srgbClr val="FFFFFF"/>
+        </a:solidFill>
+      </p:bgPr>
+    </p:bg>
+    <p:spTree>
+      <p:nvGrpSpPr>
+        <p:cNvPr id="1" name=""/>
+        <p:cNvGrpSpPr/>
+        <p:nvPr/>
+      </p:nvGrpSpPr>
+      <p:grpSpPr>
+        <a:xfrm>
+          <a:off x="0" y="0"/>
+          <a:ext cx="0" cy="0"/>
+          <a:chOff x="0" y="0"/>
+          <a:chExt cx="0" cy="0"/>
+        </a:xfrm>
+      </p:grpSpPr>
+      <p:sp>
+        <p:nvSpPr>
+          <p:cNvPr id="3" name="Text 0"/>
+          <p:cNvSpPr txBox="1"/>
+          <p:nvPr/>
+        </p:nvSpPr>
+        <p:spPr>
+          <a:xfrm>
+            <a:off x="548640" y="411480"/>
+            <a:ext cx="8046720" cy="640080"/>
+          </a:xfrm>
+          <a:prstGeom prst="rect">
+            <a:avLst/>
+          </a:prstGeom>
+          <a:noFill/>
+          <a:ln/>
+        </p:spPr>
+        <p:txBody>
+          <a:bodyPr wrap="square" lIns="0" tIns="0" rIns="0" bIns="0" rtlCol="0" anchor="ctr"/>
+          <a:lstStyle/>
+          <a:p>
+            <a:pPr indent="0" marL="0">
+              <a:buNone/>
+            </a:pPr>
+            <a:r>
+              <a:rPr lang="en-US" sz="2800" dirty="0">
+                <a:solidFill>
+                  <a:srgbClr val="000000"/>
+                </a:solidFill>
+                <a:latin typeface="Avenir Book" pitchFamily="34" charset="0"/>
+                <a:ea typeface="Avenir Book" pitchFamily="34" charset="-122"/>
+                <a:cs typeface="Avenir Book" pitchFamily="34" charset="-120"/>
+              </a:rPr>
+              <a:t>Sample</a:t>
+            </a:r>
+            <a:endParaRPr lang="en-US" sz="2800" dirty="0"/>
+          </a:p>
+        </p:txBody>
+      </p:sp>
+      <p:sp>
+        <p:nvSpPr>
+          <p:cNvPr id="4" name="Text 1"/>
+          <p:cNvSpPr txBox="1"/>
+          <p:nvPr/>
+        </p:nvSpPr>
+        <p:spPr>
+          <a:xfrm>
+            <a:off x="548640" y="1371600"/>
+            <a:ext cx="8046720" cy="3291840"/>
+          </a:xfrm>
+          <a:prstGeom prst="rect">
+            <a:avLst/>
+          </a:prstGeom>
+          <a:noFill/>
+          <a:ln/>
+        </p:spPr>
+        <p:txBody>
+          <a:bodyPr wrap="square" lIns="0" tIns="0" rIns="0" bIns="0" rtlCol="0" anchor="t"/>
+          <a:lstStyle/>
+          <a:p>
+            <a:pPr indent="0" marL="0">
+              <a:spcAft>
+                <a:spcPts val="1400"/>
+              </a:spcAft>
+              <a:buNone/>
+            </a:pPr>
+            <a:r>
+              <a:rPr lang="en-US" sz="2000" dirty="0">
+                <a:solidFill>
+                  <a:srgbClr val="000000"/>
+                </a:solidFill>
+                <a:latin typeface="Avenir Book" pitchFamily="34" charset="0"/>
+                <a:ea typeface="Avenir Book" pitchFamily="34" charset="-122"/>
+                <a:cs typeface="Avenir Book" pitchFamily="34" charset="-120"/>
+              </a:rPr>
+              <a:t>1,729 adults, January–March 2024</a:t>
+            </a:r>
+            <a:endParaRPr lang="en-US" sz="2000" dirty="0"/>
+          </a:p>
+          <a:p>
+            <a:pPr indent="0" marL="0">
+              <a:spcAft>
+                <a:spcPts val="1400"/>
+              </a:spcAft>
+              <a:buNone/>
+            </a:pPr>
+            <a:r>
+              <a:rPr lang="en-US" sz="2000" dirty="0">
+                <a:solidFill>
+                  <a:srgbClr val="000000"/>
+                </a:solidFill>
+                <a:latin typeface="Avenir Book" pitchFamily="34" charset="0"/>
+                <a:ea typeface="Avenir Book" pitchFamily="34" charset="-122"/>
+                <a:cs typeface="Avenir Book" pitchFamily="34" charset="-120"/>
+              </a:rPr>
+              <a:t>Five conflict-affected states + Ogun (non-conflict comparison)</a:t>
+            </a:r>
+            <a:endParaRPr lang="en-US" sz="2000" dirty="0"/>
+          </a:p>
+          <a:p>
+            <a:pPr indent="0" marL="0">
+              <a:spcAft>
+                <a:spcPts val="1400"/>
+              </a:spcAft>
+              <a:buNone/>
+            </a:pPr>
+            <a:r>
+              <a:rPr lang="en-US" sz="2000" dirty="0">
+                <a:solidFill>
+                  <a:srgbClr val="000000"/>
+                </a:solidFill>
+                <a:latin typeface="Avenir Book" pitchFamily="34" charset="0"/>
+                <a:ea typeface="Avenir Book" pitchFamily="34" charset="-122"/>
+                <a:cs typeface="Avenir Book" pitchFamily="34" charset="-120"/>
+              </a:rPr>
+              <a:t>Stratified multi-stage cluster design; 572 communities</a:t>
+            </a:r>
+            <a:endParaRPr lang="en-US" sz="2000" dirty="0"/>
+          </a:p>
+          <a:p>
+            <a:pPr indent="0" marL="0">
+              <a:spcAft>
+                <a:spcPts val="1400"/>
+              </a:spcAft>
+              <a:buNone/>
+            </a:pPr>
+            <a:r>
+              <a:rPr lang="en-US" sz="2000" dirty="0">
+                <a:solidFill>
+                  <a:srgbClr val="000000"/>
+                </a:solidFill>
+                <a:latin typeface="Avenir Book" pitchFamily="34" charset="0"/>
+                <a:ea typeface="Avenir Book" pitchFamily="34" charset="-122"/>
+                <a:cs typeface="Avenir Book" pitchFamily="34" charset="-120"/>
+              </a:rPr>
+              <a:t>Community and displacement-camp settings</a:t>
+            </a:r>
+            <a:endParaRPr lang="en-US" sz="2000" dirty="0"/>
+          </a:p>
+        </p:txBody>
+      </p:sp>
+    </p:spTree>
+  </p:cSld>
+  <p:clrMapOvr>
+    <a:masterClrMapping/>
+  </p:clrMapOvr>
+</p:sld>
+</file>
+
+<file path=ppt/slides/slide8.xml><?xml version="1.0" encoding="utf-8"?>
+<p:sld xmlns:a="http://schemas.openxmlformats.org/drawingml/2006/main" xmlns:r="http://schemas.openxmlformats.org/officeDocument/2006/relationships" xmlns:p="http://schemas.openxmlformats.org/presentationml/2006/main">
+  <p:cSld name="Slide 8">
+    <p:bg>
+      <p:bgPr>
+        <a:solidFill>
+          <a:srgbClr val="FFFFFF"/>
+        </a:solidFill>
+      </p:bgPr>
+    </p:bg>
+    <p:spTree>
+      <p:nvGrpSpPr>
+        <p:cNvPr id="1" name=""/>
+        <p:cNvGrpSpPr/>
+        <p:nvPr/>
+      </p:nvGrpSpPr>
+      <p:grpSpPr>
+        <a:xfrm>
+          <a:off x="0" y="0"/>
+          <a:ext cx="0" cy="0"/>
+          <a:chOff x="0" y="0"/>
+          <a:chExt cx="0" cy="0"/>
+        </a:xfrm>
+      </p:grpSpPr>
+      <p:sp>
+        <p:nvSpPr>
+          <p:cNvPr id="3" name="Text 0"/>
+          <p:cNvSpPr txBox="1"/>
+          <p:nvPr/>
+        </p:nvSpPr>
+        <p:spPr>
+          <a:xfrm>
+            <a:off x="548640" y="411480"/>
+            <a:ext cx="8046720" cy="640080"/>
+          </a:xfrm>
+          <a:prstGeom prst="rect">
+            <a:avLst/>
+          </a:prstGeom>
+          <a:noFill/>
+          <a:ln/>
+        </p:spPr>
+        <p:txBody>
+          <a:bodyPr wrap="square" lIns="0" tIns="0" rIns="0" bIns="0" rtlCol="0" anchor="ctr"/>
+          <a:lstStyle/>
+          <a:p>
+            <a:pPr indent="0" marL="0">
+              <a:buNone/>
+            </a:pPr>
+            <a:r>
+              <a:rPr lang="en-US" sz="2800" dirty="0">
+                <a:solidFill>
+                  <a:srgbClr val="000000"/>
+                </a:solidFill>
+                <a:latin typeface="Avenir Book" pitchFamily="34" charset="0"/>
+                <a:ea typeface="Avenir Book" pitchFamily="34" charset="-122"/>
+                <a:cs typeface="Avenir Book" pitchFamily="34" charset="-120"/>
+              </a:rPr>
+              <a:t>Measures and model</a:t>
+            </a:r>
+            <a:endParaRPr lang="en-US" sz="2800" dirty="0"/>
+          </a:p>
+        </p:txBody>
+      </p:sp>
+      <p:sp>
+        <p:nvSpPr>
+          <p:cNvPr id="4" name="Text 1"/>
+          <p:cNvSpPr txBox="1"/>
+          <p:nvPr/>
+        </p:nvSpPr>
+        <p:spPr>
+          <a:xfrm>
+            <a:off x="548640" y="1371600"/>
+            <a:ext cx="8046720" cy="3291840"/>
+          </a:xfrm>
+          <a:prstGeom prst="rect">
+            <a:avLst/>
+          </a:prstGeom>
+          <a:noFill/>
+          <a:ln/>
+        </p:spPr>
+        <p:txBody>
+          <a:bodyPr wrap="square" lIns="0" tIns="0" rIns="0" bIns="0" rtlCol="0" anchor="t"/>
+          <a:lstStyle/>
+          <a:p>
+            <a:pPr indent="0" marL="0">
+              <a:spcAft>
+                <a:spcPts val="1400"/>
+              </a:spcAft>
+              <a:buNone/>
+            </a:pPr>
+            <a:r>
+              <a:rPr lang="en-US" sz="1800" dirty="0">
+                <a:solidFill>
+                  <a:srgbClr val="000000"/>
+                </a:solidFill>
+                <a:latin typeface="Avenir Book" pitchFamily="34" charset="0"/>
+                <a:ea typeface="Avenir Book" pitchFamily="34" charset="-122"/>
+                <a:cs typeface="Avenir Book" pitchFamily="34" charset="-120"/>
+              </a:rPr>
+              <a:t>PCL-5 ≥ 38  ·  PHQ-9 ≥ 10  ·  GAD-7 ≥ 10 (locally validated)</a:t>
+            </a:r>
+            <a:endParaRPr lang="en-US" sz="1800" dirty="0"/>
+          </a:p>
+          <a:p>
+            <a:pPr indent="0" marL="0">
+              <a:spcAft>
+                <a:spcPts val="1400"/>
+              </a:spcAft>
+              <a:buNone/>
+            </a:pPr>
+            <a:r>
+              <a:rPr lang="en-US" sz="1800" dirty="0">
+                <a:solidFill>
+                  <a:srgbClr val="000000"/>
+                </a:solidFill>
+                <a:latin typeface="Avenir Book" pitchFamily="34" charset="0"/>
+                <a:ea typeface="Avenir Book" pitchFamily="34" charset="-122"/>
+                <a:cs typeface="Avenir Book" pitchFamily="34" charset="-120"/>
+              </a:rPr>
+              <a:t>Trauma: 0–12 event types, restricted cubic spline</a:t>
+            </a:r>
+            <a:endParaRPr lang="en-US" sz="1800" dirty="0"/>
+          </a:p>
+          <a:p>
+            <a:pPr indent="0" marL="0">
+              <a:spcAft>
+                <a:spcPts val="1400"/>
+              </a:spcAft>
+              <a:buNone/>
+            </a:pPr>
+            <a:r>
+              <a:rPr lang="en-US" sz="1800" dirty="0">
+                <a:solidFill>
+                  <a:srgbClr val="000000"/>
+                </a:solidFill>
+                <a:latin typeface="Avenir Book" pitchFamily="34" charset="0"/>
+                <a:ea typeface="Avenir Book" pitchFamily="34" charset="-122"/>
+                <a:cs typeface="Avenir Book" pitchFamily="34" charset="-120"/>
+              </a:rPr>
+              <a:t>Stressors: socioeconomic challenge count (0–10)</a:t>
+            </a:r>
+            <a:endParaRPr lang="en-US" sz="1800" dirty="0"/>
+          </a:p>
+          <a:p>
+            <a:pPr indent="0" marL="0">
+              <a:spcAft>
+                <a:spcPts val="1400"/>
+              </a:spcAft>
+              <a:buNone/>
+            </a:pPr>
+            <a:r>
+              <a:rPr lang="en-US" sz="1800" dirty="0">
+                <a:solidFill>
+                  <a:srgbClr val="000000"/>
+                </a:solidFill>
+                <a:latin typeface="Avenir Book" pitchFamily="34" charset="0"/>
+                <a:ea typeface="Avenir Book" pitchFamily="34" charset="-122"/>
+                <a:cs typeface="Avenir Book" pitchFamily="34" charset="-120"/>
+              </a:rPr>
+              <a:t>Poisson prevalence ratios; adjusted; design-based variances</a:t>
+            </a:r>
+            <a:endParaRPr lang="en-US" sz="1800" dirty="0"/>
+          </a:p>
+          <a:p>
+            <a:pPr indent="0" marL="0">
+              <a:spcAft>
+                <a:spcPts val="1400"/>
+              </a:spcAft>
+              <a:buNone/>
+            </a:pPr>
+            <a:r>
+              <a:rPr lang="en-US" sz="1800" dirty="0">
+                <a:solidFill>
+                  <a:srgbClr val="000000"/>
+                </a:solidFill>
+                <a:latin typeface="Avenir Book" pitchFamily="34" charset="0"/>
+                <a:ea typeface="Avenir Book" pitchFamily="34" charset="-122"/>
+                <a:cs typeface="Avenir Book" pitchFamily="34" charset="-120"/>
+              </a:rPr>
+              <a:t>Test: trauma × stressor interaction, both scales</a:t>
+            </a:r>
+            <a:endParaRPr lang="en-US" sz="1800" dirty="0"/>
+          </a:p>
+        </p:txBody>
+      </p:sp>
+    </p:spTree>
+  </p:cSld>
+  <p:clrMapOvr>
+    <a:masterClrMapping/>
+  </p:clrMapOvr>
+</p:sld>
+</file>
+
+<file path=ppt/slides/slide9.xml><?xml version="1.0" encoding="utf-8"?>
+<p:sld xmlns:a="http://schemas.openxmlformats.org/drawingml/2006/main" xmlns:r="http://schemas.openxmlformats.org/officeDocument/2006/relationships" xmlns:p="http://schemas.openxmlformats.org/presentationml/2006/main">
+  <p:cSld name="Slide 9">
+    <p:bg>
+      <p:bgPr>
+        <a:solidFill>
+          <a:srgbClr val="FFFFFF"/>
+        </a:solidFill>
+      </p:bgPr>
+    </p:bg>
+    <p:spTree>
+      <p:nvGrpSpPr>
+        <p:cNvPr id="1" name=""/>
+        <p:cNvGrpSpPr/>
+        <p:nvPr/>
+      </p:nvGrpSpPr>
+      <p:grpSpPr>
+        <a:xfrm>
+          <a:off x="0" y="0"/>
+          <a:ext cx="0" cy="0"/>
+          <a:chOff x="0" y="0"/>
+          <a:chExt cx="0" cy="0"/>
+        </a:xfrm>
+      </p:grpSpPr>
+      <p:sp>
+        <p:nvSpPr>
+          <p:cNvPr id="3" name="Text 0"/>
+          <p:cNvSpPr txBox="1"/>
+          <p:nvPr/>
+        </p:nvSpPr>
+        <p:spPr>
+          <a:xfrm>
+            <a:off x="3108960" y="1463040"/>
+            <a:ext cx="3657600" cy="2377440"/>
+          </a:xfrm>
+          <a:prstGeom prst="rect">
+            <a:avLst/>
+          </a:prstGeom>
+          <a:noFill/>
+          <a:ln/>
+        </p:spPr>
+        <p:txBody>
+          <a:bodyPr wrap="square" lIns="0" tIns="0" rIns="0" bIns="0" rtlCol="0" anchor="ctr"/>
+          <a:lstStyle/>
+          <a:p>
+            <a:pPr indent="0" marL="0">
+              <a:spcAft>
+                <a:spcPts val="1800"/>
+              </a:spcAft>
+              <a:buNone/>
+            </a:pPr>
+            <a:r>
+              <a:rPr lang="en-US" sz="2400" dirty="0">
+                <a:solidFill>
+                  <a:srgbClr val="000000"/>
+                </a:solidFill>
+                <a:latin typeface="Avenir Book" pitchFamily="34" charset="0"/>
+                <a:ea typeface="Avenir Book" pitchFamily="34" charset="-122"/>
+                <a:cs typeface="Avenir Book" pitchFamily="34" charset="-120"/>
+              </a:rPr>
+              <a:t>1. Background</a:t>
+            </a:r>
+            <a:endParaRPr lang="en-US" sz="2400" dirty="0"/>
+          </a:p>
+          <a:p>
+            <a:pPr indent="0" marL="0">
+              <a:spcAft>
+                <a:spcPts val="1800"/>
+              </a:spcAft>
+              <a:buNone/>
+            </a:pPr>
+            <a:r>
+              <a:rPr lang="en-US" sz="2400" dirty="0">
+                <a:solidFill>
+                  <a:srgbClr val="000000"/>
+                </a:solidFill>
+                <a:latin typeface="Avenir Book" pitchFamily="34" charset="0"/>
+                <a:ea typeface="Avenir Book" pitchFamily="34" charset="-122"/>
+                <a:cs typeface="Avenir Book" pitchFamily="34" charset="-120"/>
+              </a:rPr>
+              <a:t>2. Methods</a:t>
+            </a:r>
+            <a:endParaRPr lang="en-US" sz="2400" dirty="0"/>
+          </a:p>
+          <a:p>
+            <a:pPr indent="0" marL="0">
+              <a:spcAft>
+                <a:spcPts val="1800"/>
+              </a:spcAft>
+              <a:buNone/>
+            </a:pPr>
+            <a:r>
+              <a:rPr lang="en-US" sz="2400" dirty="0">
+                <a:solidFill>
+                  <a:srgbClr val="FF0000"/>
+                </a:solidFill>
+                <a:latin typeface="Avenir Book" pitchFamily="34" charset="0"/>
+                <a:ea typeface="Avenir Book" pitchFamily="34" charset="-122"/>
+                <a:cs typeface="Avenir Book" pitchFamily="34" charset="-120"/>
+              </a:rPr>
+              <a:t>3. Results</a:t>
+            </a:r>
+            <a:endParaRPr lang="en-US" sz="2400" dirty="0"/>
+          </a:p>
+          <a:p>
+            <a:pPr indent="0" marL="0">
+              <a:spcAft>
+                <a:spcPts val="1800"/>
+              </a:spcAft>
+              <a:buNone/>
+            </a:pPr>
+            <a:r>
+              <a:rPr lang="en-US" sz="2400" dirty="0">
+                <a:solidFill>
+                  <a:srgbClr val="000000"/>
+                </a:solidFill>
+                <a:latin typeface="Avenir Book" pitchFamily="34" charset="0"/>
+                <a:ea typeface="Avenir Book" pitchFamily="34" charset="-122"/>
+                <a:cs typeface="Avenir Book" pitchFamily="34" charset="-120"/>
+              </a:rPr>
+              <a:t>4. Discussion</a:t>
+            </a:r>
+            <a:endParaRPr lang="en-US" sz="2400" dirty="0"/>
+          </a:p>
+        </p:txBody>
+      </p:sp>
     </p:spTree>
   </p:cSld>
   <p:clrMapOvr>

</xml_diff>

<commit_message>
ISTSS deck: expanded to full 14-minute arc (21 slides)
Co-Authored-By: Claude Fable 5 <noreply@anthropic.com>
Claude-Session: https://claude.ai/code/session_019BJ4u1WYcsA14q2B552n7R
</commit_message>
<xml_diff>
--- a/projects/marvin-stress-trauma/istss_trauma_saturation.pptx
+++ b/projects/marvin-stress-trauma/istss_trauma_saturation.pptx
@@ -22,9 +22,13 @@
     <p:sldId id="270" r:id="rId16"/>
     <p:sldId id="271" r:id="rId17"/>
     <p:sldId id="272" r:id="rId18"/>
+    <p:sldId id="273" r:id="rId19"/>
+    <p:sldId id="274" r:id="rId20"/>
+    <p:sldId id="275" r:id="rId21"/>
+    <p:sldId id="276" r:id="rId22"/>
   </p:sldIdLst>
   <p:notesMasterIdLst>
-    <p:notesMasterId r:id="rId19"/>
+    <p:notesMasterId r:id="rId23"/>
   </p:notesMasterIdLst>
   <p:sldSz cx="9144000" cy="5143500"/>
   <p:notesSz cx="5143500" cy="9144000"/>
@@ -1205,7 +1209,7 @@
           <a:p>
             <a:r>
               <a:rPr lang="en-US" dirty="0"/>
-              <a:t>Thank the chair. One sentence: this talk asks whether trauma changes what everyday stress does to mental health, using population data from Nigeria.</a:t>
+              <a:t>Thank the chair. One sentence: this talk asks whether trauma changes what everyday stress does to mental health, in the same population Salma just described.</a:t>
             </a:r>
             <a:endParaRPr lang="en-US" dirty="0"/>
           </a:p>
@@ -1293,7 +1297,7 @@
           <a:p>
             <a:r>
               <a:rPr lang="en-US" dirty="0"/>
-              <a:t>Read one row aloud. Among adults with no trauma exposure, each additional stressor nearly doubles PTSD prevalence — IRR 1.97. Among adults with five or more event types, nothing — a null. Depression and anxiety do the same. The interaction is below 0.0001 for all three outcomes. The red row is the finding: stress sensitivity is concentrated where trauma exposure is lowest.</a:t>
+              <a:t>The analytic choice that matters: trauma enters continuously, zero to twelve, as a restricted cubic spline, so the shape of any saturation is estimated from the data — the earlier categorical specification imposed it. Poisson models return prevalence ratios directly; adjusted for age, gender, education, state; variances honor the cluster design. The test is the trauma-by-stressor interaction, and we read it on two scales, because relative ratios answer etiology while absolute percentage points answer programming. Everything is prespecified with sensitivity analyses on thresholds and continuous scores.</a:t>
             </a:r>
             <a:endParaRPr lang="en-US" dirty="0"/>
           </a:p>
@@ -1381,7 +1385,7 @@
           <a:p>
             <a:r>
               <a:rPr lang="en-US" dirty="0"/>
-              <a:t>The same result as a picture. Each line is a trauma level; the horizontal axis is the stressor count; the vertical axis is adjusted PTSD prevalence. The red line — no trauma exposure — climbs from 7 percent to 28 percent and keeps going. The five-event line starts near 40 percent and does not move. The gradient belongs to the unexposed; the burden belongs to the exposed.</a:t>
+              <a:t>Results in four steps: the burden, the gradient, the picture, the absolute numbers.</a:t>
             </a:r>
             <a:endParaRPr lang="en-US" dirty="0"/>
           </a:p>
@@ -1469,7 +1473,7 @@
           <a:p>
             <a:r>
               <a:rPr lang="en-US" dirty="0"/>
-              <a:t>Why this matters for programming: the absolute scale. Going from zero to four stressors adds 22 percentage points of PTSD prevalence among adults with no trauma exposure — from 7 to 28 percent. The same contrast among adults with five event types adds nothing, minus two and a half points with a confidence interval straddling zero, against a baseline near 40 percent. Depression: plus 24 versus plus 4. Anxiety: plus 18 versus minus 4. All three nulls at high exposure.</a:t>
+              <a:t>First the main effect, so the interaction has context. At zero stressors, adjusted PTSD prevalence climbs from 6.5 percent among the unexposed to 41 percent at five event types — a six-fold burden gradient. Trauma dominates the risk landscape here; that is not the news. The news is what happens to the stress gradient along the way.</a:t>
             </a:r>
             <a:endParaRPr lang="en-US" dirty="0"/>
           </a:p>
@@ -1557,7 +1561,7 @@
           <a:p>
             <a:r>
               <a:rPr lang="en-US" dirty="0"/>
-              <a:t>The result is not an artifact of any cutoff. PCL-5 at 33, PHQ-9 at 15, GAD-7 at 7, and the continuous symptom scores all show the interaction at p of 0.0002 or below. The categorical specification from earlier versions of this work agrees.</a:t>
+              <a:t>Now the interaction. Read the red row: among adults with no trauma exposure, each additional stressor nearly doubles PTSD prevalence — ratio 1.97. Walk down the column: 1.26 at one to two events, null at three to four, null at five plus. Depression and anxiety show the same staircase. All three interactions below 0.0001. This is the opposite of sensitization: the gradient is steepest where exposure is lowest.</a:t>
             </a:r>
             <a:endParaRPr lang="en-US" dirty="0"/>
           </a:p>
@@ -1645,7 +1649,7 @@
           <a:p>
             <a:r>
               <a:rPr lang="en-US" dirty="0"/>
-              <a:t>The finding in one line. Pause on this slide.</a:t>
+              <a:t>The same result as a picture. Each line is a trauma level; horizontal axis is the stressor count; vertical is adjusted PTSD prevalence. The red line — no trauma exposure — climbs from 7 to 28 percent and keeps rising. The five-event line starts near 41 percent and does not move. The lines converge: the gradient belongs to the unexposed, the burden belongs to the exposed.</a:t>
             </a:r>
             <a:endParaRPr lang="en-US" dirty="0"/>
           </a:p>
@@ -1733,7 +1737,7 @@
           <a:p>
             <a:r>
               <a:rPr lang="en-US" dirty="0"/>
-              <a:t>What this means, and what it cannot mean.</a:t>
+              <a:t>Why this matters for programming: the absolute scale. Zero to four stressors adds 22 percentage points of PTSD prevalence among adults with no trauma exposure, 7 to 28 percent. The same contrast among adults with five event types adds nothing — minus two and a half points, interval straddling zero, against a baseline near 40 percent.</a:t>
             </a:r>
             <a:endParaRPr lang="en-US" dirty="0"/>
           </a:p>
@@ -1821,7 +1825,7 @@
           <a:p>
             <a:r>
               <a:rPr lang="en-US" dirty="0"/>
-              <a:t>Implication: universal psychosocial programming aims stress reduction at people whose symptoms no longer track stress. Match the intervention to trauma history — stress-focused support where sensitivity is retained, trauma-focused therapies where exposure is extensive. Limits, stated plainly: cross-sectional data, so 'saturation' describes an association pattern, not a mechanism; recall of both events and stressors; few respondents above six events, so the extreme tail is unstable; and this is prevalence, not incidence.</a:t>
+              <a:t>Depression and anxiety, same test. Four stressors add 24 points of depression prevalence at zero trauma, 5 to 29 percent; at five events, plus three and a half, null, against 35 percent. Anxiety: plus 18 at zero trauma, minus four, null, at five. Three outcomes, one pattern. And it is not a cutoff artifact — alternative thresholds and the continuous symptom scores all reproduce the interaction at p of 0.0002 or below.</a:t>
             </a:r>
             <a:endParaRPr lang="en-US" dirty="0"/>
           </a:p>
@@ -1909,7 +1913,7 @@
           <a:p>
             <a:r>
               <a:rPr lang="en-US" dirty="0"/>
-              <a:t>Thank collaborators and the field teams in the five states and Ogun. Invite questions.</a:t>
+              <a:t>The finding in one line. Pause on this slide.</a:t>
             </a:r>
             <a:endParaRPr lang="en-US" dirty="0"/>
           </a:p>
@@ -1933,6 +1937,182 @@
             <a:fld id="{F7021451-1387-4CA6-816F-3879F97B5CBC}" type="slidenum">
               <a:rPr lang="en-US"/>
               <a:t>17</a:t>
+            </a:fld>
+            <a:endParaRPr lang="en-US"/>
+          </a:p>
+        </p:txBody>
+      </p:sp>
+    </p:spTree>
+    <p:extLst>
+      <p:ext uri="{BB962C8B-B14F-4D97-AF65-F5344CB8AC3E}">
+        <p14:creationId xmlns:p14="http://schemas.microsoft.com/office/powerpoint/2010/main" val="1024086991"/>
+      </p:ext>
+    </p:extLst>
+  </p:cSld>
+  <p:clrMapOvr>
+    <a:masterClrMapping/>
+  </p:clrMapOvr>
+</p:notes>
+</file>
+
+<file path=ppt/notesSlides/notesSlide18.xml><?xml version="1.0" encoding="utf-8"?>
+<p:notes xmlns:a="http://schemas.openxmlformats.org/drawingml/2006/main" xmlns:r="http://schemas.openxmlformats.org/officeDocument/2006/relationships" xmlns:p="http://schemas.openxmlformats.org/presentationml/2006/main">
+  <p:cSld>
+    <p:spTree>
+      <p:nvGrpSpPr>
+        <p:cNvPr id="1" name=""/>
+        <p:cNvGrpSpPr/>
+        <p:nvPr/>
+      </p:nvGrpSpPr>
+      <p:grpSpPr>
+        <a:xfrm>
+          <a:off x="0" y="0"/>
+          <a:ext cx="0" cy="0"/>
+          <a:chOff x="0" y="0"/>
+          <a:chExt cx="0" cy="0"/>
+        </a:xfrm>
+      </p:grpSpPr>
+      <p:sp>
+        <p:nvSpPr>
+          <p:cNvPr id="2" name="Slide Image Placeholder 1"/>
+          <p:cNvSpPr>
+            <a:spLocks noGrp="1" noRot="1" noChangeAspect="1"/>
+          </p:cNvSpPr>
+          <p:nvPr>
+            <p:ph type="sldImg"/>
+          </p:nvPr>
+        </p:nvSpPr>
+        <p:spPr/>
+      </p:sp>
+      <p:sp>
+        <p:nvSpPr>
+          <p:cNvPr id="3" name="Notes Placeholder 2"/>
+          <p:cNvSpPr>
+            <a:spLocks noGrp="1"/>
+          </p:cNvSpPr>
+          <p:nvPr>
+            <p:ph type="body" idx="1"/>
+          </p:nvPr>
+        </p:nvSpPr>
+        <p:spPr/>
+        <p:txBody>
+          <a:bodyPr/>
+          <a:lstStyle/>
+          <a:p>
+            <a:r>
+              <a:rPr lang="en-US" dirty="0"/>
+              <a:t>What this means, and what it cannot mean.</a:t>
+            </a:r>
+            <a:endParaRPr lang="en-US" dirty="0"/>
+          </a:p>
+        </p:txBody>
+      </p:sp>
+      <p:sp>
+        <p:nvSpPr>
+          <p:cNvPr id="4" name="Slide Number Placeholder 3"/>
+          <p:cNvSpPr>
+            <a:spLocks noGrp="1"/>
+          </p:cNvSpPr>
+          <p:nvPr>
+            <p:ph type="sldNum" sz="quarter" idx="10"/>
+          </p:nvPr>
+        </p:nvSpPr>
+        <p:spPr/>
+        <p:txBody>
+          <a:bodyPr/>
+          <a:lstStyle/>
+          <a:p>
+            <a:fld id="{F7021451-1387-4CA6-816F-3879F97B5CBC}" type="slidenum">
+              <a:rPr lang="en-US"/>
+              <a:t>18</a:t>
+            </a:fld>
+            <a:endParaRPr lang="en-US"/>
+          </a:p>
+        </p:txBody>
+      </p:sp>
+    </p:spTree>
+    <p:extLst>
+      <p:ext uri="{BB962C8B-B14F-4D97-AF65-F5344CB8AC3E}">
+        <p14:creationId xmlns:p14="http://schemas.microsoft.com/office/powerpoint/2010/main" val="1024086991"/>
+      </p:ext>
+    </p:extLst>
+  </p:cSld>
+  <p:clrMapOvr>
+    <a:masterClrMapping/>
+  </p:clrMapOvr>
+</p:notes>
+</file>
+
+<file path=ppt/notesSlides/notesSlide19.xml><?xml version="1.0" encoding="utf-8"?>
+<p:notes xmlns:a="http://schemas.openxmlformats.org/drawingml/2006/main" xmlns:r="http://schemas.openxmlformats.org/officeDocument/2006/relationships" xmlns:p="http://schemas.openxmlformats.org/presentationml/2006/main">
+  <p:cSld>
+    <p:spTree>
+      <p:nvGrpSpPr>
+        <p:cNvPr id="1" name=""/>
+        <p:cNvGrpSpPr/>
+        <p:nvPr/>
+      </p:nvGrpSpPr>
+      <p:grpSpPr>
+        <a:xfrm>
+          <a:off x="0" y="0"/>
+          <a:ext cx="0" cy="0"/>
+          <a:chOff x="0" y="0"/>
+          <a:chExt cx="0" cy="0"/>
+        </a:xfrm>
+      </p:grpSpPr>
+      <p:sp>
+        <p:nvSpPr>
+          <p:cNvPr id="2" name="Slide Image Placeholder 1"/>
+          <p:cNvSpPr>
+            <a:spLocks noGrp="1" noRot="1" noChangeAspect="1"/>
+          </p:cNvSpPr>
+          <p:nvPr>
+            <p:ph type="sldImg"/>
+          </p:nvPr>
+        </p:nvSpPr>
+        <p:spPr/>
+      </p:sp>
+      <p:sp>
+        <p:nvSpPr>
+          <p:cNvPr id="3" name="Notes Placeholder 2"/>
+          <p:cNvSpPr>
+            <a:spLocks noGrp="1"/>
+          </p:cNvSpPr>
+          <p:nvPr>
+            <p:ph type="body" idx="1"/>
+          </p:nvPr>
+        </p:nvSpPr>
+        <p:spPr/>
+        <p:txBody>
+          <a:bodyPr/>
+          <a:lstStyle/>
+          <a:p>
+            <a:r>
+              <a:rPr lang="en-US" dirty="0"/>
+              <a:t>Against sensitization, and beyond simple dose-response: symptom prevalence among the heavily exposed is high at every stressor level — saturated — while stress sensitivity is concentrated among those with limited exposure. For programming: universal stress-reduction aims at people whose symptoms no longer track stress. Match the intervention to trauma history. Stress-focused and livelihood support where sensitivity is retained — the majority, with limited exposure. Trauma-focused therapies — the treatments this society's trials support — where exposure is extensive, because for them the trauma load, not the stressor load, is the target.</a:t>
+            </a:r>
+            <a:endParaRPr lang="en-US" dirty="0"/>
+          </a:p>
+        </p:txBody>
+      </p:sp>
+      <p:sp>
+        <p:nvSpPr>
+          <p:cNvPr id="4" name="Slide Number Placeholder 3"/>
+          <p:cNvSpPr>
+            <a:spLocks noGrp="1"/>
+          </p:cNvSpPr>
+          <p:nvPr>
+            <p:ph type="sldNum" sz="quarter" idx="10"/>
+          </p:nvPr>
+        </p:nvSpPr>
+        <p:spPr/>
+        <p:txBody>
+          <a:bodyPr/>
+          <a:lstStyle/>
+          <a:p>
+            <a:fld id="{F7021451-1387-4CA6-816F-3879F97B5CBC}" type="slidenum">
+              <a:rPr lang="en-US"/>
+              <a:t>19</a:t>
             </a:fld>
             <a:endParaRPr lang="en-US"/>
           </a:p>
@@ -2039,6 +2219,182 @@
 </p:notes>
 </file>
 
+<file path=ppt/notesSlides/notesSlide20.xml><?xml version="1.0" encoding="utf-8"?>
+<p:notes xmlns:a="http://schemas.openxmlformats.org/drawingml/2006/main" xmlns:r="http://schemas.openxmlformats.org/officeDocument/2006/relationships" xmlns:p="http://schemas.openxmlformats.org/presentationml/2006/main">
+  <p:cSld>
+    <p:spTree>
+      <p:nvGrpSpPr>
+        <p:cNvPr id="1" name=""/>
+        <p:cNvGrpSpPr/>
+        <p:nvPr/>
+      </p:nvGrpSpPr>
+      <p:grpSpPr>
+        <a:xfrm>
+          <a:off x="0" y="0"/>
+          <a:ext cx="0" cy="0"/>
+          <a:chOff x="0" y="0"/>
+          <a:chExt cx="0" cy="0"/>
+        </a:xfrm>
+      </p:grpSpPr>
+      <p:sp>
+        <p:nvSpPr>
+          <p:cNvPr id="2" name="Slide Image Placeholder 1"/>
+          <p:cNvSpPr>
+            <a:spLocks noGrp="1" noRot="1" noChangeAspect="1"/>
+          </p:cNvSpPr>
+          <p:nvPr>
+            <p:ph type="sldImg"/>
+          </p:nvPr>
+        </p:nvSpPr>
+        <p:spPr/>
+      </p:sp>
+      <p:sp>
+        <p:nvSpPr>
+          <p:cNvPr id="3" name="Notes Placeholder 2"/>
+          <p:cNvSpPr>
+            <a:spLocks noGrp="1"/>
+          </p:cNvSpPr>
+          <p:nvPr>
+            <p:ph type="body" idx="1"/>
+          </p:nvPr>
+        </p:nvSpPr>
+        <p:spPr/>
+        <p:txBody>
+          <a:bodyPr/>
+          <a:lstStyle/>
+          <a:p>
+            <a:r>
+              <a:rPr lang="en-US" dirty="0"/>
+              <a:t>Stated plainly. Cross-sectional data: saturation names an association pattern, not a mechanism — selection, recall, and ceiling processes could each contribute. Event counts are lifetime recall; stressors are current. Few respondents above six events, so the extreme tail is unstable. And prevalence, not incidence: we see who is symptomatic, not who became so. The longitudinal test — does a new stressor move symptoms differently by trauma history — is the next study.</a:t>
+            </a:r>
+            <a:endParaRPr lang="en-US" dirty="0"/>
+          </a:p>
+        </p:txBody>
+      </p:sp>
+      <p:sp>
+        <p:nvSpPr>
+          <p:cNvPr id="4" name="Slide Number Placeholder 3"/>
+          <p:cNvSpPr>
+            <a:spLocks noGrp="1"/>
+          </p:cNvSpPr>
+          <p:nvPr>
+            <p:ph type="sldNum" sz="quarter" idx="10"/>
+          </p:nvPr>
+        </p:nvSpPr>
+        <p:spPr/>
+        <p:txBody>
+          <a:bodyPr/>
+          <a:lstStyle/>
+          <a:p>
+            <a:fld id="{F7021451-1387-4CA6-816F-3879F97B5CBC}" type="slidenum">
+              <a:rPr lang="en-US"/>
+              <a:t>20</a:t>
+            </a:fld>
+            <a:endParaRPr lang="en-US"/>
+          </a:p>
+        </p:txBody>
+      </p:sp>
+    </p:spTree>
+    <p:extLst>
+      <p:ext uri="{BB962C8B-B14F-4D97-AF65-F5344CB8AC3E}">
+        <p14:creationId xmlns:p14="http://schemas.microsoft.com/office/powerpoint/2010/main" val="1024086991"/>
+      </p:ext>
+    </p:extLst>
+  </p:cSld>
+  <p:clrMapOvr>
+    <a:masterClrMapping/>
+  </p:clrMapOvr>
+</p:notes>
+</file>
+
+<file path=ppt/notesSlides/notesSlide21.xml><?xml version="1.0" encoding="utf-8"?>
+<p:notes xmlns:a="http://schemas.openxmlformats.org/drawingml/2006/main" xmlns:r="http://schemas.openxmlformats.org/officeDocument/2006/relationships" xmlns:p="http://schemas.openxmlformats.org/presentationml/2006/main">
+  <p:cSld>
+    <p:spTree>
+      <p:nvGrpSpPr>
+        <p:cNvPr id="1" name=""/>
+        <p:cNvGrpSpPr/>
+        <p:nvPr/>
+      </p:nvGrpSpPr>
+      <p:grpSpPr>
+        <a:xfrm>
+          <a:off x="0" y="0"/>
+          <a:ext cx="0" cy="0"/>
+          <a:chOff x="0" y="0"/>
+          <a:chExt cx="0" cy="0"/>
+        </a:xfrm>
+      </p:grpSpPr>
+      <p:sp>
+        <p:nvSpPr>
+          <p:cNvPr id="2" name="Slide Image Placeholder 1"/>
+          <p:cNvSpPr>
+            <a:spLocks noGrp="1" noRot="1" noChangeAspect="1"/>
+          </p:cNvSpPr>
+          <p:nvPr>
+            <p:ph type="sldImg"/>
+          </p:nvPr>
+        </p:nvSpPr>
+        <p:spPr/>
+      </p:sp>
+      <p:sp>
+        <p:nvSpPr>
+          <p:cNvPr id="3" name="Notes Placeholder 2"/>
+          <p:cNvSpPr>
+            <a:spLocks noGrp="1"/>
+          </p:cNvSpPr>
+          <p:nvPr>
+            <p:ph type="body" idx="1"/>
+          </p:nvPr>
+        </p:nvSpPr>
+        <p:spPr/>
+        <p:txBody>
+          <a:bodyPr/>
+          <a:lstStyle/>
+          <a:p>
+            <a:r>
+              <a:rPr lang="en-US" dirty="0"/>
+              <a:t>Thank the field teams across the six states, co-authors, and the symposium chair. Hand to Dr. Ojo, whose paper takes these findings to the ministry.</a:t>
+            </a:r>
+            <a:endParaRPr lang="en-US" dirty="0"/>
+          </a:p>
+        </p:txBody>
+      </p:sp>
+      <p:sp>
+        <p:nvSpPr>
+          <p:cNvPr id="4" name="Slide Number Placeholder 3"/>
+          <p:cNvSpPr>
+            <a:spLocks noGrp="1"/>
+          </p:cNvSpPr>
+          <p:nvPr>
+            <p:ph type="sldNum" sz="quarter" idx="10"/>
+          </p:nvPr>
+        </p:nvSpPr>
+        <p:spPr/>
+        <p:txBody>
+          <a:bodyPr/>
+          <a:lstStyle/>
+          <a:p>
+            <a:fld id="{F7021451-1387-4CA6-816F-3879F97B5CBC}" type="slidenum">
+              <a:rPr lang="en-US"/>
+              <a:t>21</a:t>
+            </a:fld>
+            <a:endParaRPr lang="en-US"/>
+          </a:p>
+        </p:txBody>
+      </p:sp>
+    </p:spTree>
+    <p:extLst>
+      <p:ext uri="{BB962C8B-B14F-4D97-AF65-F5344CB8AC3E}">
+        <p14:creationId xmlns:p14="http://schemas.microsoft.com/office/powerpoint/2010/main" val="1024086991"/>
+      </p:ext>
+    </p:extLst>
+  </p:cSld>
+  <p:clrMapOvr>
+    <a:masterClrMapping/>
+  </p:clrMapOvr>
+</p:notes>
+</file>
+
 <file path=ppt/notesSlides/notesSlide3.xml><?xml version="1.0" encoding="utf-8"?>
 <p:notes xmlns:a="http://schemas.openxmlformats.org/drawingml/2006/main" xmlns:r="http://schemas.openxmlformats.org/officeDocument/2006/relationships" xmlns:p="http://schemas.openxmlformats.org/presentationml/2006/main">
   <p:cSld>
@@ -2085,7 +2441,7 @@
           <a:p>
             <a:r>
               <a:rPr lang="en-US" dirty="0"/>
-              <a:t>Roadmap: background, methods, results, discussion. We are here.</a:t>
+              <a:t>Roadmap: background, methods, results, discussion.</a:t>
             </a:r>
             <a:endParaRPr lang="en-US" dirty="0"/>
           </a:p>
@@ -2173,7 +2529,7 @@
           <a:p>
             <a:r>
               <a:rPr lang="en-US" dirty="0"/>
-              <a:t>Two traditions. Additive models: trauma and daily stressors each add risk, so everyone benefits from stress reduction. Effect-modification models: trauma changes stress reactivity itself. Conflict settings are where the two make sharply different predictions, and where the evidence is thinnest. Our earlier work documented roughly one in five adults with probable PTSD across conflict-affected Nigeria.</a:t>
+              <a:t>Jaimie showed the instruments work here; Salma showed the burden at scale. The population carries two loads at once: traumatic events from overlapping conflicts, and grinding daily adversity — food insecurity, job loss, housing precarity. Humanitarian programming usually treats these as one additive pile of risk. Whether that is true decides who universal psychosocial programs actually help.</a:t>
             </a:r>
             <a:endParaRPr lang="en-US" dirty="0"/>
           </a:p>
@@ -2261,7 +2617,7 @@
           <a:p>
             <a:r>
               <a:rPr lang="en-US" dirty="0"/>
-              <a:t>The question in one line. If trauma exposure modifies stress sensitivity, universal psychosocial programming is aiming at the wrong target for a large share of the population.</a:t>
+              <a:t>The literature offers three incompatible answers. Stress sensitization — Post's kindling work, and the child-adversity literature — says prior trauma amplifies reactivity to later stress, so gradients should be steepest among the most exposed. Stress inoculation says moderate exposure toughens, predicting the opposite. And the daily-stressors model in humanitarian settings — Miller and Rasmussen — says everyday adversity mediates much of conflict's effect but is largely silent on effect modification. Almost all the evidence behind these comes from high-income cohorts with far lower exposure ranges than ours. Nobody has tested the shape of the interaction in a population where exposure runs this high.</a:t>
             </a:r>
             <a:endParaRPr lang="en-US" dirty="0"/>
           </a:p>
@@ -2349,7 +2705,7 @@
           <a:p>
             <a:r>
               <a:rPr lang="en-US" dirty="0"/>
-              <a:t>Now the methods.</a:t>
+              <a:t>The question in one line. Pause.</a:t>
             </a:r>
             <a:endParaRPr lang="en-US" dirty="0"/>
           </a:p>
@@ -2437,7 +2793,7 @@
           <a:p>
             <a:r>
               <a:rPr lang="en-US" dirty="0"/>
-              <a:t>Survey of 1,729 adults (37 who declined the trauma items are excluded), January to March 2024. Six states: five conflict-affected — Benue, Borno, Enugu, Rivers, Sokoto — and Ogun as a non-conflict comparison, which anchors the low end of the trauma gradient. Stratified multi-stage cluster design: state strata, 572 community clusters, community and IDP-camp settings. Analyses account for the design throughout.</a:t>
+              <a:t>Methods: the sample you have already met, then measures, then the model.</a:t>
             </a:r>
             <a:endParaRPr lang="en-US" dirty="0"/>
           </a:p>
@@ -2525,7 +2881,7 @@
           <a:p>
             <a:r>
               <a:rPr lang="en-US" dirty="0"/>
-              <a:t>Outcomes: probable PTSD, PCL-5 at 38 and above; depression, PHQ-9 at 10; anxiety, GAD-7 at 10 — instruments validated in this population in our first study. Exposure: count of traumatic event types, zero to twelve, modeled as a restricted cubic spline so the shape of any saturation is estimated, not imposed by categories. Stressors: a 0-to-10 count of socioeconomic challenges. Poisson models give prevalence ratios; adjusted for age, gender, education, state; variances account for the cluster design. The test is the trauma-by-stressor interaction. We also estimate absolute prevalence differences, because targeting claims live on the absolute scale.</a:t>
+              <a:t>The MaRVIN sample Salma presented: 1,774 adults surveyed January to March 2024; 1,729 answered the trauma inventory and enter this analysis. Six states: five conflict-affected — Benue, Borno, Enugu, Rivers, Sokoto — plus Ogun as a non-conflict comparison, which anchors the low end of the trauma gradient. Stratified multi-stage cluster design, 565 community clusters, community and IDP-camp settings. All analyses honor the design: state strata, community clusters, linearized variances.</a:t>
             </a:r>
             <a:endParaRPr lang="en-US" dirty="0"/>
           </a:p>
@@ -2613,7 +2969,7 @@
           <a:p>
             <a:r>
               <a:rPr lang="en-US" dirty="0"/>
-              <a:t>Results in three steps: the gradient, the picture, the absolute numbers.</a:t>
+              <a:t>Outcomes use the instruments Jaimie validated: probable PTSD at PCL-5 38 and above; depression, PHQ-9 at 10; anxiety, GAD-7 at 10. Trauma exposure is a count of twelve event types — assaults, armed conflict, disasters, accidents; respondents who declined the inventory are excluded, not counted as unexposed. Stressors are a 0-to-10 count of socioeconomic challenges: job loss, rent difficulty, eviction, family disruption, isolation.</a:t>
             </a:r>
             <a:endParaRPr lang="en-US" dirty="0"/>
           </a:p>
@@ -3224,6 +3580,506 @@
                 <a:ea typeface="Avenir Book" pitchFamily="34" charset="-122"/>
                 <a:cs typeface="Avenir Book" pitchFamily="34" charset="-120"/>
               </a:rPr>
+              <a:t>Model</a:t>
+            </a:r>
+            <a:endParaRPr lang="en-US" sz="2800" dirty="0"/>
+          </a:p>
+        </p:txBody>
+      </p:sp>
+      <p:sp>
+        <p:nvSpPr>
+          <p:cNvPr id="4" name="Text 1"/>
+          <p:cNvSpPr txBox="1"/>
+          <p:nvPr/>
+        </p:nvSpPr>
+        <p:spPr>
+          <a:xfrm>
+            <a:off x="548640" y="1371600"/>
+            <a:ext cx="8046720" cy="3291840"/>
+          </a:xfrm>
+          <a:prstGeom prst="rect">
+            <a:avLst/>
+          </a:prstGeom>
+          <a:noFill/>
+          <a:ln/>
+        </p:spPr>
+        <p:txBody>
+          <a:bodyPr wrap="square" lIns="0" tIns="0" rIns="0" bIns="0" rtlCol="0" anchor="t"/>
+          <a:lstStyle/>
+          <a:p>
+            <a:pPr indent="0" marL="0">
+              <a:spcAft>
+                <a:spcPts val="1400"/>
+              </a:spcAft>
+              <a:buNone/>
+            </a:pPr>
+            <a:r>
+              <a:rPr lang="en-US" sz="2000" dirty="0">
+                <a:solidFill>
+                  <a:srgbClr val="000000"/>
+                </a:solidFill>
+                <a:latin typeface="Avenir Book" pitchFamily="34" charset="0"/>
+                <a:ea typeface="Avenir Book" pitchFamily="34" charset="-122"/>
+                <a:cs typeface="Avenir Book" pitchFamily="34" charset="-120"/>
+              </a:rPr>
+              <a:t>Trauma as a restricted cubic spline: the saturation shape is estimated, not assumed</a:t>
+            </a:r>
+            <a:endParaRPr lang="en-US" sz="2000" dirty="0"/>
+          </a:p>
+          <a:p>
+            <a:pPr indent="0" marL="0">
+              <a:spcAft>
+                <a:spcPts val="1400"/>
+              </a:spcAft>
+              <a:buNone/>
+            </a:pPr>
+            <a:r>
+              <a:rPr lang="en-US" sz="2000" dirty="0">
+                <a:solidFill>
+                  <a:srgbClr val="000000"/>
+                </a:solidFill>
+                <a:latin typeface="Avenir Book" pitchFamily="34" charset="0"/>
+                <a:ea typeface="Avenir Book" pitchFamily="34" charset="-122"/>
+                <a:cs typeface="Avenir Book" pitchFamily="34" charset="-120"/>
+              </a:rPr>
+              <a:t>Poisson prevalence ratios; adjusted; design-based variances</a:t>
+            </a:r>
+            <a:endParaRPr lang="en-US" sz="2000" dirty="0"/>
+          </a:p>
+          <a:p>
+            <a:pPr indent="0" marL="0">
+              <a:spcAft>
+                <a:spcPts val="1400"/>
+              </a:spcAft>
+              <a:buNone/>
+            </a:pPr>
+            <a:r>
+              <a:rPr lang="en-US" sz="2000" dirty="0">
+                <a:solidFill>
+                  <a:srgbClr val="000000"/>
+                </a:solidFill>
+                <a:latin typeface="Avenir Book" pitchFamily="34" charset="0"/>
+                <a:ea typeface="Avenir Book" pitchFamily="34" charset="-122"/>
+                <a:cs typeface="Avenir Book" pitchFamily="34" charset="-120"/>
+              </a:rPr>
+              <a:t>Test: trauma × stressor interaction — on the relative and the absolute scale</a:t>
+            </a:r>
+            <a:endParaRPr lang="en-US" sz="2000" dirty="0"/>
+          </a:p>
+          <a:p>
+            <a:pPr indent="0" marL="0">
+              <a:spcAft>
+                <a:spcPts val="200"/>
+              </a:spcAft>
+              <a:buNone/>
+            </a:pPr>
+            <a:r>
+              <a:rPr lang="en-US" sz="2000" dirty="0">
+                <a:solidFill>
+                  <a:srgbClr val="000000"/>
+                </a:solidFill>
+                <a:latin typeface="Avenir Book" pitchFamily="34" charset="0"/>
+                <a:ea typeface="Avenir Book" pitchFamily="34" charset="-122"/>
+                <a:cs typeface="Avenir Book" pitchFamily="34" charset="-120"/>
+              </a:rPr>
+              <a:t>Sensitivity: alternative thresholds, continuous scores, categorical specification</a:t>
+            </a:r>
+            <a:endParaRPr lang="en-US" sz="2000" dirty="0"/>
+          </a:p>
+        </p:txBody>
+      </p:sp>
+    </p:spTree>
+  </p:cSld>
+  <p:clrMapOvr>
+    <a:masterClrMapping/>
+  </p:clrMapOvr>
+</p:sld>
+</file>
+
+<file path=ppt/slides/slide11.xml><?xml version="1.0" encoding="utf-8"?>
+<p:sld xmlns:a="http://schemas.openxmlformats.org/drawingml/2006/main" xmlns:r="http://schemas.openxmlformats.org/officeDocument/2006/relationships" xmlns:p="http://schemas.openxmlformats.org/presentationml/2006/main">
+  <p:cSld name="Slide 11">
+    <p:bg>
+      <p:bgPr>
+        <a:solidFill>
+          <a:srgbClr val="FFFFFF"/>
+        </a:solidFill>
+      </p:bgPr>
+    </p:bg>
+    <p:spTree>
+      <p:nvGrpSpPr>
+        <p:cNvPr id="1" name=""/>
+        <p:cNvGrpSpPr/>
+        <p:nvPr/>
+      </p:nvGrpSpPr>
+      <p:grpSpPr>
+        <a:xfrm>
+          <a:off x="0" y="0"/>
+          <a:ext cx="0" cy="0"/>
+          <a:chOff x="0" y="0"/>
+          <a:chExt cx="0" cy="0"/>
+        </a:xfrm>
+      </p:grpSpPr>
+      <p:sp>
+        <p:nvSpPr>
+          <p:cNvPr id="3" name="Text 0"/>
+          <p:cNvSpPr txBox="1"/>
+          <p:nvPr/>
+        </p:nvSpPr>
+        <p:spPr>
+          <a:xfrm>
+            <a:off x="3108960" y="1463040"/>
+            <a:ext cx="3657600" cy="2377440"/>
+          </a:xfrm>
+          <a:prstGeom prst="rect">
+            <a:avLst/>
+          </a:prstGeom>
+          <a:noFill/>
+          <a:ln/>
+        </p:spPr>
+        <p:txBody>
+          <a:bodyPr wrap="square" lIns="0" tIns="0" rIns="0" bIns="0" rtlCol="0" anchor="ctr"/>
+          <a:lstStyle/>
+          <a:p>
+            <a:pPr indent="0" marL="0">
+              <a:spcAft>
+                <a:spcPts val="1800"/>
+              </a:spcAft>
+              <a:buNone/>
+            </a:pPr>
+            <a:r>
+              <a:rPr lang="en-US" sz="2400" dirty="0">
+                <a:solidFill>
+                  <a:srgbClr val="000000"/>
+                </a:solidFill>
+                <a:latin typeface="Avenir Book" pitchFamily="34" charset="0"/>
+                <a:ea typeface="Avenir Book" pitchFamily="34" charset="-122"/>
+                <a:cs typeface="Avenir Book" pitchFamily="34" charset="-120"/>
+              </a:rPr>
+              <a:t>1. Background</a:t>
+            </a:r>
+            <a:endParaRPr lang="en-US" sz="2400" dirty="0"/>
+          </a:p>
+          <a:p>
+            <a:pPr indent="0" marL="0">
+              <a:spcAft>
+                <a:spcPts val="1800"/>
+              </a:spcAft>
+              <a:buNone/>
+            </a:pPr>
+            <a:r>
+              <a:rPr lang="en-US" sz="2400" dirty="0">
+                <a:solidFill>
+                  <a:srgbClr val="000000"/>
+                </a:solidFill>
+                <a:latin typeface="Avenir Book" pitchFamily="34" charset="0"/>
+                <a:ea typeface="Avenir Book" pitchFamily="34" charset="-122"/>
+                <a:cs typeface="Avenir Book" pitchFamily="34" charset="-120"/>
+              </a:rPr>
+              <a:t>2. Methods</a:t>
+            </a:r>
+            <a:endParaRPr lang="en-US" sz="2400" dirty="0"/>
+          </a:p>
+          <a:p>
+            <a:pPr indent="0" marL="0">
+              <a:spcAft>
+                <a:spcPts val="1800"/>
+              </a:spcAft>
+              <a:buNone/>
+            </a:pPr>
+            <a:r>
+              <a:rPr lang="en-US" sz="2400" dirty="0">
+                <a:solidFill>
+                  <a:srgbClr val="FF0000"/>
+                </a:solidFill>
+                <a:latin typeface="Avenir Book" pitchFamily="34" charset="0"/>
+                <a:ea typeface="Avenir Book" pitchFamily="34" charset="-122"/>
+                <a:cs typeface="Avenir Book" pitchFamily="34" charset="-120"/>
+              </a:rPr>
+              <a:t>3. Results</a:t>
+            </a:r>
+            <a:endParaRPr lang="en-US" sz="2400" dirty="0"/>
+          </a:p>
+          <a:p>
+            <a:pPr indent="0" marL="0">
+              <a:spcAft>
+                <a:spcPts val="1800"/>
+              </a:spcAft>
+              <a:buNone/>
+            </a:pPr>
+            <a:r>
+              <a:rPr lang="en-US" sz="2400" dirty="0">
+                <a:solidFill>
+                  <a:srgbClr val="000000"/>
+                </a:solidFill>
+                <a:latin typeface="Avenir Book" pitchFamily="34" charset="0"/>
+                <a:ea typeface="Avenir Book" pitchFamily="34" charset="-122"/>
+                <a:cs typeface="Avenir Book" pitchFamily="34" charset="-120"/>
+              </a:rPr>
+              <a:t>4. Discussion</a:t>
+            </a:r>
+            <a:endParaRPr lang="en-US" sz="2400" dirty="0"/>
+          </a:p>
+        </p:txBody>
+      </p:sp>
+    </p:spTree>
+  </p:cSld>
+  <p:clrMapOvr>
+    <a:masterClrMapping/>
+  </p:clrMapOvr>
+</p:sld>
+</file>
+
+<file path=ppt/slides/slide12.xml><?xml version="1.0" encoding="utf-8"?>
+<p:sld xmlns:a="http://schemas.openxmlformats.org/drawingml/2006/main" xmlns:r="http://schemas.openxmlformats.org/officeDocument/2006/relationships" xmlns:p="http://schemas.openxmlformats.org/presentationml/2006/main">
+  <p:cSld name="Slide 12">
+    <p:bg>
+      <p:bgPr>
+        <a:solidFill>
+          <a:srgbClr val="FFFFFF"/>
+        </a:solidFill>
+      </p:bgPr>
+    </p:bg>
+    <p:spTree>
+      <p:nvGrpSpPr>
+        <p:cNvPr id="1" name=""/>
+        <p:cNvGrpSpPr/>
+        <p:nvPr/>
+      </p:nvGrpSpPr>
+      <p:grpSpPr>
+        <a:xfrm>
+          <a:off x="0" y="0"/>
+          <a:ext cx="0" cy="0"/>
+          <a:chOff x="0" y="0"/>
+          <a:chExt cx="0" cy="0"/>
+        </a:xfrm>
+      </p:grpSpPr>
+      <p:sp>
+        <p:nvSpPr>
+          <p:cNvPr id="3" name="Text 0"/>
+          <p:cNvSpPr txBox="1"/>
+          <p:nvPr/>
+        </p:nvSpPr>
+        <p:spPr>
+          <a:xfrm>
+            <a:off x="548640" y="411480"/>
+            <a:ext cx="8046720" cy="640080"/>
+          </a:xfrm>
+          <a:prstGeom prst="rect">
+            <a:avLst/>
+          </a:prstGeom>
+          <a:noFill/>
+          <a:ln/>
+        </p:spPr>
+        <p:txBody>
+          <a:bodyPr wrap="square" lIns="0" tIns="0" rIns="0" bIns="0" rtlCol="0" anchor="ctr"/>
+          <a:lstStyle/>
+          <a:p>
+            <a:pPr indent="0" marL="0">
+              <a:buNone/>
+            </a:pPr>
+            <a:r>
+              <a:rPr lang="en-US" sz="2800" dirty="0">
+                <a:solidFill>
+                  <a:srgbClr val="000000"/>
+                </a:solidFill>
+                <a:latin typeface="Avenir Book" pitchFamily="34" charset="0"/>
+                <a:ea typeface="Avenir Book" pitchFamily="34" charset="-122"/>
+                <a:cs typeface="Avenir Book" pitchFamily="34" charset="-120"/>
+              </a:rPr>
+              <a:t>The burden gradient</a:t>
+            </a:r>
+            <a:endParaRPr lang="en-US" sz="2800" dirty="0"/>
+          </a:p>
+        </p:txBody>
+      </p:sp>
+      <p:sp>
+        <p:nvSpPr>
+          <p:cNvPr id="4" name="Text 1"/>
+          <p:cNvSpPr txBox="1"/>
+          <p:nvPr/>
+        </p:nvSpPr>
+        <p:spPr>
+          <a:xfrm>
+            <a:off x="548640" y="1371600"/>
+            <a:ext cx="8046720" cy="3291840"/>
+          </a:xfrm>
+          <a:prstGeom prst="rect">
+            <a:avLst/>
+          </a:prstGeom>
+          <a:noFill/>
+          <a:ln/>
+        </p:spPr>
+        <p:txBody>
+          <a:bodyPr wrap="square" lIns="0" tIns="0" rIns="0" bIns="0" rtlCol="0" anchor="t"/>
+          <a:lstStyle/>
+          <a:p>
+            <a:pPr indent="0" marL="0">
+              <a:spcAft>
+                <a:spcPts val="1400"/>
+              </a:spcAft>
+              <a:buNone/>
+            </a:pPr>
+            <a:r>
+              <a:rPr lang="en-US" sz="2000" dirty="0">
+                <a:solidFill>
+                  <a:srgbClr val="000000"/>
+                </a:solidFill>
+                <a:latin typeface="Avenir Book" pitchFamily="34" charset="0"/>
+                <a:ea typeface="Avenir Book" pitchFamily="34" charset="-122"/>
+                <a:cs typeface="Avenir Book" pitchFamily="34" charset="-120"/>
+              </a:rPr>
+              <a:t>Adjusted PTSD prevalence at zero stressors:</a:t>
+            </a:r>
+            <a:endParaRPr lang="en-US" sz="2000" dirty="0"/>
+          </a:p>
+          <a:p>
+            <a:pPr indent="0" marL="0">
+              <a:spcAft>
+                <a:spcPts val="1400"/>
+              </a:spcAft>
+              <a:buNone/>
+            </a:pPr>
+            <a:r>
+              <a:rPr lang="en-US" sz="2000" dirty="0">
+                <a:solidFill>
+                  <a:srgbClr val="000000"/>
+                </a:solidFill>
+                <a:latin typeface="Avenir Book" pitchFamily="34" charset="0"/>
+                <a:ea typeface="Avenir Book" pitchFamily="34" charset="-122"/>
+                <a:cs typeface="Avenir Book" pitchFamily="34" charset="-120"/>
+              </a:rPr>
+              <a:t>6.5% with no trauma exposure</a:t>
+            </a:r>
+            <a:endParaRPr lang="en-US" sz="2000" dirty="0"/>
+          </a:p>
+          <a:p>
+            <a:pPr indent="0" marL="0">
+              <a:spcAft>
+                <a:spcPts val="1400"/>
+              </a:spcAft>
+              <a:buNone/>
+            </a:pPr>
+            <a:r>
+              <a:rPr lang="en-US" sz="2000" dirty="0">
+                <a:solidFill>
+                  <a:srgbClr val="000000"/>
+                </a:solidFill>
+                <a:latin typeface="Avenir Book" pitchFamily="34" charset="0"/>
+                <a:ea typeface="Avenir Book" pitchFamily="34" charset="-122"/>
+                <a:cs typeface="Avenir Book" pitchFamily="34" charset="-120"/>
+              </a:rPr>
+              <a:t>20% at three event types</a:t>
+            </a:r>
+            <a:endParaRPr lang="en-US" sz="2000" dirty="0"/>
+          </a:p>
+          <a:p>
+            <a:pPr indent="0" marL="0">
+              <a:spcAft>
+                <a:spcPts val="1400"/>
+              </a:spcAft>
+              <a:buNone/>
+            </a:pPr>
+            <a:r>
+              <a:rPr lang="en-US" sz="2000" dirty="0">
+                <a:solidFill>
+                  <a:srgbClr val="000000"/>
+                </a:solidFill>
+                <a:latin typeface="Avenir Book" pitchFamily="34" charset="0"/>
+                <a:ea typeface="Avenir Book" pitchFamily="34" charset="-122"/>
+                <a:cs typeface="Avenir Book" pitchFamily="34" charset="-120"/>
+              </a:rPr>
+              <a:t>41% at five event types</a:t>
+            </a:r>
+            <a:endParaRPr lang="en-US" sz="2000" dirty="0"/>
+          </a:p>
+          <a:p>
+            <a:pPr indent="0" marL="0">
+              <a:spcAft>
+                <a:spcPts val="200"/>
+              </a:spcAft>
+              <a:buNone/>
+            </a:pPr>
+            <a:r>
+              <a:rPr lang="en-US" sz="2000" dirty="0">
+                <a:solidFill>
+                  <a:srgbClr val="000000"/>
+                </a:solidFill>
+                <a:latin typeface="Avenir Book" pitchFamily="34" charset="0"/>
+                <a:ea typeface="Avenir Book" pitchFamily="34" charset="-122"/>
+                <a:cs typeface="Avenir Book" pitchFamily="34" charset="-120"/>
+              </a:rPr>
+              <a:t>Trauma dominates the risk landscape — that is not the news</a:t>
+            </a:r>
+            <a:endParaRPr lang="en-US" sz="2000" dirty="0"/>
+          </a:p>
+        </p:txBody>
+      </p:sp>
+    </p:spTree>
+  </p:cSld>
+  <p:clrMapOvr>
+    <a:masterClrMapping/>
+  </p:clrMapOvr>
+</p:sld>
+</file>
+
+<file path=ppt/slides/slide13.xml><?xml version="1.0" encoding="utf-8"?>
+<p:sld xmlns:a="http://schemas.openxmlformats.org/drawingml/2006/main" xmlns:r="http://schemas.openxmlformats.org/officeDocument/2006/relationships" xmlns:p="http://schemas.openxmlformats.org/presentationml/2006/main">
+  <p:cSld name="Slide 13">
+    <p:bg>
+      <p:bgPr>
+        <a:solidFill>
+          <a:srgbClr val="FFFFFF"/>
+        </a:solidFill>
+      </p:bgPr>
+    </p:bg>
+    <p:spTree>
+      <p:nvGrpSpPr>
+        <p:cNvPr id="1" name=""/>
+        <p:cNvGrpSpPr/>
+        <p:nvPr/>
+      </p:nvGrpSpPr>
+      <p:grpSpPr>
+        <a:xfrm>
+          <a:off x="0" y="0"/>
+          <a:ext cx="0" cy="0"/>
+          <a:chOff x="0" y="0"/>
+          <a:chExt cx="0" cy="0"/>
+        </a:xfrm>
+      </p:grpSpPr>
+      <p:sp>
+        <p:nvSpPr>
+          <p:cNvPr id="3" name="Text 0"/>
+          <p:cNvSpPr txBox="1"/>
+          <p:nvPr/>
+        </p:nvSpPr>
+        <p:spPr>
+          <a:xfrm>
+            <a:off x="548640" y="411480"/>
+            <a:ext cx="8046720" cy="640080"/>
+          </a:xfrm>
+          <a:prstGeom prst="rect">
+            <a:avLst/>
+          </a:prstGeom>
+          <a:noFill/>
+          <a:ln/>
+        </p:spPr>
+        <p:txBody>
+          <a:bodyPr wrap="square" lIns="0" tIns="0" rIns="0" bIns="0" rtlCol="0" anchor="ctr"/>
+          <a:lstStyle/>
+          <a:p>
+            <a:pPr indent="0" marL="0">
+              <a:buNone/>
+            </a:pPr>
+            <a:r>
+              <a:rPr lang="en-US" sz="2800" dirty="0">
+                <a:solidFill>
+                  <a:srgbClr val="000000"/>
+                </a:solidFill>
+                <a:latin typeface="Avenir Book" pitchFamily="34" charset="0"/>
+                <a:ea typeface="Avenir Book" pitchFamily="34" charset="-122"/>
+                <a:cs typeface="Avenir Book" pitchFamily="34" charset="-120"/>
+              </a:rPr>
               <a:t>Per-stressor prevalence ratio, by trauma exposure</a:t>
             </a:r>
             <a:endParaRPr lang="en-US" sz="2800" dirty="0"/>
@@ -3232,7 +4088,7 @@
       </p:sp>
       <p:graphicFrame>
         <p:nvGraphicFramePr>
-          <p:cNvPr id="11" name="Table 0"/>
+          <p:cNvPr id="14" name="Table 0"/>
           <p:cNvGraphicFramePr>
             <a:graphicFrameLocks noGrp="1"/>
           </p:cNvGraphicFramePr>
@@ -4266,546 +5122,6 @@
 </p:sld>
 </file>
 
-<file path=ppt/slides/slide11.xml><?xml version="1.0" encoding="utf-8"?>
-<p:sld xmlns:a="http://schemas.openxmlformats.org/drawingml/2006/main" xmlns:r="http://schemas.openxmlformats.org/officeDocument/2006/relationships" xmlns:p="http://schemas.openxmlformats.org/presentationml/2006/main">
-  <p:cSld name="Slide 11">
-    <p:bg>
-      <p:bgPr>
-        <a:solidFill>
-          <a:srgbClr val="FFFFFF"/>
-        </a:solidFill>
-      </p:bgPr>
-    </p:bg>
-    <p:spTree>
-      <p:nvGrpSpPr>
-        <p:cNvPr id="1" name=""/>
-        <p:cNvGrpSpPr/>
-        <p:nvPr/>
-      </p:nvGrpSpPr>
-      <p:grpSpPr>
-        <a:xfrm>
-          <a:off x="0" y="0"/>
-          <a:ext cx="0" cy="0"/>
-          <a:chOff x="0" y="0"/>
-          <a:chExt cx="0" cy="0"/>
-        </a:xfrm>
-      </p:grpSpPr>
-      <p:sp>
-        <p:nvSpPr>
-          <p:cNvPr id="3" name="Text 0"/>
-          <p:cNvSpPr txBox="1"/>
-          <p:nvPr/>
-        </p:nvSpPr>
-        <p:spPr>
-          <a:xfrm>
-            <a:off x="548640" y="411480"/>
-            <a:ext cx="8046720" cy="640080"/>
-          </a:xfrm>
-          <a:prstGeom prst="rect">
-            <a:avLst/>
-          </a:prstGeom>
-          <a:noFill/>
-          <a:ln/>
-        </p:spPr>
-        <p:txBody>
-          <a:bodyPr wrap="square" lIns="0" tIns="0" rIns="0" bIns="0" rtlCol="0" anchor="ctr"/>
-          <a:lstStyle/>
-          <a:p>
-            <a:pPr indent="0" marL="0">
-              <a:buNone/>
-            </a:pPr>
-            <a:r>
-              <a:rPr lang="en-US" sz="2800" dirty="0">
-                <a:solidFill>
-                  <a:srgbClr val="000000"/>
-                </a:solidFill>
-                <a:latin typeface="Avenir Book" pitchFamily="34" charset="0"/>
-                <a:ea typeface="Avenir Book" pitchFamily="34" charset="-122"/>
-                <a:cs typeface="Avenir Book" pitchFamily="34" charset="-120"/>
-              </a:rPr>
-              <a:t>Adjusted PTSD prevalence</a:t>
-            </a:r>
-            <a:endParaRPr lang="en-US" sz="2800" dirty="0"/>
-          </a:p>
-        </p:txBody>
-      </p:sp>
-      <p:graphicFrame>
-        <p:nvGraphicFramePr>
-          <p:cNvPr id="4" name="Chart 0" descr=""/>
-          <p:cNvGraphicFramePr/>
-          <p:nvPr/>
-        </p:nvGraphicFramePr>
-        <p:xfrm>
-          <a:off x="548640" y="1234440"/>
-          <a:ext cx="8046720" cy="3291840"/>
-        </p:xfrm>
-        <a:graphic xmlns:a="http://schemas.openxmlformats.org/drawingml/2006/main">
-          <a:graphicData uri="http://schemas.openxmlformats.org/drawingml/2006/chart">
-            <c:chart xmlns:c="http://schemas.openxmlformats.org/drawingml/2006/chart" r:id="rId1"/>
-          </a:graphicData>
-        </a:graphic>
-      </p:graphicFrame>
-    </p:spTree>
-  </p:cSld>
-  <p:clrMapOvr>
-    <a:masterClrMapping/>
-  </p:clrMapOvr>
-</p:sld>
-</file>
-
-<file path=ppt/slides/slide12.xml><?xml version="1.0" encoding="utf-8"?>
-<p:sld xmlns:a="http://schemas.openxmlformats.org/drawingml/2006/main" xmlns:r="http://schemas.openxmlformats.org/officeDocument/2006/relationships" xmlns:p="http://schemas.openxmlformats.org/presentationml/2006/main">
-  <p:cSld name="Slide 12">
-    <p:bg>
-      <p:bgPr>
-        <a:solidFill>
-          <a:srgbClr val="FFFFFF"/>
-        </a:solidFill>
-      </p:bgPr>
-    </p:bg>
-    <p:spTree>
-      <p:nvGrpSpPr>
-        <p:cNvPr id="1" name=""/>
-        <p:cNvGrpSpPr/>
-        <p:nvPr/>
-      </p:nvGrpSpPr>
-      <p:grpSpPr>
-        <a:xfrm>
-          <a:off x="0" y="0"/>
-          <a:ext cx="0" cy="0"/>
-          <a:chOff x="0" y="0"/>
-          <a:chExt cx="0" cy="0"/>
-        </a:xfrm>
-      </p:grpSpPr>
-      <p:sp>
-        <p:nvSpPr>
-          <p:cNvPr id="3" name="Text 0"/>
-          <p:cNvSpPr txBox="1"/>
-          <p:nvPr/>
-        </p:nvSpPr>
-        <p:spPr>
-          <a:xfrm>
-            <a:off x="548640" y="411480"/>
-            <a:ext cx="8046720" cy="640080"/>
-          </a:xfrm>
-          <a:prstGeom prst="rect">
-            <a:avLst/>
-          </a:prstGeom>
-          <a:noFill/>
-          <a:ln/>
-        </p:spPr>
-        <p:txBody>
-          <a:bodyPr wrap="square" lIns="0" tIns="0" rIns="0" bIns="0" rtlCol="0" anchor="ctr"/>
-          <a:lstStyle/>
-          <a:p>
-            <a:pPr indent="0" marL="0">
-              <a:buNone/>
-            </a:pPr>
-            <a:r>
-              <a:rPr lang="en-US" sz="2800" dirty="0">
-                <a:solidFill>
-                  <a:srgbClr val="000000"/>
-                </a:solidFill>
-                <a:latin typeface="Avenir Book" pitchFamily="34" charset="0"/>
-                <a:ea typeface="Avenir Book" pitchFamily="34" charset="-122"/>
-                <a:cs typeface="Avenir Book" pitchFamily="34" charset="-120"/>
-              </a:rPr>
-              <a:t>Four additional stressors, in percentage points</a:t>
-            </a:r>
-            <a:endParaRPr lang="en-US" sz="2800" dirty="0"/>
-          </a:p>
-        </p:txBody>
-      </p:sp>
-      <p:sp>
-        <p:nvSpPr>
-          <p:cNvPr id="4" name="Text 1"/>
-          <p:cNvSpPr txBox="1"/>
-          <p:nvPr/>
-        </p:nvSpPr>
-        <p:spPr>
-          <a:xfrm>
-            <a:off x="1097280" y="1554480"/>
-            <a:ext cx="3108960" cy="1097280"/>
-          </a:xfrm>
-          <a:prstGeom prst="rect">
-            <a:avLst/>
-          </a:prstGeom>
-          <a:noFill/>
-          <a:ln/>
-        </p:spPr>
-        <p:txBody>
-          <a:bodyPr wrap="square" lIns="0" tIns="0" rIns="0" bIns="0" rtlCol="0" anchor="ctr"/>
-          <a:lstStyle/>
-          <a:p>
-            <a:pPr algn="ctr" indent="0" marL="0">
-              <a:buNone/>
-            </a:pPr>
-            <a:r>
-              <a:rPr lang="en-US" sz="6000" dirty="0">
-                <a:solidFill>
-                  <a:srgbClr val="FF0000"/>
-                </a:solidFill>
-                <a:latin typeface="Avenir Book" pitchFamily="34" charset="0"/>
-                <a:ea typeface="Avenir Book" pitchFamily="34" charset="-122"/>
-                <a:cs typeface="Avenir Book" pitchFamily="34" charset="-120"/>
-              </a:rPr>
-              <a:t>+21.8</a:t>
-            </a:r>
-            <a:endParaRPr lang="en-US" sz="6000" dirty="0"/>
-          </a:p>
-        </p:txBody>
-      </p:sp>
-      <p:sp>
-        <p:nvSpPr>
-          <p:cNvPr id="5" name="Text 2"/>
-          <p:cNvSpPr txBox="1"/>
-          <p:nvPr/>
-        </p:nvSpPr>
-        <p:spPr>
-          <a:xfrm>
-            <a:off x="1097280" y="2651760"/>
-            <a:ext cx="3108960" cy="731520"/>
-          </a:xfrm>
-          <a:prstGeom prst="rect">
-            <a:avLst/>
-          </a:prstGeom>
-          <a:noFill/>
-          <a:ln/>
-        </p:spPr>
-        <p:txBody>
-          <a:bodyPr wrap="square" lIns="0" tIns="0" rIns="0" bIns="0" rtlCol="0" anchor="ctr"/>
-          <a:lstStyle/>
-          <a:p>
-            <a:pPr algn="ctr" indent="0" marL="0">
-              <a:buNone/>
-            </a:pPr>
-            <a:r>
-              <a:rPr lang="en-US" sz="1400" dirty="0">
-                <a:solidFill>
-                  <a:srgbClr val="000000"/>
-                </a:solidFill>
-                <a:latin typeface="Avenir Book" pitchFamily="34" charset="0"/>
-                <a:ea typeface="Avenir Book" pitchFamily="34" charset="-122"/>
-                <a:cs typeface="Avenir Book" pitchFamily="34" charset="-120"/>
-              </a:rPr>
-              <a:t>no trauma exposure</a:t>
-            </a:r>
-            <a:endParaRPr lang="en-US" sz="1400" dirty="0"/>
-          </a:p>
-          <a:p>
-            <a:pPr algn="ctr" indent="0" marL="0">
-              <a:buNone/>
-            </a:pPr>
-            <a:r>
-              <a:rPr lang="en-US" sz="1400" dirty="0">
-                <a:solidFill>
-                  <a:srgbClr val="000000"/>
-                </a:solidFill>
-                <a:latin typeface="Avenir Book" pitchFamily="34" charset="0"/>
-                <a:ea typeface="Avenir Book" pitchFamily="34" charset="-122"/>
-                <a:cs typeface="Avenir Book" pitchFamily="34" charset="-120"/>
-              </a:rPr>
-              <a:t>(95% CI 7.2–36.5)</a:t>
-            </a:r>
-            <a:endParaRPr lang="en-US" sz="1400" dirty="0"/>
-          </a:p>
-        </p:txBody>
-      </p:sp>
-      <p:sp>
-        <p:nvSpPr>
-          <p:cNvPr id="6" name="Text 3"/>
-          <p:cNvSpPr txBox="1"/>
-          <p:nvPr/>
-        </p:nvSpPr>
-        <p:spPr>
-          <a:xfrm>
-            <a:off x="4937760" y="1554480"/>
-            <a:ext cx="3108960" cy="1097280"/>
-          </a:xfrm>
-          <a:prstGeom prst="rect">
-            <a:avLst/>
-          </a:prstGeom>
-          <a:noFill/>
-          <a:ln/>
-        </p:spPr>
-        <p:txBody>
-          <a:bodyPr wrap="square" lIns="0" tIns="0" rIns="0" bIns="0" rtlCol="0" anchor="ctr"/>
-          <a:lstStyle/>
-          <a:p>
-            <a:pPr algn="ctr" indent="0" marL="0">
-              <a:buNone/>
-            </a:pPr>
-            <a:r>
-              <a:rPr lang="en-US" sz="6000" dirty="0">
-                <a:solidFill>
-                  <a:srgbClr val="000000"/>
-                </a:solidFill>
-                <a:latin typeface="Avenir Book" pitchFamily="34" charset="0"/>
-                <a:ea typeface="Avenir Book" pitchFamily="34" charset="-122"/>
-                <a:cs typeface="Avenir Book" pitchFamily="34" charset="-120"/>
-              </a:rPr>
-              <a:t>−2.5</a:t>
-            </a:r>
-            <a:endParaRPr lang="en-US" sz="6000" dirty="0"/>
-          </a:p>
-        </p:txBody>
-      </p:sp>
-      <p:sp>
-        <p:nvSpPr>
-          <p:cNvPr id="7" name="Text 4"/>
-          <p:cNvSpPr txBox="1"/>
-          <p:nvPr/>
-        </p:nvSpPr>
-        <p:spPr>
-          <a:xfrm>
-            <a:off x="4937760" y="2651760"/>
-            <a:ext cx="3108960" cy="731520"/>
-          </a:xfrm>
-          <a:prstGeom prst="rect">
-            <a:avLst/>
-          </a:prstGeom>
-          <a:noFill/>
-          <a:ln/>
-        </p:spPr>
-        <p:txBody>
-          <a:bodyPr wrap="square" lIns="0" tIns="0" rIns="0" bIns="0" rtlCol="0" anchor="ctr"/>
-          <a:lstStyle/>
-          <a:p>
-            <a:pPr algn="ctr" indent="0" marL="0">
-              <a:buNone/>
-            </a:pPr>
-            <a:r>
-              <a:rPr lang="en-US" sz="1400" dirty="0">
-                <a:solidFill>
-                  <a:srgbClr val="000000"/>
-                </a:solidFill>
-                <a:latin typeface="Avenir Book" pitchFamily="34" charset="0"/>
-                <a:ea typeface="Avenir Book" pitchFamily="34" charset="-122"/>
-                <a:cs typeface="Avenir Book" pitchFamily="34" charset="-120"/>
-              </a:rPr>
-              <a:t>five or more events</a:t>
-            </a:r>
-            <a:endParaRPr lang="en-US" sz="1400" dirty="0"/>
-          </a:p>
-          <a:p>
-            <a:pPr algn="ctr" indent="0" marL="0">
-              <a:buNone/>
-            </a:pPr>
-            <a:r>
-              <a:rPr lang="en-US" sz="1400" dirty="0">
-                <a:solidFill>
-                  <a:srgbClr val="000000"/>
-                </a:solidFill>
-                <a:latin typeface="Avenir Book" pitchFamily="34" charset="0"/>
-                <a:ea typeface="Avenir Book" pitchFamily="34" charset="-122"/>
-                <a:cs typeface="Avenir Book" pitchFamily="34" charset="-120"/>
-              </a:rPr>
-              <a:t>(95% CI −18.3 to +13.4)</a:t>
-            </a:r>
-            <a:endParaRPr lang="en-US" sz="1400" dirty="0"/>
-          </a:p>
-        </p:txBody>
-      </p:sp>
-      <p:sp>
-        <p:nvSpPr>
-          <p:cNvPr id="8" name="Text 5"/>
-          <p:cNvSpPr txBox="1"/>
-          <p:nvPr/>
-        </p:nvSpPr>
-        <p:spPr>
-          <a:xfrm>
-            <a:off x="548640" y="3840480"/>
-            <a:ext cx="8046720" cy="457200"/>
-          </a:xfrm>
-          <a:prstGeom prst="rect">
-            <a:avLst/>
-          </a:prstGeom>
-          <a:noFill/>
-          <a:ln/>
-        </p:spPr>
-        <p:txBody>
-          <a:bodyPr wrap="square" lIns="0" tIns="0" rIns="0" bIns="0" rtlCol="0" anchor="ctr"/>
-          <a:lstStyle/>
-          <a:p>
-            <a:pPr algn="ctr" indent="0" marL="0">
-              <a:buNone/>
-            </a:pPr>
-            <a:r>
-              <a:rPr lang="en-US" sz="1600" dirty="0">
-                <a:solidFill>
-                  <a:srgbClr val="000000"/>
-                </a:solidFill>
-                <a:latin typeface="Avenir Book" pitchFamily="34" charset="0"/>
-                <a:ea typeface="Avenir Book" pitchFamily="34" charset="-122"/>
-                <a:cs typeface="Avenir Book" pitchFamily="34" charset="-120"/>
-              </a:rPr>
-              <a:t>Depression: +24.1 vs +3.5   ·   Anxiety: +17.8 vs −4.0</a:t>
-            </a:r>
-            <a:endParaRPr lang="en-US" sz="1600" dirty="0"/>
-          </a:p>
-        </p:txBody>
-      </p:sp>
-    </p:spTree>
-  </p:cSld>
-  <p:clrMapOvr>
-    <a:masterClrMapping/>
-  </p:clrMapOvr>
-</p:sld>
-</file>
-
-<file path=ppt/slides/slide13.xml><?xml version="1.0" encoding="utf-8"?>
-<p:sld xmlns:a="http://schemas.openxmlformats.org/drawingml/2006/main" xmlns:r="http://schemas.openxmlformats.org/officeDocument/2006/relationships" xmlns:p="http://schemas.openxmlformats.org/presentationml/2006/main">
-  <p:cSld name="Slide 13">
-    <p:bg>
-      <p:bgPr>
-        <a:solidFill>
-          <a:srgbClr val="FFFFFF"/>
-        </a:solidFill>
-      </p:bgPr>
-    </p:bg>
-    <p:spTree>
-      <p:nvGrpSpPr>
-        <p:cNvPr id="1" name=""/>
-        <p:cNvGrpSpPr/>
-        <p:nvPr/>
-      </p:nvGrpSpPr>
-      <p:grpSpPr>
-        <a:xfrm>
-          <a:off x="0" y="0"/>
-          <a:ext cx="0" cy="0"/>
-          <a:chOff x="0" y="0"/>
-          <a:chExt cx="0" cy="0"/>
-        </a:xfrm>
-      </p:grpSpPr>
-      <p:sp>
-        <p:nvSpPr>
-          <p:cNvPr id="3" name="Text 0"/>
-          <p:cNvSpPr txBox="1"/>
-          <p:nvPr/>
-        </p:nvSpPr>
-        <p:spPr>
-          <a:xfrm>
-            <a:off x="548640" y="411480"/>
-            <a:ext cx="8046720" cy="640080"/>
-          </a:xfrm>
-          <a:prstGeom prst="rect">
-            <a:avLst/>
-          </a:prstGeom>
-          <a:noFill/>
-          <a:ln/>
-        </p:spPr>
-        <p:txBody>
-          <a:bodyPr wrap="square" lIns="0" tIns="0" rIns="0" bIns="0" rtlCol="0" anchor="ctr"/>
-          <a:lstStyle/>
-          <a:p>
-            <a:pPr indent="0" marL="0">
-              <a:buNone/>
-            </a:pPr>
-            <a:r>
-              <a:rPr lang="en-US" sz="2800" dirty="0">
-                <a:solidFill>
-                  <a:srgbClr val="000000"/>
-                </a:solidFill>
-                <a:latin typeface="Avenir Book" pitchFamily="34" charset="0"/>
-                <a:ea typeface="Avenir Book" pitchFamily="34" charset="-122"/>
-                <a:cs typeface="Avenir Book" pitchFamily="34" charset="-120"/>
-              </a:rPr>
-              <a:t>Robustness</a:t>
-            </a:r>
-            <a:endParaRPr lang="en-US" sz="2800" dirty="0"/>
-          </a:p>
-        </p:txBody>
-      </p:sp>
-      <p:sp>
-        <p:nvSpPr>
-          <p:cNvPr id="4" name="Text 1"/>
-          <p:cNvSpPr txBox="1"/>
-          <p:nvPr/>
-        </p:nvSpPr>
-        <p:spPr>
-          <a:xfrm>
-            <a:off x="548640" y="1371600"/>
-            <a:ext cx="8046720" cy="3291840"/>
-          </a:xfrm>
-          <a:prstGeom prst="rect">
-            <a:avLst/>
-          </a:prstGeom>
-          <a:noFill/>
-          <a:ln/>
-        </p:spPr>
-        <p:txBody>
-          <a:bodyPr wrap="square" lIns="0" tIns="0" rIns="0" bIns="0" rtlCol="0" anchor="t"/>
-          <a:lstStyle/>
-          <a:p>
-            <a:pPr indent="0" marL="0">
-              <a:spcAft>
-                <a:spcPts val="1400"/>
-              </a:spcAft>
-              <a:buNone/>
-            </a:pPr>
-            <a:r>
-              <a:rPr lang="en-US" sz="2000" dirty="0">
-                <a:solidFill>
-                  <a:srgbClr val="000000"/>
-                </a:solidFill>
-                <a:latin typeface="Avenir Book" pitchFamily="34" charset="0"/>
-                <a:ea typeface="Avenir Book" pitchFamily="34" charset="-122"/>
-                <a:cs typeface="Avenir Book" pitchFamily="34" charset="-120"/>
-              </a:rPr>
-              <a:t>Alternative thresholds (PCL-5≥33, PHQ-9≥15, GAD-7≥7): all p≤0.0002</a:t>
-            </a:r>
-            <a:endParaRPr lang="en-US" sz="2000" dirty="0"/>
-          </a:p>
-          <a:p>
-            <a:pPr indent="0" marL="0">
-              <a:spcAft>
-                <a:spcPts val="1400"/>
-              </a:spcAft>
-              <a:buNone/>
-            </a:pPr>
-            <a:r>
-              <a:rPr lang="en-US" sz="2000" dirty="0">
-                <a:solidFill>
-                  <a:srgbClr val="000000"/>
-                </a:solidFill>
-                <a:latin typeface="Avenir Book" pitchFamily="34" charset="0"/>
-                <a:ea typeface="Avenir Book" pitchFamily="34" charset="-122"/>
-                <a:cs typeface="Avenir Book" pitchFamily="34" charset="-120"/>
-              </a:rPr>
-              <a:t>Continuous symptom scores: all p≤0.0001</a:t>
-            </a:r>
-            <a:endParaRPr lang="en-US" sz="2000" dirty="0"/>
-          </a:p>
-          <a:p>
-            <a:pPr indent="0" marL="0">
-              <a:spcAft>
-                <a:spcPts val="1400"/>
-              </a:spcAft>
-              <a:buNone/>
-            </a:pPr>
-            <a:r>
-              <a:rPr lang="en-US" sz="2000" dirty="0">
-                <a:solidFill>
-                  <a:srgbClr val="000000"/>
-                </a:solidFill>
-                <a:latin typeface="Avenir Book" pitchFamily="34" charset="0"/>
-                <a:ea typeface="Avenir Book" pitchFamily="34" charset="-122"/>
-                <a:cs typeface="Avenir Book" pitchFamily="34" charset="-120"/>
-              </a:rPr>
-              <a:t>Categorical trauma specification: same pattern</a:t>
-            </a:r>
-            <a:endParaRPr lang="en-US" sz="2000" dirty="0"/>
-          </a:p>
-        </p:txBody>
-      </p:sp>
-    </p:spTree>
-  </p:cSld>
-  <p:clrMapOvr>
-    <a:masterClrMapping/>
-  </p:clrMapOvr>
-</p:sld>
-</file>
-
 <file path=ppt/slides/slide14.xml><?xml version="1.0" encoding="utf-8"?>
 <p:sld xmlns:a="http://schemas.openxmlformats.org/drawingml/2006/main" xmlns:r="http://schemas.openxmlformats.org/officeDocument/2006/relationships" xmlns:p="http://schemas.openxmlformats.org/presentationml/2006/main">
   <p:cSld name="Slide 14">
@@ -4838,8 +5154,8 @@
         </p:nvSpPr>
         <p:spPr>
           <a:xfrm>
-            <a:off x="731520" y="2011680"/>
-            <a:ext cx="7680960" cy="1097280"/>
+            <a:off x="548640" y="411480"/>
+            <a:ext cx="8046720" cy="640080"/>
           </a:xfrm>
           <a:prstGeom prst="rect">
             <a:avLst/>
@@ -4851,11 +5167,11 @@
           <a:bodyPr wrap="square" lIns="0" tIns="0" rIns="0" bIns="0" rtlCol="0" anchor="ctr"/>
           <a:lstStyle/>
           <a:p>
-            <a:pPr algn="ctr" indent="0" marL="0">
-              <a:buNone/>
-            </a:pPr>
-            <a:r>
-              <a:rPr lang="en-US" sz="3000" dirty="0">
+            <a:pPr indent="0" marL="0">
+              <a:buNone/>
+            </a:pPr>
+            <a:r>
+              <a:rPr lang="en-US" sz="2800" dirty="0">
                 <a:solidFill>
                   <a:srgbClr val="000000"/>
                 </a:solidFill>
@@ -4863,12 +5179,28 @@
                 <a:ea typeface="Avenir Book" pitchFamily="34" charset="-122"/>
                 <a:cs typeface="Avenir Book" pitchFamily="34" charset="-120"/>
               </a:rPr>
-              <a:t>The stress gradient lives among the least trauma-exposed.</a:t>
-            </a:r>
-            <a:endParaRPr lang="en-US" sz="3000" dirty="0"/>
-          </a:p>
-        </p:txBody>
-      </p:sp>
+              <a:t>Adjusted PTSD prevalence</a:t>
+            </a:r>
+            <a:endParaRPr lang="en-US" sz="2800" dirty="0"/>
+          </a:p>
+        </p:txBody>
+      </p:sp>
+      <p:graphicFrame>
+        <p:nvGraphicFramePr>
+          <p:cNvPr id="4" name="Chart 0" descr=""/>
+          <p:cNvGraphicFramePr/>
+          <p:nvPr/>
+        </p:nvGraphicFramePr>
+        <p:xfrm>
+          <a:off x="548640" y="1234440"/>
+          <a:ext cx="8046720" cy="3291840"/>
+        </p:xfrm>
+        <a:graphic xmlns:a="http://schemas.openxmlformats.org/drawingml/2006/main">
+          <a:graphicData uri="http://schemas.openxmlformats.org/drawingml/2006/chart">
+            <c:chart xmlns:c="http://schemas.openxmlformats.org/drawingml/2006/chart" r:id="rId1"/>
+          </a:graphicData>
+        </a:graphic>
+      </p:graphicFrame>
     </p:spTree>
   </p:cSld>
   <p:clrMapOvr>
@@ -4909,8 +5241,8 @@
         </p:nvSpPr>
         <p:spPr>
           <a:xfrm>
-            <a:off x="3108960" y="1463040"/>
-            <a:ext cx="3657600" cy="2377440"/>
+            <a:off x="548640" y="411480"/>
+            <a:ext cx="8046720" cy="640080"/>
           </a:xfrm>
           <a:prstGeom prst="rect">
             <a:avLst/>
@@ -4923,13 +5255,10 @@
           <a:lstStyle/>
           <a:p>
             <a:pPr indent="0" marL="0">
-              <a:spcAft>
-                <a:spcPts val="1800"/>
-              </a:spcAft>
-              <a:buNone/>
-            </a:pPr>
-            <a:r>
-              <a:rPr lang="en-US" sz="2400" dirty="0">
+              <a:buNone/>
+            </a:pPr>
+            <a:r>
+              <a:rPr lang="en-US" sz="2800" dirty="0">
                 <a:solidFill>
                   <a:srgbClr val="000000"/>
                 </a:solidFill>
@@ -4937,19 +5266,77 @@
                 <a:ea typeface="Avenir Book" pitchFamily="34" charset="-122"/>
                 <a:cs typeface="Avenir Book" pitchFamily="34" charset="-120"/>
               </a:rPr>
-              <a:t>1. Background</a:t>
-            </a:r>
-            <a:endParaRPr lang="en-US" sz="2400" dirty="0"/>
-          </a:p>
-          <a:p>
-            <a:pPr indent="0" marL="0">
-              <a:spcAft>
-                <a:spcPts val="1800"/>
-              </a:spcAft>
-              <a:buNone/>
-            </a:pPr>
-            <a:r>
-              <a:rPr lang="en-US" sz="2400" dirty="0">
+              <a:t>Four additional stressors, in percentage points</a:t>
+            </a:r>
+            <a:endParaRPr lang="en-US" sz="2800" dirty="0"/>
+          </a:p>
+        </p:txBody>
+      </p:sp>
+      <p:sp>
+        <p:nvSpPr>
+          <p:cNvPr id="4" name="Text 1"/>
+          <p:cNvSpPr txBox="1"/>
+          <p:nvPr/>
+        </p:nvSpPr>
+        <p:spPr>
+          <a:xfrm>
+            <a:off x="1097280" y="1554480"/>
+            <a:ext cx="3108960" cy="1097280"/>
+          </a:xfrm>
+          <a:prstGeom prst="rect">
+            <a:avLst/>
+          </a:prstGeom>
+          <a:noFill/>
+          <a:ln/>
+        </p:spPr>
+        <p:txBody>
+          <a:bodyPr wrap="square" lIns="0" tIns="0" rIns="0" bIns="0" rtlCol="0" anchor="ctr"/>
+          <a:lstStyle/>
+          <a:p>
+            <a:pPr algn="ctr" indent="0" marL="0">
+              <a:buNone/>
+            </a:pPr>
+            <a:r>
+              <a:rPr lang="en-US" sz="6000" dirty="0">
+                <a:solidFill>
+                  <a:srgbClr val="FF0000"/>
+                </a:solidFill>
+                <a:latin typeface="Avenir Book" pitchFamily="34" charset="0"/>
+                <a:ea typeface="Avenir Book" pitchFamily="34" charset="-122"/>
+                <a:cs typeface="Avenir Book" pitchFamily="34" charset="-120"/>
+              </a:rPr>
+              <a:t>+21.8</a:t>
+            </a:r>
+            <a:endParaRPr lang="en-US" sz="6000" dirty="0"/>
+          </a:p>
+        </p:txBody>
+      </p:sp>
+      <p:sp>
+        <p:nvSpPr>
+          <p:cNvPr id="5" name="Text 2"/>
+          <p:cNvSpPr txBox="1"/>
+          <p:nvPr/>
+        </p:nvSpPr>
+        <p:spPr>
+          <a:xfrm>
+            <a:off x="1097280" y="2651760"/>
+            <a:ext cx="3108960" cy="731520"/>
+          </a:xfrm>
+          <a:prstGeom prst="rect">
+            <a:avLst/>
+          </a:prstGeom>
+          <a:noFill/>
+          <a:ln/>
+        </p:spPr>
+        <p:txBody>
+          <a:bodyPr wrap="square" lIns="0" tIns="0" rIns="0" bIns="0" rtlCol="0" anchor="ctr"/>
+          <a:lstStyle/>
+          <a:p>
+            <a:pPr algn="ctr" indent="0" marL="0">
+              <a:buNone/>
+            </a:pPr>
+            <a:r>
+              <a:rPr lang="en-US" sz="1400" dirty="0">
                 <a:solidFill>
                   <a:srgbClr val="000000"/>
                 </a:solidFill>
@@ -4957,19 +5344,16 @@
                 <a:ea typeface="Avenir Book" pitchFamily="34" charset="-122"/>
                 <a:cs typeface="Avenir Book" pitchFamily="34" charset="-120"/>
               </a:rPr>
-              <a:t>2. Methods</a:t>
-            </a:r>
-            <a:endParaRPr lang="en-US" sz="2400" dirty="0"/>
-          </a:p>
-          <a:p>
-            <a:pPr indent="0" marL="0">
-              <a:spcAft>
-                <a:spcPts val="1800"/>
-              </a:spcAft>
-              <a:buNone/>
-            </a:pPr>
-            <a:r>
-              <a:rPr lang="en-US" sz="2400" dirty="0">
+              <a:t>no trauma exposure</a:t>
+            </a:r>
+            <a:endParaRPr lang="en-US" sz="1400" dirty="0"/>
+          </a:p>
+          <a:p>
+            <a:pPr algn="ctr" indent="0" marL="0">
+              <a:buNone/>
+            </a:pPr>
+            <a:r>
+              <a:rPr lang="en-US" sz="1400" dirty="0">
                 <a:solidFill>
                   <a:srgbClr val="000000"/>
                 </a:solidFill>
@@ -4977,29 +5361,104 @@
                 <a:ea typeface="Avenir Book" pitchFamily="34" charset="-122"/>
                 <a:cs typeface="Avenir Book" pitchFamily="34" charset="-120"/>
               </a:rPr>
-              <a:t>3. Results</a:t>
-            </a:r>
-            <a:endParaRPr lang="en-US" sz="2400" dirty="0"/>
-          </a:p>
-          <a:p>
-            <a:pPr indent="0" marL="0">
-              <a:spcAft>
-                <a:spcPts val="1800"/>
-              </a:spcAft>
-              <a:buNone/>
-            </a:pPr>
-            <a:r>
-              <a:rPr lang="en-US" sz="2400" dirty="0">
-                <a:solidFill>
-                  <a:srgbClr val="FF0000"/>
-                </a:solidFill>
-                <a:latin typeface="Avenir Book" pitchFamily="34" charset="0"/>
-                <a:ea typeface="Avenir Book" pitchFamily="34" charset="-122"/>
-                <a:cs typeface="Avenir Book" pitchFamily="34" charset="-120"/>
-              </a:rPr>
-              <a:t>4. Discussion</a:t>
-            </a:r>
-            <a:endParaRPr lang="en-US" sz="2400" dirty="0"/>
+              <a:t>(95% CI 7.2–36.5)</a:t>
+            </a:r>
+            <a:endParaRPr lang="en-US" sz="1400" dirty="0"/>
+          </a:p>
+        </p:txBody>
+      </p:sp>
+      <p:sp>
+        <p:nvSpPr>
+          <p:cNvPr id="6" name="Text 3"/>
+          <p:cNvSpPr txBox="1"/>
+          <p:nvPr/>
+        </p:nvSpPr>
+        <p:spPr>
+          <a:xfrm>
+            <a:off x="4937760" y="1554480"/>
+            <a:ext cx="3108960" cy="1097280"/>
+          </a:xfrm>
+          <a:prstGeom prst="rect">
+            <a:avLst/>
+          </a:prstGeom>
+          <a:noFill/>
+          <a:ln/>
+        </p:spPr>
+        <p:txBody>
+          <a:bodyPr wrap="square" lIns="0" tIns="0" rIns="0" bIns="0" rtlCol="0" anchor="ctr"/>
+          <a:lstStyle/>
+          <a:p>
+            <a:pPr algn="ctr" indent="0" marL="0">
+              <a:buNone/>
+            </a:pPr>
+            <a:r>
+              <a:rPr lang="en-US" sz="6000" dirty="0">
+                <a:solidFill>
+                  <a:srgbClr val="000000"/>
+                </a:solidFill>
+                <a:latin typeface="Avenir Book" pitchFamily="34" charset="0"/>
+                <a:ea typeface="Avenir Book" pitchFamily="34" charset="-122"/>
+                <a:cs typeface="Avenir Book" pitchFamily="34" charset="-120"/>
+              </a:rPr>
+              <a:t>−2.5</a:t>
+            </a:r>
+            <a:endParaRPr lang="en-US" sz="6000" dirty="0"/>
+          </a:p>
+        </p:txBody>
+      </p:sp>
+      <p:sp>
+        <p:nvSpPr>
+          <p:cNvPr id="7" name="Text 4"/>
+          <p:cNvSpPr txBox="1"/>
+          <p:nvPr/>
+        </p:nvSpPr>
+        <p:spPr>
+          <a:xfrm>
+            <a:off x="4937760" y="2651760"/>
+            <a:ext cx="3108960" cy="731520"/>
+          </a:xfrm>
+          <a:prstGeom prst="rect">
+            <a:avLst/>
+          </a:prstGeom>
+          <a:noFill/>
+          <a:ln/>
+        </p:spPr>
+        <p:txBody>
+          <a:bodyPr wrap="square" lIns="0" tIns="0" rIns="0" bIns="0" rtlCol="0" anchor="ctr"/>
+          <a:lstStyle/>
+          <a:p>
+            <a:pPr algn="ctr" indent="0" marL="0">
+              <a:buNone/>
+            </a:pPr>
+            <a:r>
+              <a:rPr lang="en-US" sz="1400" dirty="0">
+                <a:solidFill>
+                  <a:srgbClr val="000000"/>
+                </a:solidFill>
+                <a:latin typeface="Avenir Book" pitchFamily="34" charset="0"/>
+                <a:ea typeface="Avenir Book" pitchFamily="34" charset="-122"/>
+                <a:cs typeface="Avenir Book" pitchFamily="34" charset="-120"/>
+              </a:rPr>
+              <a:t>five or more events</a:t>
+            </a:r>
+            <a:endParaRPr lang="en-US" sz="1400" dirty="0"/>
+          </a:p>
+          <a:p>
+            <a:pPr algn="ctr" indent="0" marL="0">
+              <a:buNone/>
+            </a:pPr>
+            <a:r>
+              <a:rPr lang="en-US" sz="1400" dirty="0">
+                <a:solidFill>
+                  <a:srgbClr val="000000"/>
+                </a:solidFill>
+                <a:latin typeface="Avenir Book" pitchFamily="34" charset="0"/>
+                <a:ea typeface="Avenir Book" pitchFamily="34" charset="-122"/>
+                <a:cs typeface="Avenir Book" pitchFamily="34" charset="-120"/>
+              </a:rPr>
+              <a:t>(95% CI −18.3 to +13.4)</a:t>
+            </a:r>
+            <a:endParaRPr lang="en-US" sz="1400" dirty="0"/>
           </a:p>
         </p:txBody>
       </p:sp>
@@ -5068,7 +5527,7 @@
                 <a:ea typeface="Avenir Book" pitchFamily="34" charset="-122"/>
                 <a:cs typeface="Avenir Book" pitchFamily="34" charset="-120"/>
               </a:rPr>
-              <a:t>What this means</a:t>
+              <a:t>Depression and anxiety: the same pattern</a:t>
             </a:r>
             <a:endParaRPr lang="en-US" sz="2800" dirty="0"/>
           </a:p>
@@ -5110,7 +5569,7 @@
                 <a:ea typeface="Avenir Book" pitchFamily="34" charset="-122"/>
                 <a:cs typeface="Avenir Book" pitchFamily="34" charset="-120"/>
               </a:rPr>
-              <a:t>Match intervention to trauma history, not one program for all</a:t>
+              <a:t>Depression: +24.1 points at zero trauma (5%→29%); +3.5, null, at five events</a:t>
             </a:r>
             <a:endParaRPr lang="en-US" sz="2000" dirty="0"/>
           </a:p>
@@ -5130,7 +5589,7 @@
                 <a:ea typeface="Avenir Book" pitchFamily="34" charset="-122"/>
                 <a:cs typeface="Avenir Book" pitchFamily="34" charset="-120"/>
               </a:rPr>
-              <a:t>Stress-focused support where sensitivity is retained</a:t>
+              <a:t>Anxiety: +17.8 points at zero trauma; −4.0, null, at five events</a:t>
             </a:r>
             <a:endParaRPr lang="en-US" sz="2000" dirty="0"/>
           </a:p>
@@ -5150,27 +5609,7 @@
                 <a:ea typeface="Avenir Book" pitchFamily="34" charset="-122"/>
                 <a:cs typeface="Avenir Book" pitchFamily="34" charset="-120"/>
               </a:rPr>
-              <a:t>Trauma-focused therapies where exposure is extensive</a:t>
-            </a:r>
-            <a:endParaRPr lang="en-US" sz="2000" dirty="0"/>
-          </a:p>
-          <a:p>
-            <a:pPr indent="0" marL="0">
-              <a:spcAft>
-                <a:spcPts val="200"/>
-              </a:spcAft>
-              <a:buNone/>
-            </a:pPr>
-            <a:r>
-              <a:rPr lang="en-US" sz="2000" dirty="0">
-                <a:solidFill>
-                  <a:srgbClr val="000000"/>
-                </a:solidFill>
-                <a:latin typeface="Avenir Book" pitchFamily="34" charset="0"/>
-                <a:ea typeface="Avenir Book" pitchFamily="34" charset="-122"/>
-                <a:cs typeface="Avenir Book" pitchFamily="34" charset="-120"/>
-              </a:rPr>
-              <a:t>Limits: cross-sectional; recall; sparse data above six events</a:t>
+              <a:t>Robust: alternative thresholds and continuous scores, all p ≤ 0.0002</a:t>
             </a:r>
             <a:endParaRPr lang="en-US" sz="2000" dirty="0"/>
           </a:p>
@@ -5216,8 +5655,8 @@
         </p:nvSpPr>
         <p:spPr>
           <a:xfrm>
-            <a:off x="731520" y="2286000"/>
-            <a:ext cx="7680960" cy="548640"/>
+            <a:off x="731520" y="2011680"/>
+            <a:ext cx="7680960" cy="1097280"/>
           </a:xfrm>
           <a:prstGeom prst="rect">
             <a:avLst/>
@@ -5233,7 +5672,7 @@
               <a:buNone/>
             </a:pPr>
             <a:r>
-              <a:rPr lang="en-US" sz="2200" dirty="0">
+              <a:rPr lang="en-US" sz="3000" dirty="0">
                 <a:solidFill>
                   <a:srgbClr val="000000"/>
                 </a:solidFill>
@@ -5241,9 +5680,316 @@
                 <a:ea typeface="Avenir Book" pitchFamily="34" charset="-122"/>
                 <a:cs typeface="Avenir Book" pitchFamily="34" charset="-120"/>
               </a:rPr>
-              <a:t>[your preferred email]</a:t>
-            </a:r>
-            <a:endParaRPr lang="en-US" sz="2200" dirty="0"/>
+              <a:t>The stress gradient lives among the least trauma-exposed.</a:t>
+            </a:r>
+            <a:endParaRPr lang="en-US" sz="3000" dirty="0"/>
+          </a:p>
+        </p:txBody>
+      </p:sp>
+    </p:spTree>
+  </p:cSld>
+  <p:clrMapOvr>
+    <a:masterClrMapping/>
+  </p:clrMapOvr>
+</p:sld>
+</file>
+
+<file path=ppt/slides/slide18.xml><?xml version="1.0" encoding="utf-8"?>
+<p:sld xmlns:a="http://schemas.openxmlformats.org/drawingml/2006/main" xmlns:r="http://schemas.openxmlformats.org/officeDocument/2006/relationships" xmlns:p="http://schemas.openxmlformats.org/presentationml/2006/main">
+  <p:cSld name="Slide 18">
+    <p:bg>
+      <p:bgPr>
+        <a:solidFill>
+          <a:srgbClr val="FFFFFF"/>
+        </a:solidFill>
+      </p:bgPr>
+    </p:bg>
+    <p:spTree>
+      <p:nvGrpSpPr>
+        <p:cNvPr id="1" name=""/>
+        <p:cNvGrpSpPr/>
+        <p:nvPr/>
+      </p:nvGrpSpPr>
+      <p:grpSpPr>
+        <a:xfrm>
+          <a:off x="0" y="0"/>
+          <a:ext cx="0" cy="0"/>
+          <a:chOff x="0" y="0"/>
+          <a:chExt cx="0" cy="0"/>
+        </a:xfrm>
+      </p:grpSpPr>
+      <p:sp>
+        <p:nvSpPr>
+          <p:cNvPr id="3" name="Text 0"/>
+          <p:cNvSpPr txBox="1"/>
+          <p:nvPr/>
+        </p:nvSpPr>
+        <p:spPr>
+          <a:xfrm>
+            <a:off x="3108960" y="1463040"/>
+            <a:ext cx="3657600" cy="2377440"/>
+          </a:xfrm>
+          <a:prstGeom prst="rect">
+            <a:avLst/>
+          </a:prstGeom>
+          <a:noFill/>
+          <a:ln/>
+        </p:spPr>
+        <p:txBody>
+          <a:bodyPr wrap="square" lIns="0" tIns="0" rIns="0" bIns="0" rtlCol="0" anchor="ctr"/>
+          <a:lstStyle/>
+          <a:p>
+            <a:pPr indent="0" marL="0">
+              <a:spcAft>
+                <a:spcPts val="1800"/>
+              </a:spcAft>
+              <a:buNone/>
+            </a:pPr>
+            <a:r>
+              <a:rPr lang="en-US" sz="2400" dirty="0">
+                <a:solidFill>
+                  <a:srgbClr val="000000"/>
+                </a:solidFill>
+                <a:latin typeface="Avenir Book" pitchFamily="34" charset="0"/>
+                <a:ea typeface="Avenir Book" pitchFamily="34" charset="-122"/>
+                <a:cs typeface="Avenir Book" pitchFamily="34" charset="-120"/>
+              </a:rPr>
+              <a:t>1. Background</a:t>
+            </a:r>
+            <a:endParaRPr lang="en-US" sz="2400" dirty="0"/>
+          </a:p>
+          <a:p>
+            <a:pPr indent="0" marL="0">
+              <a:spcAft>
+                <a:spcPts val="1800"/>
+              </a:spcAft>
+              <a:buNone/>
+            </a:pPr>
+            <a:r>
+              <a:rPr lang="en-US" sz="2400" dirty="0">
+                <a:solidFill>
+                  <a:srgbClr val="000000"/>
+                </a:solidFill>
+                <a:latin typeface="Avenir Book" pitchFamily="34" charset="0"/>
+                <a:ea typeface="Avenir Book" pitchFamily="34" charset="-122"/>
+                <a:cs typeface="Avenir Book" pitchFamily="34" charset="-120"/>
+              </a:rPr>
+              <a:t>2. Methods</a:t>
+            </a:r>
+            <a:endParaRPr lang="en-US" sz="2400" dirty="0"/>
+          </a:p>
+          <a:p>
+            <a:pPr indent="0" marL="0">
+              <a:spcAft>
+                <a:spcPts val="1800"/>
+              </a:spcAft>
+              <a:buNone/>
+            </a:pPr>
+            <a:r>
+              <a:rPr lang="en-US" sz="2400" dirty="0">
+                <a:solidFill>
+                  <a:srgbClr val="000000"/>
+                </a:solidFill>
+                <a:latin typeface="Avenir Book" pitchFamily="34" charset="0"/>
+                <a:ea typeface="Avenir Book" pitchFamily="34" charset="-122"/>
+                <a:cs typeface="Avenir Book" pitchFamily="34" charset="-120"/>
+              </a:rPr>
+              <a:t>3. Results</a:t>
+            </a:r>
+            <a:endParaRPr lang="en-US" sz="2400" dirty="0"/>
+          </a:p>
+          <a:p>
+            <a:pPr indent="0" marL="0">
+              <a:spcAft>
+                <a:spcPts val="1800"/>
+              </a:spcAft>
+              <a:buNone/>
+            </a:pPr>
+            <a:r>
+              <a:rPr lang="en-US" sz="2400" dirty="0">
+                <a:solidFill>
+                  <a:srgbClr val="FF0000"/>
+                </a:solidFill>
+                <a:latin typeface="Avenir Book" pitchFamily="34" charset="0"/>
+                <a:ea typeface="Avenir Book" pitchFamily="34" charset="-122"/>
+                <a:cs typeface="Avenir Book" pitchFamily="34" charset="-120"/>
+              </a:rPr>
+              <a:t>4. Discussion</a:t>
+            </a:r>
+            <a:endParaRPr lang="en-US" sz="2400" dirty="0"/>
+          </a:p>
+        </p:txBody>
+      </p:sp>
+    </p:spTree>
+  </p:cSld>
+  <p:clrMapOvr>
+    <a:masterClrMapping/>
+  </p:clrMapOvr>
+</p:sld>
+</file>
+
+<file path=ppt/slides/slide19.xml><?xml version="1.0" encoding="utf-8"?>
+<p:sld xmlns:a="http://schemas.openxmlformats.org/drawingml/2006/main" xmlns:r="http://schemas.openxmlformats.org/officeDocument/2006/relationships" xmlns:p="http://schemas.openxmlformats.org/presentationml/2006/main">
+  <p:cSld name="Slide 19">
+    <p:bg>
+      <p:bgPr>
+        <a:solidFill>
+          <a:srgbClr val="FFFFFF"/>
+        </a:solidFill>
+      </p:bgPr>
+    </p:bg>
+    <p:spTree>
+      <p:nvGrpSpPr>
+        <p:cNvPr id="1" name=""/>
+        <p:cNvGrpSpPr/>
+        <p:nvPr/>
+      </p:nvGrpSpPr>
+      <p:grpSpPr>
+        <a:xfrm>
+          <a:off x="0" y="0"/>
+          <a:ext cx="0" cy="0"/>
+          <a:chOff x="0" y="0"/>
+          <a:chExt cx="0" cy="0"/>
+        </a:xfrm>
+      </p:grpSpPr>
+      <p:sp>
+        <p:nvSpPr>
+          <p:cNvPr id="3" name="Text 0"/>
+          <p:cNvSpPr txBox="1"/>
+          <p:nvPr/>
+        </p:nvSpPr>
+        <p:spPr>
+          <a:xfrm>
+            <a:off x="548640" y="411480"/>
+            <a:ext cx="8046720" cy="640080"/>
+          </a:xfrm>
+          <a:prstGeom prst="rect">
+            <a:avLst/>
+          </a:prstGeom>
+          <a:noFill/>
+          <a:ln/>
+        </p:spPr>
+        <p:txBody>
+          <a:bodyPr wrap="square" lIns="0" tIns="0" rIns="0" bIns="0" rtlCol="0" anchor="ctr"/>
+          <a:lstStyle/>
+          <a:p>
+            <a:pPr indent="0" marL="0">
+              <a:buNone/>
+            </a:pPr>
+            <a:r>
+              <a:rPr lang="en-US" sz="2800" dirty="0">
+                <a:solidFill>
+                  <a:srgbClr val="000000"/>
+                </a:solidFill>
+                <a:latin typeface="Avenir Book" pitchFamily="34" charset="0"/>
+                <a:ea typeface="Avenir Book" pitchFamily="34" charset="-122"/>
+                <a:cs typeface="Avenir Book" pitchFamily="34" charset="-120"/>
+              </a:rPr>
+              <a:t>What this means</a:t>
+            </a:r>
+            <a:endParaRPr lang="en-US" sz="2800" dirty="0"/>
+          </a:p>
+        </p:txBody>
+      </p:sp>
+      <p:sp>
+        <p:nvSpPr>
+          <p:cNvPr id="4" name="Text 1"/>
+          <p:cNvSpPr txBox="1"/>
+          <p:nvPr/>
+        </p:nvSpPr>
+        <p:spPr>
+          <a:xfrm>
+            <a:off x="548640" y="1371600"/>
+            <a:ext cx="8046720" cy="3291840"/>
+          </a:xfrm>
+          <a:prstGeom prst="rect">
+            <a:avLst/>
+          </a:prstGeom>
+          <a:noFill/>
+          <a:ln/>
+        </p:spPr>
+        <p:txBody>
+          <a:bodyPr wrap="square" lIns="0" tIns="0" rIns="0" bIns="0" rtlCol="0" anchor="t"/>
+          <a:lstStyle/>
+          <a:p>
+            <a:pPr indent="0" marL="0">
+              <a:spcAft>
+                <a:spcPts val="1400"/>
+              </a:spcAft>
+              <a:buNone/>
+            </a:pPr>
+            <a:r>
+              <a:rPr lang="en-US" sz="2000" dirty="0">
+                <a:solidFill>
+                  <a:srgbClr val="000000"/>
+                </a:solidFill>
+                <a:latin typeface="Avenir Book" pitchFamily="34" charset="0"/>
+                <a:ea typeface="Avenir Book" pitchFamily="34" charset="-122"/>
+                <a:cs typeface="Avenir Book" pitchFamily="34" charset="-120"/>
+              </a:rPr>
+              <a:t>Not sensitization: gradients flatten, not steepen, with exposure</a:t>
+            </a:r>
+            <a:endParaRPr lang="en-US" sz="2000" dirty="0"/>
+          </a:p>
+          <a:p>
+            <a:pPr indent="0" marL="0">
+              <a:spcAft>
+                <a:spcPts val="1400"/>
+              </a:spcAft>
+              <a:buNone/>
+            </a:pPr>
+            <a:r>
+              <a:rPr lang="en-US" sz="2000" dirty="0">
+                <a:solidFill>
+                  <a:srgbClr val="000000"/>
+                </a:solidFill>
+                <a:latin typeface="Avenir Book" pitchFamily="34" charset="0"/>
+                <a:ea typeface="Avenir Book" pitchFamily="34" charset="-122"/>
+                <a:cs typeface="Avenir Book" pitchFamily="34" charset="-120"/>
+              </a:rPr>
+              <a:t>Universal stress-reduction targets people whose symptoms no longer track stress</a:t>
+            </a:r>
+            <a:endParaRPr lang="en-US" sz="2000" dirty="0"/>
+          </a:p>
+          <a:p>
+            <a:pPr indent="0" marL="0">
+              <a:spcAft>
+                <a:spcPts val="1400"/>
+              </a:spcAft>
+              <a:buNone/>
+            </a:pPr>
+            <a:r>
+              <a:rPr lang="en-US" sz="2000" dirty="0">
+                <a:solidFill>
+                  <a:srgbClr val="000000"/>
+                </a:solidFill>
+                <a:latin typeface="Avenir Book" pitchFamily="34" charset="0"/>
+                <a:ea typeface="Avenir Book" pitchFamily="34" charset="-122"/>
+                <a:cs typeface="Avenir Book" pitchFamily="34" charset="-120"/>
+              </a:rPr>
+              <a:t>Stress-focused and livelihood support where sensitivity is retained</a:t>
+            </a:r>
+            <a:endParaRPr lang="en-US" sz="2000" dirty="0"/>
+          </a:p>
+          <a:p>
+            <a:pPr indent="0" marL="0">
+              <a:spcAft>
+                <a:spcPts val="1400"/>
+              </a:spcAft>
+              <a:buNone/>
+            </a:pPr>
+            <a:r>
+              <a:rPr lang="en-US" sz="2000" dirty="0">
+                <a:solidFill>
+                  <a:srgbClr val="000000"/>
+                </a:solidFill>
+                <a:latin typeface="Avenir Book" pitchFamily="34" charset="0"/>
+                <a:ea typeface="Avenir Book" pitchFamily="34" charset="-122"/>
+                <a:cs typeface="Avenir Book" pitchFamily="34" charset="-120"/>
+              </a:rPr>
+              <a:t>Trauma-focused therapies where exposure is extensive</a:t>
+            </a:r>
+            <a:endParaRPr lang="en-US" sz="2000" dirty="0"/>
           </a:p>
         </p:txBody>
       </p:sp>
@@ -5388,6 +6134,250 @@
 </p:sld>
 </file>
 
+<file path=ppt/slides/slide20.xml><?xml version="1.0" encoding="utf-8"?>
+<p:sld xmlns:a="http://schemas.openxmlformats.org/drawingml/2006/main" xmlns:r="http://schemas.openxmlformats.org/officeDocument/2006/relationships" xmlns:p="http://schemas.openxmlformats.org/presentationml/2006/main">
+  <p:cSld name="Slide 20">
+    <p:bg>
+      <p:bgPr>
+        <a:solidFill>
+          <a:srgbClr val="FFFFFF"/>
+        </a:solidFill>
+      </p:bgPr>
+    </p:bg>
+    <p:spTree>
+      <p:nvGrpSpPr>
+        <p:cNvPr id="1" name=""/>
+        <p:cNvGrpSpPr/>
+        <p:nvPr/>
+      </p:nvGrpSpPr>
+      <p:grpSpPr>
+        <a:xfrm>
+          <a:off x="0" y="0"/>
+          <a:ext cx="0" cy="0"/>
+          <a:chOff x="0" y="0"/>
+          <a:chExt cx="0" cy="0"/>
+        </a:xfrm>
+      </p:grpSpPr>
+      <p:sp>
+        <p:nvSpPr>
+          <p:cNvPr id="3" name="Text 0"/>
+          <p:cNvSpPr txBox="1"/>
+          <p:nvPr/>
+        </p:nvSpPr>
+        <p:spPr>
+          <a:xfrm>
+            <a:off x="548640" y="411480"/>
+            <a:ext cx="8046720" cy="640080"/>
+          </a:xfrm>
+          <a:prstGeom prst="rect">
+            <a:avLst/>
+          </a:prstGeom>
+          <a:noFill/>
+          <a:ln/>
+        </p:spPr>
+        <p:txBody>
+          <a:bodyPr wrap="square" lIns="0" tIns="0" rIns="0" bIns="0" rtlCol="0" anchor="ctr"/>
+          <a:lstStyle/>
+          <a:p>
+            <a:pPr indent="0" marL="0">
+              <a:buNone/>
+            </a:pPr>
+            <a:r>
+              <a:rPr lang="en-US" sz="2800" dirty="0">
+                <a:solidFill>
+                  <a:srgbClr val="000000"/>
+                </a:solidFill>
+                <a:latin typeface="Avenir Book" pitchFamily="34" charset="0"/>
+                <a:ea typeface="Avenir Book" pitchFamily="34" charset="-122"/>
+                <a:cs typeface="Avenir Book" pitchFamily="34" charset="-120"/>
+              </a:rPr>
+              <a:t>Limits</a:t>
+            </a:r>
+            <a:endParaRPr lang="en-US" sz="2800" dirty="0"/>
+          </a:p>
+        </p:txBody>
+      </p:sp>
+      <p:sp>
+        <p:nvSpPr>
+          <p:cNvPr id="4" name="Text 1"/>
+          <p:cNvSpPr txBox="1"/>
+          <p:nvPr/>
+        </p:nvSpPr>
+        <p:spPr>
+          <a:xfrm>
+            <a:off x="548640" y="1371600"/>
+            <a:ext cx="8046720" cy="3291840"/>
+          </a:xfrm>
+          <a:prstGeom prst="rect">
+            <a:avLst/>
+          </a:prstGeom>
+          <a:noFill/>
+          <a:ln/>
+        </p:spPr>
+        <p:txBody>
+          <a:bodyPr wrap="square" lIns="0" tIns="0" rIns="0" bIns="0" rtlCol="0" anchor="t"/>
+          <a:lstStyle/>
+          <a:p>
+            <a:pPr indent="0" marL="0">
+              <a:spcAft>
+                <a:spcPts val="1400"/>
+              </a:spcAft>
+              <a:buNone/>
+            </a:pPr>
+            <a:r>
+              <a:rPr lang="en-US" sz="2000" dirty="0">
+                <a:solidFill>
+                  <a:srgbClr val="000000"/>
+                </a:solidFill>
+                <a:latin typeface="Avenir Book" pitchFamily="34" charset="0"/>
+                <a:ea typeface="Avenir Book" pitchFamily="34" charset="-122"/>
+                <a:cs typeface="Avenir Book" pitchFamily="34" charset="-120"/>
+              </a:rPr>
+              <a:t>Cross-sectional: a pattern of association, not a mechanism</a:t>
+            </a:r>
+            <a:endParaRPr lang="en-US" sz="2000" dirty="0"/>
+          </a:p>
+          <a:p>
+            <a:pPr indent="0" marL="0">
+              <a:spcAft>
+                <a:spcPts val="1400"/>
+              </a:spcAft>
+              <a:buNone/>
+            </a:pPr>
+            <a:r>
+              <a:rPr lang="en-US" sz="2000" dirty="0">
+                <a:solidFill>
+                  <a:srgbClr val="000000"/>
+                </a:solidFill>
+                <a:latin typeface="Avenir Book" pitchFamily="34" charset="0"/>
+                <a:ea typeface="Avenir Book" pitchFamily="34" charset="-122"/>
+                <a:cs typeface="Avenir Book" pitchFamily="34" charset="-120"/>
+              </a:rPr>
+              <a:t>Lifetime event recall against current stressors</a:t>
+            </a:r>
+            <a:endParaRPr lang="en-US" sz="2000" dirty="0"/>
+          </a:p>
+          <a:p>
+            <a:pPr indent="0" marL="0">
+              <a:spcAft>
+                <a:spcPts val="1400"/>
+              </a:spcAft>
+              <a:buNone/>
+            </a:pPr>
+            <a:r>
+              <a:rPr lang="en-US" sz="2000" dirty="0">
+                <a:solidFill>
+                  <a:srgbClr val="000000"/>
+                </a:solidFill>
+                <a:latin typeface="Avenir Book" pitchFamily="34" charset="0"/>
+                <a:ea typeface="Avenir Book" pitchFamily="34" charset="-122"/>
+                <a:cs typeface="Avenir Book" pitchFamily="34" charset="-120"/>
+              </a:rPr>
+              <a:t>Sparse data above six events</a:t>
+            </a:r>
+            <a:endParaRPr lang="en-US" sz="2000" dirty="0"/>
+          </a:p>
+          <a:p>
+            <a:pPr indent="0" marL="0">
+              <a:spcAft>
+                <a:spcPts val="200"/>
+              </a:spcAft>
+              <a:buNone/>
+            </a:pPr>
+            <a:r>
+              <a:rPr lang="en-US" sz="2000" dirty="0">
+                <a:solidFill>
+                  <a:srgbClr val="000000"/>
+                </a:solidFill>
+                <a:latin typeface="Avenir Book" pitchFamily="34" charset="0"/>
+                <a:ea typeface="Avenir Book" pitchFamily="34" charset="-122"/>
+                <a:cs typeface="Avenir Book" pitchFamily="34" charset="-120"/>
+              </a:rPr>
+              <a:t>Prevalence, not incidence — the longitudinal test is next</a:t>
+            </a:r>
+            <a:endParaRPr lang="en-US" sz="2000" dirty="0"/>
+          </a:p>
+        </p:txBody>
+      </p:sp>
+    </p:spTree>
+  </p:cSld>
+  <p:clrMapOvr>
+    <a:masterClrMapping/>
+  </p:clrMapOvr>
+</p:sld>
+</file>
+
+<file path=ppt/slides/slide21.xml><?xml version="1.0" encoding="utf-8"?>
+<p:sld xmlns:a="http://schemas.openxmlformats.org/drawingml/2006/main" xmlns:r="http://schemas.openxmlformats.org/officeDocument/2006/relationships" xmlns:p="http://schemas.openxmlformats.org/presentationml/2006/main">
+  <p:cSld name="Slide 21">
+    <p:bg>
+      <p:bgPr>
+        <a:solidFill>
+          <a:srgbClr val="FFFFFF"/>
+        </a:solidFill>
+      </p:bgPr>
+    </p:bg>
+    <p:spTree>
+      <p:nvGrpSpPr>
+        <p:cNvPr id="1" name=""/>
+        <p:cNvGrpSpPr/>
+        <p:nvPr/>
+      </p:nvGrpSpPr>
+      <p:grpSpPr>
+        <a:xfrm>
+          <a:off x="0" y="0"/>
+          <a:ext cx="0" cy="0"/>
+          <a:chOff x="0" y="0"/>
+          <a:chExt cx="0" cy="0"/>
+        </a:xfrm>
+      </p:grpSpPr>
+      <p:sp>
+        <p:nvSpPr>
+          <p:cNvPr id="3" name="Text 0"/>
+          <p:cNvSpPr txBox="1"/>
+          <p:nvPr/>
+        </p:nvSpPr>
+        <p:spPr>
+          <a:xfrm>
+            <a:off x="731520" y="2286000"/>
+            <a:ext cx="7680960" cy="548640"/>
+          </a:xfrm>
+          <a:prstGeom prst="rect">
+            <a:avLst/>
+          </a:prstGeom>
+          <a:noFill/>
+          <a:ln/>
+        </p:spPr>
+        <p:txBody>
+          <a:bodyPr wrap="square" lIns="0" tIns="0" rIns="0" bIns="0" rtlCol="0" anchor="ctr"/>
+          <a:lstStyle/>
+          <a:p>
+            <a:pPr algn="ctr" indent="0" marL="0">
+              <a:buNone/>
+            </a:pPr>
+            <a:r>
+              <a:rPr lang="en-US" sz="2200" dirty="0">
+                <a:solidFill>
+                  <a:srgbClr val="000000"/>
+                </a:solidFill>
+                <a:latin typeface="Avenir Book" pitchFamily="34" charset="0"/>
+                <a:ea typeface="Avenir Book" pitchFamily="34" charset="-122"/>
+                <a:cs typeface="Avenir Book" pitchFamily="34" charset="-120"/>
+              </a:rPr>
+              <a:t>[your preferred email]</a:t>
+            </a:r>
+            <a:endParaRPr lang="en-US" sz="2200" dirty="0"/>
+          </a:p>
+        </p:txBody>
+      </p:sp>
+    </p:spTree>
+  </p:cSld>
+  <p:clrMapOvr>
+    <a:masterClrMapping/>
+  </p:clrMapOvr>
+</p:sld>
+</file>
+
 <file path=ppt/slides/slide3.xml><?xml version="1.0" encoding="utf-8"?>
 <p:sld xmlns:a="http://schemas.openxmlformats.org/drawingml/2006/main" xmlns:r="http://schemas.openxmlformats.org/officeDocument/2006/relationships" xmlns:p="http://schemas.openxmlformats.org/presentationml/2006/main">
   <p:cSld name="Slide 3">
@@ -5579,7 +6569,7 @@
                 <a:ea typeface="Avenir Book" pitchFamily="34" charset="-122"/>
                 <a:cs typeface="Avenir Book" pitchFamily="34" charset="-120"/>
               </a:rPr>
-              <a:t>Two views of trauma and daily stress</a:t>
+              <a:t>Two burdens, one population</a:t>
             </a:r>
             <a:endParaRPr lang="en-US" sz="2800" dirty="0"/>
           </a:p>
@@ -5621,7 +6611,7 @@
                 <a:ea typeface="Avenir Book" pitchFamily="34" charset="-122"/>
                 <a:cs typeface="Avenir Book" pitchFamily="34" charset="-120"/>
               </a:rPr>
-              <a:t>Additive: each stressor adds the same risk to everyone</a:t>
+              <a:t>Conflict-affected Nigerians carry traumatic exposure and daily socioeconomic adversity together</a:t>
             </a:r>
             <a:endParaRPr lang="en-US" sz="2000" dirty="0"/>
           </a:p>
@@ -5641,7 +6631,7 @@
                 <a:ea typeface="Avenir Book" pitchFamily="34" charset="-122"/>
                 <a:cs typeface="Avenir Book" pitchFamily="34" charset="-120"/>
               </a:rPr>
-              <a:t>Effect modification: trauma changes stress sensitivity itself</a:t>
+              <a:t>Programming typically treats the two as additive: every stressor removed helps everyone equally</a:t>
             </a:r>
             <a:endParaRPr lang="en-US" sz="2000" dirty="0"/>
           </a:p>
@@ -5661,27 +6651,7 @@
                 <a:ea typeface="Avenir Book" pitchFamily="34" charset="-122"/>
                 <a:cs typeface="Avenir Book" pitchFamily="34" charset="-120"/>
               </a:rPr>
-              <a:t>Conflict settings make these predictions diverge</a:t>
-            </a:r>
-            <a:endParaRPr lang="en-US" sz="2000" dirty="0"/>
-          </a:p>
-          <a:p>
-            <a:pPr indent="0" marL="0">
-              <a:spcAft>
-                <a:spcPts val="1400"/>
-              </a:spcAft>
-              <a:buNone/>
-            </a:pPr>
-            <a:r>
-              <a:rPr lang="en-US" sz="2000" dirty="0">
-                <a:solidFill>
-                  <a:srgbClr val="000000"/>
-                </a:solidFill>
-                <a:latin typeface="Avenir Book" pitchFamily="34" charset="0"/>
-                <a:ea typeface="Avenir Book" pitchFamily="34" charset="-122"/>
-                <a:cs typeface="Avenir Book" pitchFamily="34" charset="-120"/>
-              </a:rPr>
-              <a:t>Nigeria: ~1 in 5 adults with probable PTSD in conflict-affected states</a:t>
+              <a:t>If trauma modifies stress sensitivity, that assumption fails for a large share of the population</a:t>
             </a:r>
             <a:endParaRPr lang="en-US" sz="2000" dirty="0"/>
           </a:p>
@@ -5727,8 +6697,8 @@
         </p:nvSpPr>
         <p:spPr>
           <a:xfrm>
-            <a:off x="731520" y="2011680"/>
-            <a:ext cx="7680960" cy="1097280"/>
+            <a:off x="548640" y="411480"/>
+            <a:ext cx="8046720" cy="640080"/>
           </a:xfrm>
           <a:prstGeom prst="rect">
             <a:avLst/>
@@ -5740,11 +6710,11 @@
           <a:bodyPr wrap="square" lIns="0" tIns="0" rIns="0" bIns="0" rtlCol="0" anchor="ctr"/>
           <a:lstStyle/>
           <a:p>
-            <a:pPr algn="ctr" indent="0" marL="0">
-              <a:buNone/>
-            </a:pPr>
-            <a:r>
-              <a:rPr lang="en-US" sz="3000" dirty="0">
+            <a:pPr indent="0" marL="0">
+              <a:buNone/>
+            </a:pPr>
+            <a:r>
+              <a:rPr lang="en-US" sz="2800" dirty="0">
                 <a:solidFill>
                   <a:srgbClr val="000000"/>
                 </a:solidFill>
@@ -5752,9 +6722,111 @@
                 <a:ea typeface="Avenir Book" pitchFamily="34" charset="-122"/>
                 <a:cs typeface="Avenir Book" pitchFamily="34" charset="-120"/>
               </a:rPr>
-              <a:t>Does trauma change what stress does?</a:t>
-            </a:r>
-            <a:endParaRPr lang="en-US" sz="3000" dirty="0"/>
+              <a:t>Three predictions in the literature</a:t>
+            </a:r>
+            <a:endParaRPr lang="en-US" sz="2800" dirty="0"/>
+          </a:p>
+        </p:txBody>
+      </p:sp>
+      <p:sp>
+        <p:nvSpPr>
+          <p:cNvPr id="4" name="Text 1"/>
+          <p:cNvSpPr txBox="1"/>
+          <p:nvPr/>
+        </p:nvSpPr>
+        <p:spPr>
+          <a:xfrm>
+            <a:off x="548640" y="1371600"/>
+            <a:ext cx="8046720" cy="3291840"/>
+          </a:xfrm>
+          <a:prstGeom prst="rect">
+            <a:avLst/>
+          </a:prstGeom>
+          <a:noFill/>
+          <a:ln/>
+        </p:spPr>
+        <p:txBody>
+          <a:bodyPr wrap="square" lIns="0" tIns="0" rIns="0" bIns="0" rtlCol="0" anchor="t"/>
+          <a:lstStyle/>
+          <a:p>
+            <a:pPr indent="0" marL="0">
+              <a:spcAft>
+                <a:spcPts val="1400"/>
+              </a:spcAft>
+              <a:buNone/>
+            </a:pPr>
+            <a:r>
+              <a:rPr lang="en-US" sz="2000" dirty="0">
+                <a:solidFill>
+                  <a:srgbClr val="000000"/>
+                </a:solidFill>
+                <a:latin typeface="Avenir Book" pitchFamily="34" charset="0"/>
+                <a:ea typeface="Avenir Book" pitchFamily="34" charset="-122"/>
+                <a:cs typeface="Avenir Book" pitchFamily="34" charset="-120"/>
+              </a:rPr>
+              <a:t>Stress sensitization: prior trauma amplifies reactivity, steepest gradients among the exposed</a:t>
+            </a:r>
+            <a:endParaRPr lang="en-US" sz="2000" dirty="0"/>
+          </a:p>
+          <a:p>
+            <a:pPr indent="0" marL="0">
+              <a:spcAft>
+                <a:spcPts val="1400"/>
+              </a:spcAft>
+              <a:buNone/>
+            </a:pPr>
+            <a:r>
+              <a:rPr lang="en-US" sz="2000" dirty="0">
+                <a:solidFill>
+                  <a:srgbClr val="000000"/>
+                </a:solidFill>
+                <a:latin typeface="Avenir Book" pitchFamily="34" charset="0"/>
+                <a:ea typeface="Avenir Book" pitchFamily="34" charset="-122"/>
+                <a:cs typeface="Avenir Book" pitchFamily="34" charset="-120"/>
+              </a:rPr>
+              <a:t>Stress inoculation: moderate exposure protects against later stress</a:t>
+            </a:r>
+            <a:endParaRPr lang="en-US" sz="2000" dirty="0"/>
+          </a:p>
+          <a:p>
+            <a:pPr indent="0" marL="0">
+              <a:spcAft>
+                <a:spcPts val="1400"/>
+              </a:spcAft>
+              <a:buNone/>
+            </a:pPr>
+            <a:r>
+              <a:rPr lang="en-US" sz="2000" dirty="0">
+                <a:solidFill>
+                  <a:srgbClr val="000000"/>
+                </a:solidFill>
+                <a:latin typeface="Avenir Book" pitchFamily="34" charset="0"/>
+                <a:ea typeface="Avenir Book" pitchFamily="34" charset="-122"/>
+                <a:cs typeface="Avenir Book" pitchFamily="34" charset="-120"/>
+              </a:rPr>
+              <a:t>Daily-stressors model: adversity mediates conflict's effect; silent on modification</a:t>
+            </a:r>
+            <a:endParaRPr lang="en-US" sz="2000" dirty="0"/>
+          </a:p>
+          <a:p>
+            <a:pPr indent="0" marL="0">
+              <a:spcAft>
+                <a:spcPts val="200"/>
+              </a:spcAft>
+              <a:buNone/>
+            </a:pPr>
+            <a:r>
+              <a:rPr lang="en-US" sz="2000" dirty="0">
+                <a:solidFill>
+                  <a:srgbClr val="000000"/>
+                </a:solidFill>
+                <a:latin typeface="Avenir Book" pitchFamily="34" charset="0"/>
+                <a:ea typeface="Avenir Book" pitchFamily="34" charset="-122"/>
+                <a:cs typeface="Avenir Book" pitchFamily="34" charset="-120"/>
+              </a:rPr>
+              <a:t>Nearly all evidence: high-income samples, narrow exposure ranges</a:t>
+            </a:r>
+            <a:endParaRPr lang="en-US" sz="2000" dirty="0"/>
           </a:p>
         </p:txBody>
       </p:sp>
@@ -5798,8 +6870,8 @@
         </p:nvSpPr>
         <p:spPr>
           <a:xfrm>
-            <a:off x="3108960" y="1463040"/>
-            <a:ext cx="3657600" cy="2377440"/>
+            <a:off x="731520" y="2011680"/>
+            <a:ext cx="7680960" cy="1097280"/>
           </a:xfrm>
           <a:prstGeom prst="rect">
             <a:avLst/>
@@ -5811,14 +6883,11 @@
           <a:bodyPr wrap="square" lIns="0" tIns="0" rIns="0" bIns="0" rtlCol="0" anchor="ctr"/>
           <a:lstStyle/>
           <a:p>
-            <a:pPr indent="0" marL="0">
-              <a:spcAft>
-                <a:spcPts val="1800"/>
-              </a:spcAft>
-              <a:buNone/>
-            </a:pPr>
-            <a:r>
-              <a:rPr lang="en-US" sz="2400" dirty="0">
+            <a:pPr algn="ctr" indent="0" marL="0">
+              <a:buNone/>
+            </a:pPr>
+            <a:r>
+              <a:rPr lang="en-US" sz="3000" dirty="0">
                 <a:solidFill>
                   <a:srgbClr val="000000"/>
                 </a:solidFill>
@@ -5826,69 +6895,9 @@
                 <a:ea typeface="Avenir Book" pitchFamily="34" charset="-122"/>
                 <a:cs typeface="Avenir Book" pitchFamily="34" charset="-120"/>
               </a:rPr>
-              <a:t>1. Background</a:t>
-            </a:r>
-            <a:endParaRPr lang="en-US" sz="2400" dirty="0"/>
-          </a:p>
-          <a:p>
-            <a:pPr indent="0" marL="0">
-              <a:spcAft>
-                <a:spcPts val="1800"/>
-              </a:spcAft>
-              <a:buNone/>
-            </a:pPr>
-            <a:r>
-              <a:rPr lang="en-US" sz="2400" dirty="0">
-                <a:solidFill>
-                  <a:srgbClr val="FF0000"/>
-                </a:solidFill>
-                <a:latin typeface="Avenir Book" pitchFamily="34" charset="0"/>
-                <a:ea typeface="Avenir Book" pitchFamily="34" charset="-122"/>
-                <a:cs typeface="Avenir Book" pitchFamily="34" charset="-120"/>
-              </a:rPr>
-              <a:t>2. Methods</a:t>
-            </a:r>
-            <a:endParaRPr lang="en-US" sz="2400" dirty="0"/>
-          </a:p>
-          <a:p>
-            <a:pPr indent="0" marL="0">
-              <a:spcAft>
-                <a:spcPts val="1800"/>
-              </a:spcAft>
-              <a:buNone/>
-            </a:pPr>
-            <a:r>
-              <a:rPr lang="en-US" sz="2400" dirty="0">
-                <a:solidFill>
-                  <a:srgbClr val="000000"/>
-                </a:solidFill>
-                <a:latin typeface="Avenir Book" pitchFamily="34" charset="0"/>
-                <a:ea typeface="Avenir Book" pitchFamily="34" charset="-122"/>
-                <a:cs typeface="Avenir Book" pitchFamily="34" charset="-120"/>
-              </a:rPr>
-              <a:t>3. Results</a:t>
-            </a:r>
-            <a:endParaRPr lang="en-US" sz="2400" dirty="0"/>
-          </a:p>
-          <a:p>
-            <a:pPr indent="0" marL="0">
-              <a:spcAft>
-                <a:spcPts val="1800"/>
-              </a:spcAft>
-              <a:buNone/>
-            </a:pPr>
-            <a:r>
-              <a:rPr lang="en-US" sz="2400" dirty="0">
-                <a:solidFill>
-                  <a:srgbClr val="000000"/>
-                </a:solidFill>
-                <a:latin typeface="Avenir Book" pitchFamily="34" charset="0"/>
-                <a:ea typeface="Avenir Book" pitchFamily="34" charset="-122"/>
-                <a:cs typeface="Avenir Book" pitchFamily="34" charset="-120"/>
-              </a:rPr>
-              <a:t>4. Discussion</a:t>
-            </a:r>
-            <a:endParaRPr lang="en-US" sz="2400" dirty="0"/>
+              <a:t>Does trauma change what stress does?</a:t>
+            </a:r>
+            <a:endParaRPr lang="en-US" sz="3000" dirty="0"/>
           </a:p>
         </p:txBody>
       </p:sp>
@@ -5932,8 +6941,8 @@
         </p:nvSpPr>
         <p:spPr>
           <a:xfrm>
-            <a:off x="548640" y="411480"/>
-            <a:ext cx="8046720" cy="640080"/>
+            <a:off x="3108960" y="1463040"/>
+            <a:ext cx="3657600" cy="2377440"/>
           </a:xfrm>
           <a:prstGeom prst="rect">
             <a:avLst/>
@@ -5946,10 +6955,13 @@
           <a:lstStyle/>
           <a:p>
             <a:pPr indent="0" marL="0">
-              <a:buNone/>
-            </a:pPr>
-            <a:r>
-              <a:rPr lang="en-US" sz="2800" dirty="0">
+              <a:spcAft>
+                <a:spcPts val="1800"/>
+              </a:spcAft>
+              <a:buNone/>
+            </a:pPr>
+            <a:r>
+              <a:rPr lang="en-US" sz="2400" dirty="0">
                 <a:solidFill>
                   <a:srgbClr val="000000"/>
                 </a:solidFill>
@@ -5957,61 +6969,39 @@
                 <a:ea typeface="Avenir Book" pitchFamily="34" charset="-122"/>
                 <a:cs typeface="Avenir Book" pitchFamily="34" charset="-120"/>
               </a:rPr>
-              <a:t>Sample</a:t>
-            </a:r>
-            <a:endParaRPr lang="en-US" sz="2800" dirty="0"/>
-          </a:p>
-        </p:txBody>
-      </p:sp>
-      <p:sp>
-        <p:nvSpPr>
-          <p:cNvPr id="4" name="Text 1"/>
-          <p:cNvSpPr txBox="1"/>
-          <p:nvPr/>
-        </p:nvSpPr>
-        <p:spPr>
-          <a:xfrm>
-            <a:off x="548640" y="1371600"/>
-            <a:ext cx="8046720" cy="3291840"/>
-          </a:xfrm>
-          <a:prstGeom prst="rect">
-            <a:avLst/>
-          </a:prstGeom>
-          <a:noFill/>
-          <a:ln/>
-        </p:spPr>
-        <p:txBody>
-          <a:bodyPr wrap="square" lIns="0" tIns="0" rIns="0" bIns="0" rtlCol="0" anchor="t"/>
-          <a:lstStyle/>
+              <a:t>1. Background</a:t>
+            </a:r>
+            <a:endParaRPr lang="en-US" sz="2400" dirty="0"/>
+          </a:p>
           <a:p>
             <a:pPr indent="0" marL="0">
               <a:spcAft>
-                <a:spcPts val="1400"/>
+                <a:spcPts val="1800"/>
               </a:spcAft>
               <a:buNone/>
             </a:pPr>
             <a:r>
-              <a:rPr lang="en-US" sz="2000" dirty="0">
-                <a:solidFill>
-                  <a:srgbClr val="000000"/>
-                </a:solidFill>
-                <a:latin typeface="Avenir Book" pitchFamily="34" charset="0"/>
-                <a:ea typeface="Avenir Book" pitchFamily="34" charset="-122"/>
-                <a:cs typeface="Avenir Book" pitchFamily="34" charset="-120"/>
-              </a:rPr>
-              <a:t>1,729 adults, January–March 2024</a:t>
-            </a:r>
-            <a:endParaRPr lang="en-US" sz="2000" dirty="0"/>
+              <a:rPr lang="en-US" sz="2400" dirty="0">
+                <a:solidFill>
+                  <a:srgbClr val="FF0000"/>
+                </a:solidFill>
+                <a:latin typeface="Avenir Book" pitchFamily="34" charset="0"/>
+                <a:ea typeface="Avenir Book" pitchFamily="34" charset="-122"/>
+                <a:cs typeface="Avenir Book" pitchFamily="34" charset="-120"/>
+              </a:rPr>
+              <a:t>2. Methods</a:t>
+            </a:r>
+            <a:endParaRPr lang="en-US" sz="2400" dirty="0"/>
           </a:p>
           <a:p>
             <a:pPr indent="0" marL="0">
               <a:spcAft>
-                <a:spcPts val="1400"/>
+                <a:spcPts val="1800"/>
               </a:spcAft>
               <a:buNone/>
             </a:pPr>
             <a:r>
-              <a:rPr lang="en-US" sz="2000" dirty="0">
+              <a:rPr lang="en-US" sz="2400" dirty="0">
                 <a:solidFill>
                   <a:srgbClr val="000000"/>
                 </a:solidFill>
@@ -6019,19 +7009,19 @@
                 <a:ea typeface="Avenir Book" pitchFamily="34" charset="-122"/>
                 <a:cs typeface="Avenir Book" pitchFamily="34" charset="-120"/>
               </a:rPr>
-              <a:t>Five conflict-affected states + Ogun (non-conflict comparison)</a:t>
-            </a:r>
-            <a:endParaRPr lang="en-US" sz="2000" dirty="0"/>
+              <a:t>3. Results</a:t>
+            </a:r>
+            <a:endParaRPr lang="en-US" sz="2400" dirty="0"/>
           </a:p>
           <a:p>
             <a:pPr indent="0" marL="0">
               <a:spcAft>
-                <a:spcPts val="1400"/>
+                <a:spcPts val="1800"/>
               </a:spcAft>
               <a:buNone/>
             </a:pPr>
             <a:r>
-              <a:rPr lang="en-US" sz="2000" dirty="0">
+              <a:rPr lang="en-US" sz="2400" dirty="0">
                 <a:solidFill>
                   <a:srgbClr val="000000"/>
                 </a:solidFill>
@@ -6039,29 +7029,9 @@
                 <a:ea typeface="Avenir Book" pitchFamily="34" charset="-122"/>
                 <a:cs typeface="Avenir Book" pitchFamily="34" charset="-120"/>
               </a:rPr>
-              <a:t>Stratified multi-stage cluster design; 572 communities</a:t>
-            </a:r>
-            <a:endParaRPr lang="en-US" sz="2000" dirty="0"/>
-          </a:p>
-          <a:p>
-            <a:pPr indent="0" marL="0">
-              <a:spcAft>
-                <a:spcPts val="1400"/>
-              </a:spcAft>
-              <a:buNone/>
-            </a:pPr>
-            <a:r>
-              <a:rPr lang="en-US" sz="2000" dirty="0">
-                <a:solidFill>
-                  <a:srgbClr val="000000"/>
-                </a:solidFill>
-                <a:latin typeface="Avenir Book" pitchFamily="34" charset="0"/>
-                <a:ea typeface="Avenir Book" pitchFamily="34" charset="-122"/>
-                <a:cs typeface="Avenir Book" pitchFamily="34" charset="-120"/>
-              </a:rPr>
-              <a:t>Community and displacement-camp settings</a:t>
-            </a:r>
-            <a:endParaRPr lang="en-US" sz="2000" dirty="0"/>
+              <a:t>4. Discussion</a:t>
+            </a:r>
+            <a:endParaRPr lang="en-US" sz="2400" dirty="0"/>
           </a:p>
         </p:txBody>
       </p:sp>
@@ -6130,7 +7100,7 @@
                 <a:ea typeface="Avenir Book" pitchFamily="34" charset="-122"/>
                 <a:cs typeface="Avenir Book" pitchFamily="34" charset="-120"/>
               </a:rPr>
-              <a:t>Measures and model</a:t>
+              <a:t>Sample</a:t>
             </a:r>
             <a:endParaRPr lang="en-US" sz="2800" dirty="0"/>
           </a:p>
@@ -6164,7 +7134,7 @@
               <a:buNone/>
             </a:pPr>
             <a:r>
-              <a:rPr lang="en-US" sz="1800" dirty="0">
+              <a:rPr lang="en-US" sz="2000" dirty="0">
                 <a:solidFill>
                   <a:srgbClr val="000000"/>
                 </a:solidFill>
@@ -6172,9 +7142,9 @@
                 <a:ea typeface="Avenir Book" pitchFamily="34" charset="-122"/>
                 <a:cs typeface="Avenir Book" pitchFamily="34" charset="-120"/>
               </a:rPr>
-              <a:t>PCL-5 ≥ 38  ·  PHQ-9 ≥ 10  ·  GAD-7 ≥ 10 (locally validated)</a:t>
-            </a:r>
-            <a:endParaRPr lang="en-US" sz="1800" dirty="0"/>
+              <a:t>1,729 adults, January–March 2024 (of the 1,774 in the previous talk)</a:t>
+            </a:r>
+            <a:endParaRPr lang="en-US" sz="2000" dirty="0"/>
           </a:p>
           <a:p>
             <a:pPr indent="0" marL="0">
@@ -6184,7 +7154,7 @@
               <a:buNone/>
             </a:pPr>
             <a:r>
-              <a:rPr lang="en-US" sz="1800" dirty="0">
+              <a:rPr lang="en-US" sz="2000" dirty="0">
                 <a:solidFill>
                   <a:srgbClr val="000000"/>
                 </a:solidFill>
@@ -6192,9 +7162,9 @@
                 <a:ea typeface="Avenir Book" pitchFamily="34" charset="-122"/>
                 <a:cs typeface="Avenir Book" pitchFamily="34" charset="-120"/>
               </a:rPr>
-              <a:t>Trauma: 0–12 event types, restricted cubic spline</a:t>
-            </a:r>
-            <a:endParaRPr lang="en-US" sz="1800" dirty="0"/>
+              <a:t>Five conflict-affected states + Ogun (non-conflict comparison)</a:t>
+            </a:r>
+            <a:endParaRPr lang="en-US" sz="2000" dirty="0"/>
           </a:p>
           <a:p>
             <a:pPr indent="0" marL="0">
@@ -6204,7 +7174,7 @@
               <a:buNone/>
             </a:pPr>
             <a:r>
-              <a:rPr lang="en-US" sz="1800" dirty="0">
+              <a:rPr lang="en-US" sz="2000" dirty="0">
                 <a:solidFill>
                   <a:srgbClr val="000000"/>
                 </a:solidFill>
@@ -6212,9 +7182,9 @@
                 <a:ea typeface="Avenir Book" pitchFamily="34" charset="-122"/>
                 <a:cs typeface="Avenir Book" pitchFamily="34" charset="-120"/>
               </a:rPr>
-              <a:t>Stressors: socioeconomic challenge count (0–10)</a:t>
-            </a:r>
-            <a:endParaRPr lang="en-US" sz="1800" dirty="0"/>
+              <a:t>Stratified multi-stage cluster design; 565 communities</a:t>
+            </a:r>
+            <a:endParaRPr lang="en-US" sz="2000" dirty="0"/>
           </a:p>
           <a:p>
             <a:pPr indent="0" marL="0">
@@ -6224,7 +7194,7 @@
               <a:buNone/>
             </a:pPr>
             <a:r>
-              <a:rPr lang="en-US" sz="1800" dirty="0">
+              <a:rPr lang="en-US" sz="2000" dirty="0">
                 <a:solidFill>
                   <a:srgbClr val="000000"/>
                 </a:solidFill>
@@ -6232,29 +7202,9 @@
                 <a:ea typeface="Avenir Book" pitchFamily="34" charset="-122"/>
                 <a:cs typeface="Avenir Book" pitchFamily="34" charset="-120"/>
               </a:rPr>
-              <a:t>Poisson prevalence ratios; adjusted; design-based variances</a:t>
-            </a:r>
-            <a:endParaRPr lang="en-US" sz="1800" dirty="0"/>
-          </a:p>
-          <a:p>
-            <a:pPr indent="0" marL="0">
-              <a:spcAft>
-                <a:spcPts val="1400"/>
-              </a:spcAft>
-              <a:buNone/>
-            </a:pPr>
-            <a:r>
-              <a:rPr lang="en-US" sz="1800" dirty="0">
-                <a:solidFill>
-                  <a:srgbClr val="000000"/>
-                </a:solidFill>
-                <a:latin typeface="Avenir Book" pitchFamily="34" charset="0"/>
-                <a:ea typeface="Avenir Book" pitchFamily="34" charset="-122"/>
-                <a:cs typeface="Avenir Book" pitchFamily="34" charset="-120"/>
-              </a:rPr>
-              <a:t>Test: trauma × stressor interaction, both scales</a:t>
-            </a:r>
-            <a:endParaRPr lang="en-US" sz="1800" dirty="0"/>
+              <a:t>Community and displacement-camp settings</a:t>
+            </a:r>
+            <a:endParaRPr lang="en-US" sz="2000" dirty="0"/>
           </a:p>
         </p:txBody>
       </p:sp>
@@ -6298,8 +7248,8 @@
         </p:nvSpPr>
         <p:spPr>
           <a:xfrm>
-            <a:off x="3108960" y="1463040"/>
-            <a:ext cx="3657600" cy="2377440"/>
+            <a:off x="548640" y="411480"/>
+            <a:ext cx="8046720" cy="640080"/>
           </a:xfrm>
           <a:prstGeom prst="rect">
             <a:avLst/>
@@ -6312,13 +7262,10 @@
           <a:lstStyle/>
           <a:p>
             <a:pPr indent="0" marL="0">
-              <a:spcAft>
-                <a:spcPts val="1800"/>
-              </a:spcAft>
-              <a:buNone/>
-            </a:pPr>
-            <a:r>
-              <a:rPr lang="en-US" sz="2400" dirty="0">
+              <a:buNone/>
+            </a:pPr>
+            <a:r>
+              <a:rPr lang="en-US" sz="2800" dirty="0">
                 <a:solidFill>
                   <a:srgbClr val="000000"/>
                 </a:solidFill>
@@ -6326,19 +7273,41 @@
                 <a:ea typeface="Avenir Book" pitchFamily="34" charset="-122"/>
                 <a:cs typeface="Avenir Book" pitchFamily="34" charset="-120"/>
               </a:rPr>
-              <a:t>1. Background</a:t>
-            </a:r>
-            <a:endParaRPr lang="en-US" sz="2400" dirty="0"/>
-          </a:p>
+              <a:t>Measures</a:t>
+            </a:r>
+            <a:endParaRPr lang="en-US" sz="2800" dirty="0"/>
+          </a:p>
+        </p:txBody>
+      </p:sp>
+      <p:sp>
+        <p:nvSpPr>
+          <p:cNvPr id="4" name="Text 1"/>
+          <p:cNvSpPr txBox="1"/>
+          <p:nvPr/>
+        </p:nvSpPr>
+        <p:spPr>
+          <a:xfrm>
+            <a:off x="548640" y="1371600"/>
+            <a:ext cx="8046720" cy="3291840"/>
+          </a:xfrm>
+          <a:prstGeom prst="rect">
+            <a:avLst/>
+          </a:prstGeom>
+          <a:noFill/>
+          <a:ln/>
+        </p:spPr>
+        <p:txBody>
+          <a:bodyPr wrap="square" lIns="0" tIns="0" rIns="0" bIns="0" rtlCol="0" anchor="t"/>
+          <a:lstStyle/>
           <a:p>
             <a:pPr indent="0" marL="0">
               <a:spcAft>
-                <a:spcPts val="1800"/>
+                <a:spcPts val="1400"/>
               </a:spcAft>
               <a:buNone/>
             </a:pPr>
             <a:r>
-              <a:rPr lang="en-US" sz="2400" dirty="0">
+              <a:rPr lang="en-US" sz="2000" dirty="0">
                 <a:solidFill>
                   <a:srgbClr val="000000"/>
                 </a:solidFill>
@@ -6346,39 +7315,39 @@
                 <a:ea typeface="Avenir Book" pitchFamily="34" charset="-122"/>
                 <a:cs typeface="Avenir Book" pitchFamily="34" charset="-120"/>
               </a:rPr>
-              <a:t>2. Methods</a:t>
-            </a:r>
-            <a:endParaRPr lang="en-US" sz="2400" dirty="0"/>
+              <a:t>PCL-5 ≥ 38  ·  PHQ-9 ≥ 10  ·  GAD-7 ≥ 10 (validated in this population — paper 1)</a:t>
+            </a:r>
+            <a:endParaRPr lang="en-US" sz="2000" dirty="0"/>
           </a:p>
           <a:p>
             <a:pPr indent="0" marL="0">
               <a:spcAft>
-                <a:spcPts val="1800"/>
+                <a:spcPts val="1400"/>
               </a:spcAft>
               <a:buNone/>
             </a:pPr>
             <a:r>
-              <a:rPr lang="en-US" sz="2400" dirty="0">
-                <a:solidFill>
-                  <a:srgbClr val="FF0000"/>
-                </a:solidFill>
-                <a:latin typeface="Avenir Book" pitchFamily="34" charset="0"/>
-                <a:ea typeface="Avenir Book" pitchFamily="34" charset="-122"/>
-                <a:cs typeface="Avenir Book" pitchFamily="34" charset="-120"/>
-              </a:rPr>
-              <a:t>3. Results</a:t>
-            </a:r>
-            <a:endParaRPr lang="en-US" sz="2400" dirty="0"/>
+              <a:rPr lang="en-US" sz="2000" dirty="0">
+                <a:solidFill>
+                  <a:srgbClr val="000000"/>
+                </a:solidFill>
+                <a:latin typeface="Avenir Book" pitchFamily="34" charset="0"/>
+                <a:ea typeface="Avenir Book" pitchFamily="34" charset="-122"/>
+                <a:cs typeface="Avenir Book" pitchFamily="34" charset="-120"/>
+              </a:rPr>
+              <a:t>Trauma: count of 12 event types; refusals excluded, not zero</a:t>
+            </a:r>
+            <a:endParaRPr lang="en-US" sz="2000" dirty="0"/>
           </a:p>
           <a:p>
             <a:pPr indent="0" marL="0">
               <a:spcAft>
-                <a:spcPts val="1800"/>
+                <a:spcPts val="1400"/>
               </a:spcAft>
               <a:buNone/>
             </a:pPr>
             <a:r>
-              <a:rPr lang="en-US" sz="2400" dirty="0">
+              <a:rPr lang="en-US" sz="2000" dirty="0">
                 <a:solidFill>
                   <a:srgbClr val="000000"/>
                 </a:solidFill>
@@ -6386,9 +7355,9 @@
                 <a:ea typeface="Avenir Book" pitchFamily="34" charset="-122"/>
                 <a:cs typeface="Avenir Book" pitchFamily="34" charset="-120"/>
               </a:rPr>
-              <a:t>4. Discussion</a:t>
-            </a:r>
-            <a:endParaRPr lang="en-US" sz="2400" dirty="0"/>
+              <a:t>Stressors: socioeconomic challenge count, 0–10</a:t>
+            </a:r>
+            <a:endParaRPr lang="en-US" sz="2000" dirty="0"/>
           </a:p>
         </p:txBody>
       </p:sp>

</xml_diff>

<commit_message>
Rebuild Sandro-style deck with corrected dates
Co-Authored-By: Claude Fable 5 <noreply@anthropic.com>
Claude-Session: https://claude.ai/code/session_019BJ4u1WYcsA14q2B552n7R
</commit_message>
<xml_diff>
--- a/projects/marvin-stress-trauma/istss_trauma_saturation.pptx
+++ b/projects/marvin-stress-trauma/istss_trauma_saturation.pptx
@@ -2881,7 +2881,7 @@
           <a:p>
             <a:r>
               <a:rPr lang="en-US" dirty="0"/>
-              <a:t>The MaRVIN sample Salma presented: 1,774 adults surveyed January to March 2024; 1,729 answered the trauma inventory and enter this analysis. Six states: five conflict-affected — Benue, Borno, Enugu, Rivers, Sokoto — plus Ogun as a non-conflict comparison, which anchors the low end of the trauma gradient. Stratified multi-stage cluster design, 565 community clusters, community and IDP-camp settings. All analyses honor the design: state strata, community clusters, linearized variances.</a:t>
+              <a:t>The MaRVIN sample Salma presented: 1,774 adults surveyed May to October 2025; 1,729 answered the trauma inventory and enter this analysis. Six states: five conflict-affected — Benue, Borno, Enugu, Rivers, Sokoto — plus Ogun as a non-conflict comparison, which anchors the low end of the trauma gradient. Stratified multi-stage cluster design, 565 community clusters, community and IDP-camp settings. All analyses honor the design: state strata, community clusters, linearized variances.</a:t>
             </a:r>
             <a:endParaRPr lang="en-US" dirty="0"/>
           </a:p>
@@ -7142,7 +7142,7 @@
                 <a:ea typeface="Avenir Book" pitchFamily="34" charset="-122"/>
                 <a:cs typeface="Avenir Book" pitchFamily="34" charset="-120"/>
               </a:rPr>
-              <a:t>1,729 adults, January–March 2024 (of the 1,774 in the previous talk)</a:t>
+              <a:t>1,729 adults, May–October 2025 (of the 1,774 in the previous talk)</a:t>
             </a:r>
             <a:endParaRPr lang="en-US" sz="2000" dirty="0"/>
           </a:p>

</xml_diff>